<commit_message>
Adjust slide master fonts and bullet points
</commit_message>
<xml_diff>
--- a/working-template.pptx
+++ b/working-template.pptx
@@ -211,7 +211,7 @@
           <a:p>
             <a:fld id="{0F9C1CCF-B725-44A7-AA57-5E433BD85C9F}" type="datetimeFigureOut">
               <a:rPr lang="en-US" smtClean="0"/>
-              <a:t>1/2/22</a:t>
+              <a:t>9/23/26</a:t>
             </a:fld>
             <a:endParaRPr lang="en-US"/>
           </a:p>
@@ -864,7 +864,7 @@
           <a:p>
             <a:fld id="{241EB5C9-1307-BA42-ABA2-0BC069CD8E7F}" type="datetimeFigureOut">
               <a:rPr lang="en-US" smtClean="0"/>
-              <a:t>1/2/22</a:t>
+              <a:t>9/23/26</a:t>
             </a:fld>
             <a:endParaRPr lang="en-US"/>
           </a:p>
@@ -922,6 +922,22 @@
   <p:clrMapOvr>
     <a:masterClrMapping/>
   </p:clrMapOvr>
+  <p:extLst>
+    <p:ext uri="{DCECCB84-F9BA-43D5-87BE-67443E8EF086}">
+      <p15:sldGuideLst xmlns:p15="http://schemas.microsoft.com/office/powerpoint/2012/main">
+        <p15:guide id="1" orient="horz" pos="1620" userDrawn="1">
+          <p15:clr>
+            <a:srgbClr val="FBAE40"/>
+          </p15:clr>
+        </p15:guide>
+        <p15:guide id="2" pos="2880" userDrawn="1">
+          <p15:clr>
+            <a:srgbClr val="FBAE40"/>
+          </p15:clr>
+        </p15:guide>
+      </p15:sldGuideLst>
+    </p:ext>
+  </p:extLst>
 </p:sldLayout>
 </file>
 
@@ -1032,7 +1048,7 @@
           <a:p>
             <a:fld id="{241EB5C9-1307-BA42-ABA2-0BC069CD8E7F}" type="datetimeFigureOut">
               <a:rPr lang="en-US" smtClean="0"/>
-              <a:t>1/2/22</a:t>
+              <a:t>9/23/26</a:t>
             </a:fld>
             <a:endParaRPr lang="en-US"/>
           </a:p>
@@ -1210,7 +1226,7 @@
           <a:p>
             <a:fld id="{241EB5C9-1307-BA42-ABA2-0BC069CD8E7F}" type="datetimeFigureOut">
               <a:rPr lang="en-US" smtClean="0"/>
-              <a:t>1/2/22</a:t>
+              <a:t>9/23/26</a:t>
             </a:fld>
             <a:endParaRPr lang="en-US"/>
           </a:p>
@@ -1378,7 +1394,7 @@
           <a:p>
             <a:fld id="{241EB5C9-1307-BA42-ABA2-0BC069CD8E7F}" type="datetimeFigureOut">
               <a:rPr lang="en-US" smtClean="0"/>
-              <a:t>1/2/22</a:t>
+              <a:t>9/23/26</a:t>
             </a:fld>
             <a:endParaRPr lang="en-US"/>
           </a:p>
@@ -1623,7 +1639,7 @@
           <a:p>
             <a:fld id="{241EB5C9-1307-BA42-ABA2-0BC069CD8E7F}" type="datetimeFigureOut">
               <a:rPr lang="en-US" smtClean="0"/>
-              <a:t>1/2/22</a:t>
+              <a:t>9/23/26</a:t>
             </a:fld>
             <a:endParaRPr lang="en-US"/>
           </a:p>
@@ -1908,7 +1924,7 @@
           <a:p>
             <a:fld id="{241EB5C9-1307-BA42-ABA2-0BC069CD8E7F}" type="datetimeFigureOut">
               <a:rPr lang="en-US" smtClean="0"/>
-              <a:t>1/2/22</a:t>
+              <a:t>9/23/26</a:t>
             </a:fld>
             <a:endParaRPr lang="en-US"/>
           </a:p>
@@ -2327,7 +2343,7 @@
           <a:p>
             <a:fld id="{241EB5C9-1307-BA42-ABA2-0BC069CD8E7F}" type="datetimeFigureOut">
               <a:rPr lang="en-US" smtClean="0"/>
-              <a:t>1/2/22</a:t>
+              <a:t>9/23/26</a:t>
             </a:fld>
             <a:endParaRPr lang="en-US"/>
           </a:p>
@@ -2444,7 +2460,7 @@
           <a:p>
             <a:fld id="{241EB5C9-1307-BA42-ABA2-0BC069CD8E7F}" type="datetimeFigureOut">
               <a:rPr lang="en-US" smtClean="0"/>
-              <a:t>1/2/22</a:t>
+              <a:t>9/23/26</a:t>
             </a:fld>
             <a:endParaRPr lang="en-US"/>
           </a:p>
@@ -2539,7 +2555,7 @@
           <a:p>
             <a:fld id="{241EB5C9-1307-BA42-ABA2-0BC069CD8E7F}" type="datetimeFigureOut">
               <a:rPr lang="en-US" smtClean="0"/>
-              <a:t>1/2/22</a:t>
+              <a:t>9/23/26</a:t>
             </a:fld>
             <a:endParaRPr lang="en-US"/>
           </a:p>
@@ -2814,7 +2830,7 @@
           <a:p>
             <a:fld id="{241EB5C9-1307-BA42-ABA2-0BC069CD8E7F}" type="datetimeFigureOut">
               <a:rPr lang="en-US" smtClean="0"/>
-              <a:t>1/2/22</a:t>
+              <a:t>9/23/26</a:t>
             </a:fld>
             <a:endParaRPr lang="en-US"/>
           </a:p>
@@ -3066,7 +3082,7 @@
           <a:p>
             <a:fld id="{241EB5C9-1307-BA42-ABA2-0BC069CD8E7F}" type="datetimeFigureOut">
               <a:rPr lang="en-US" smtClean="0"/>
-              <a:t>1/2/22</a:t>
+              <a:t>9/23/26</a:t>
             </a:fld>
             <a:endParaRPr lang="en-US"/>
           </a:p>
@@ -3169,13 +3185,13 @@
           </a:prstGeom>
         </p:spPr>
         <p:txBody>
-          <a:bodyPr vert="horz" lIns="91440" tIns="45720" rIns="91440" bIns="45720" rtlCol="0" anchor="ctr">
+          <a:bodyPr vert="horz" lIns="91440" tIns="45720" rIns="91440" bIns="45720" rtlCol="0" anchor="b">
             <a:normAutofit/>
           </a:bodyPr>
           <a:lstStyle/>
           <a:p>
             <a:r>
-              <a:rPr lang="en-US"/>
+              <a:rPr lang="en-US" dirty="0"/>
               <a:t>Click to edit Master title style</a:t>
             </a:r>
           </a:p>
@@ -3208,35 +3224,35 @@
           <a:p>
             <a:pPr lvl="0"/>
             <a:r>
-              <a:rPr lang="en-US"/>
+              <a:rPr lang="en-US" dirty="0"/>
               <a:t>Click to edit Master text styles</a:t>
             </a:r>
           </a:p>
           <a:p>
             <a:pPr lvl="1"/>
             <a:r>
-              <a:rPr lang="en-US"/>
+              <a:rPr lang="en-US" dirty="0"/>
               <a:t>Second level</a:t>
             </a:r>
           </a:p>
           <a:p>
             <a:pPr lvl="2"/>
             <a:r>
-              <a:rPr lang="en-US"/>
+              <a:rPr lang="en-US" dirty="0"/>
               <a:t>Third level</a:t>
             </a:r>
           </a:p>
           <a:p>
             <a:pPr lvl="3"/>
             <a:r>
-              <a:rPr lang="en-US"/>
+              <a:rPr lang="en-US" dirty="0"/>
               <a:t>Fourth level</a:t>
             </a:r>
           </a:p>
           <a:p>
             <a:pPr lvl="4"/>
             <a:r>
-              <a:rPr lang="en-US"/>
+              <a:rPr lang="en-US" dirty="0"/>
               <a:t>Fifth level</a:t>
             </a:r>
           </a:p>
@@ -3277,9 +3293,9 @@
           <a:p>
             <a:fld id="{241EB5C9-1307-BA42-ABA2-0BC069CD8E7F}" type="datetimeFigureOut">
               <a:rPr lang="en-US" smtClean="0"/>
-              <a:t>1/2/22</a:t>
+              <a:t>9/23/26</a:t>
             </a:fld>
-            <a:endParaRPr lang="en-US"/>
+            <a:endParaRPr lang="en-US" dirty="0"/>
           </a:p>
         </p:txBody>
       </p:sp>
@@ -3389,13 +3405,13 @@
           <a:spcPct val="0"/>
         </a:spcBef>
         <a:buNone/>
-        <a:defRPr sz="3300" kern="1200">
+        <a:defRPr sz="2800" kern="1200">
           <a:solidFill>
             <a:schemeClr val="tx1"/>
           </a:solidFill>
-          <a:latin typeface="+mj-lt"/>
-          <a:ea typeface="+mj-ea"/>
-          <a:cs typeface="+mj-cs"/>
+          <a:latin typeface="Verdana" panose="020B0604030504040204" pitchFamily="34" charset="0"/>
+          <a:ea typeface="Verdana" panose="020B0604030504040204" pitchFamily="34" charset="0"/>
+          <a:cs typeface="Verdana" panose="020B0604030504040204" pitchFamily="34" charset="0"/>
         </a:defRPr>
       </a:lvl1pPr>
     </p:titleStyle>
@@ -3404,75 +3420,82 @@
         <a:spcBef>
           <a:spcPct val="20000"/>
         </a:spcBef>
-        <a:buFont typeface="Arial"/>
+        <a:buFont typeface="Arial" panose="020B0604020202020204" pitchFamily="34" charset="0"/>
         <a:buChar char="•"/>
-        <a:defRPr sz="2400" kern="1200">
+        <a:defRPr sz="2000" b="0" i="0" kern="1200">
           <a:solidFill>
             <a:schemeClr val="tx1"/>
           </a:solidFill>
-          <a:latin typeface="+mn-lt"/>
-          <a:ea typeface="+mn-ea"/>
-          <a:cs typeface="+mn-cs"/>
+          <a:latin typeface="Verdana" panose="020B0604030504040204" pitchFamily="34" charset="0"/>
+          <a:ea typeface="Verdana" panose="020B0604030504040204" pitchFamily="34" charset="0"/>
+          <a:cs typeface="Verdana" panose="020B0604030504040204" pitchFamily="34" charset="0"/>
         </a:defRPr>
       </a:lvl1pPr>
-      <a:lvl2pPr marL="685800" indent="-342900" algn="l" defTabSz="342900" rtl="0" eaLnBrk="1" latinLnBrk="0" hangingPunct="1">
+      <a:lvl2pPr marL="576263" indent="-346075" algn="l" defTabSz="342900" rtl="0" eaLnBrk="1" latinLnBrk="0" hangingPunct="1">
+        <a:spcBef>
+          <a:spcPct val="20000"/>
+        </a:spcBef>
+        <a:buFont typeface="Wingdings" pitchFamily="2" charset="2"/>
+        <a:buChar char="§"/>
+        <a:tabLst/>
+        <a:defRPr sz="1800" b="0" i="0" kern="1200">
+          <a:solidFill>
+            <a:schemeClr val="tx1"/>
+          </a:solidFill>
+          <a:latin typeface="Verdana" panose="020B0604030504040204" pitchFamily="34" charset="0"/>
+          <a:ea typeface="Verdana" panose="020B0604030504040204" pitchFamily="34" charset="0"/>
+          <a:cs typeface="Verdana" panose="020B0604030504040204" pitchFamily="34" charset="0"/>
+        </a:defRPr>
+      </a:lvl2pPr>
+      <a:lvl3pPr marL="862013" indent="-339725" algn="l" defTabSz="342900" rtl="0" eaLnBrk="1" latinLnBrk="0" hangingPunct="1">
+        <a:spcBef>
+          <a:spcPct val="20000"/>
+        </a:spcBef>
+        <a:buFont typeface="Courier New" panose="02070309020205020404" pitchFamily="49" charset="0"/>
+        <a:buChar char="o"/>
+        <a:tabLst/>
+        <a:defRPr sz="1600" b="0" i="0" kern="1200">
+          <a:solidFill>
+            <a:schemeClr val="tx1"/>
+          </a:solidFill>
+          <a:latin typeface="Verdana" panose="020B0604030504040204" pitchFamily="34" charset="0"/>
+          <a:ea typeface="Verdana" panose="020B0604030504040204" pitchFamily="34" charset="0"/>
+          <a:cs typeface="Verdana" panose="020B0604030504040204" pitchFamily="34" charset="0"/>
+        </a:defRPr>
+      </a:lvl3pPr>
+      <a:lvl4pPr marL="1200150" indent="-346075" algn="l" defTabSz="342900" rtl="0" eaLnBrk="1" latinLnBrk="0" hangingPunct="1">
         <a:spcBef>
           <a:spcPct val="20000"/>
         </a:spcBef>
         <a:buFont typeface="Arial"/>
         <a:buChar char="–"/>
-        <a:defRPr sz="2100" kern="1200">
+        <a:tabLst/>
+        <a:defRPr sz="1400" b="0" i="0" kern="1200">
           <a:solidFill>
             <a:schemeClr val="tx1"/>
           </a:solidFill>
-          <a:latin typeface="+mn-lt"/>
-          <a:ea typeface="+mn-ea"/>
-          <a:cs typeface="+mn-cs"/>
-        </a:defRPr>
-      </a:lvl2pPr>
-      <a:lvl3pPr marL="1028700" indent="-342900" algn="l" defTabSz="342900" rtl="0" eaLnBrk="1" latinLnBrk="0" hangingPunct="1">
-        <a:spcBef>
-          <a:spcPct val="20000"/>
-        </a:spcBef>
-        <a:buFont typeface="Arial"/>
-        <a:buChar char="•"/>
-        <a:defRPr sz="1800" kern="1200">
-          <a:solidFill>
-            <a:schemeClr val="tx1"/>
-          </a:solidFill>
-          <a:latin typeface="+mn-lt"/>
-          <a:ea typeface="+mn-ea"/>
-          <a:cs typeface="+mn-cs"/>
-        </a:defRPr>
-      </a:lvl3pPr>
-      <a:lvl4pPr marL="1371600" indent="-342900" algn="l" defTabSz="342900" rtl="0" eaLnBrk="1" latinLnBrk="0" hangingPunct="1">
-        <a:spcBef>
-          <a:spcPct val="20000"/>
-        </a:spcBef>
-        <a:buFont typeface="Arial"/>
-        <a:buChar char="–"/>
-        <a:defRPr sz="1500" kern="1200">
-          <a:solidFill>
-            <a:schemeClr val="tx1"/>
-          </a:solidFill>
-          <a:latin typeface="+mn-lt"/>
-          <a:ea typeface="+mn-ea"/>
-          <a:cs typeface="+mn-cs"/>
+          <a:latin typeface="Verdana" panose="020B0604030504040204" pitchFamily="34" charset="0"/>
+          <a:ea typeface="Verdana" panose="020B0604030504040204" pitchFamily="34" charset="0"/>
+          <a:cs typeface="Verdana" panose="020B0604030504040204" pitchFamily="34" charset="0"/>
         </a:defRPr>
       </a:lvl4pPr>
-      <a:lvl5pPr marL="1714500" indent="-342900" algn="l" defTabSz="342900" rtl="0" eaLnBrk="1" latinLnBrk="0" hangingPunct="1">
+      <a:lvl5pPr marL="1492250" indent="-338138" algn="l" defTabSz="342900" rtl="0" eaLnBrk="1" latinLnBrk="0" hangingPunct="1">
         <a:spcBef>
           <a:spcPct val="20000"/>
         </a:spcBef>
         <a:buFont typeface="Arial"/>
         <a:buChar char="»"/>
-        <a:defRPr sz="1500" kern="1200">
+        <a:tabLst/>
+        <a:defRPr sz="1400" b="0" i="0" kern="1200">
           <a:solidFill>
-            <a:schemeClr val="tx1"/>
+            <a:schemeClr val="tx1">
+              <a:lumMod val="65000"/>
+              <a:lumOff val="35000"/>
+            </a:schemeClr>
           </a:solidFill>
-          <a:latin typeface="+mn-lt"/>
-          <a:ea typeface="+mn-ea"/>
-          <a:cs typeface="+mn-cs"/>
+          <a:latin typeface="Verdana" panose="020B0604030504040204" pitchFamily="34" charset="0"/>
+          <a:ea typeface="Verdana" panose="020B0604030504040204" pitchFamily="34" charset="0"/>
+          <a:cs typeface="Verdana" panose="020B0604030504040204" pitchFamily="34" charset="0"/>
         </a:defRPr>
       </a:lvl5pPr>
       <a:lvl6pPr marL="2057400" indent="-342900" algn="l" defTabSz="342900" rtl="0" eaLnBrk="1" latinLnBrk="0" hangingPunct="1">
@@ -3840,6 +3863,13 @@
           </p:nvPr>
         </p:nvSpPr>
         <p:spPr/>
+        <p:txBody>
+          <a:bodyPr/>
+          <a:lstStyle/>
+          <a:p>
+            <a:endParaRPr lang="en-US"/>
+          </a:p>
+        </p:txBody>
       </p:sp>
     </p:spTree>
     <p:extLst>

</xml_diff>

<commit_message>
Establish consistent footer across all slide types
</commit_message>
<xml_diff>
--- a/working-template.pptx
+++ b/working-template.pptx
@@ -1,6 +1,6 @@
 
 <file path=ppt/presentation.xml><?xml version="1.0" encoding="utf-8"?>
-<p:presentation xmlns:a="http://schemas.openxmlformats.org/drawingml/2006/main" xmlns:r="http://schemas.openxmlformats.org/officeDocument/2006/relationships" xmlns:p="http://schemas.openxmlformats.org/presentationml/2006/main" saveSubsetFonts="1" autoCompressPictures="0">
+<p:presentation xmlns:a="http://schemas.openxmlformats.org/drawingml/2006/main" xmlns:r="http://schemas.openxmlformats.org/officeDocument/2006/relationships" xmlns:p="http://schemas.openxmlformats.org/presentationml/2006/main" showSpecialPlsOnTitleSld="0" saveSubsetFonts="1" autoCompressPictures="0">
   <p:sldMasterIdLst>
     <p:sldMasterId id="2147483648" r:id="rId1"/>
   </p:sldMasterIdLst>
@@ -723,7 +723,7 @@
           <a:lstStyle/>
           <a:p>
             <a:r>
-              <a:rPr lang="en-US"/>
+              <a:rPr lang="en-US" dirty="0"/>
               <a:t>Click to edit Master title style</a:t>
             </a:r>
           </a:p>
@@ -849,7 +849,13 @@
       </p:sp>
       <p:sp>
         <p:nvSpPr>
-          <p:cNvPr id="4" name="Date Placeholder 3"/>
+          <p:cNvPr id="7" name="Date Placeholder 6">
+            <a:extLst>
+              <a:ext uri="{FF2B5EF4-FFF2-40B4-BE49-F238E27FC236}">
+                <a16:creationId xmlns:a16="http://schemas.microsoft.com/office/drawing/2014/main" id="{061B09C1-B224-518F-0685-9136C57B0AAB}"/>
+              </a:ext>
+            </a:extLst>
+          </p:cNvPr>
           <p:cNvSpPr>
             <a:spLocks noGrp="1"/>
           </p:cNvSpPr>
@@ -862,17 +868,24 @@
           <a:bodyPr/>
           <a:lstStyle/>
           <a:p>
-            <a:fld id="{241EB5C9-1307-BA42-ABA2-0BC069CD8E7F}" type="datetimeFigureOut">
-              <a:rPr lang="en-US" smtClean="0"/>
+            <a:pPr algn="ctr"/>
+            <a:r>
+              <a:rPr lang="en-US"/>
               <a:t>9/23/26</a:t>
-            </a:fld>
-            <a:endParaRPr lang="en-US"/>
-          </a:p>
-        </p:txBody>
-      </p:sp>
-      <p:sp>
-        <p:nvSpPr>
-          <p:cNvPr id="5" name="Footer Placeholder 4"/>
+            </a:r>
+            <a:endParaRPr lang="en-US" dirty="0"/>
+          </a:p>
+        </p:txBody>
+      </p:sp>
+      <p:sp>
+        <p:nvSpPr>
+          <p:cNvPr id="8" name="Footer Placeholder 7">
+            <a:extLst>
+              <a:ext uri="{FF2B5EF4-FFF2-40B4-BE49-F238E27FC236}">
+                <a16:creationId xmlns:a16="http://schemas.microsoft.com/office/drawing/2014/main" id="{DF1B80E6-457B-EDED-0211-B71E2739445B}"/>
+              </a:ext>
+            </a:extLst>
+          </p:cNvPr>
           <p:cNvSpPr>
             <a:spLocks noGrp="1"/>
           </p:cNvSpPr>
@@ -885,13 +898,23 @@
           <a:bodyPr/>
           <a:lstStyle/>
           <a:p>
-            <a:endParaRPr lang="en-US"/>
-          </a:p>
-        </p:txBody>
-      </p:sp>
-      <p:sp>
-        <p:nvSpPr>
-          <p:cNvPr id="6" name="Slide Number Placeholder 5"/>
+            <a:r>
+              <a:rPr lang="en-US"/>
+              <a:t>© LMU Open Science Center</a:t>
+            </a:r>
+            <a:endParaRPr lang="en-US" dirty="0"/>
+          </a:p>
+        </p:txBody>
+      </p:sp>
+      <p:sp>
+        <p:nvSpPr>
+          <p:cNvPr id="9" name="Slide Number Placeholder 8">
+            <a:extLst>
+              <a:ext uri="{FF2B5EF4-FFF2-40B4-BE49-F238E27FC236}">
+                <a16:creationId xmlns:a16="http://schemas.microsoft.com/office/drawing/2014/main" id="{9A738F11-4DF9-41BE-57C0-5A8B98080E05}"/>
+              </a:ext>
+            </a:extLst>
+          </p:cNvPr>
           <p:cNvSpPr>
             <a:spLocks noGrp="1"/>
           </p:cNvSpPr>
@@ -904,11 +927,17 @@
           <a:bodyPr/>
           <a:lstStyle/>
           <a:p>
+            <a:pPr algn="ctr"/>
+            <a:r>
+              <a:rPr lang="en-US"/>
+              <a:t>Slide </a:t>
+            </a:r>
             <a:fld id="{C5EF2332-01BF-834F-8236-50238282D533}" type="slidenum">
               <a:rPr lang="en-US" smtClean="0"/>
+              <a:pPr algn="ctr"/>
               <a:t>‹#›</a:t>
             </a:fld>
-            <a:endParaRPr lang="en-US"/>
+            <a:endParaRPr lang="en-US" dirty="0"/>
           </a:p>
         </p:txBody>
       </p:sp>
@@ -1033,7 +1062,13 @@
       </p:sp>
       <p:sp>
         <p:nvSpPr>
-          <p:cNvPr id="4" name="Date Placeholder 3"/>
+          <p:cNvPr id="7" name="Date Placeholder 6">
+            <a:extLst>
+              <a:ext uri="{FF2B5EF4-FFF2-40B4-BE49-F238E27FC236}">
+                <a16:creationId xmlns:a16="http://schemas.microsoft.com/office/drawing/2014/main" id="{1633ABB9-0FD6-00F4-2186-D3425C9073F8}"/>
+              </a:ext>
+            </a:extLst>
+          </p:cNvPr>
           <p:cNvSpPr>
             <a:spLocks noGrp="1"/>
           </p:cNvSpPr>
@@ -1046,17 +1081,24 @@
           <a:bodyPr/>
           <a:lstStyle/>
           <a:p>
-            <a:fld id="{241EB5C9-1307-BA42-ABA2-0BC069CD8E7F}" type="datetimeFigureOut">
-              <a:rPr lang="en-US" smtClean="0"/>
+            <a:pPr algn="ctr"/>
+            <a:r>
+              <a:rPr lang="en-US"/>
               <a:t>9/23/26</a:t>
-            </a:fld>
-            <a:endParaRPr lang="en-US"/>
-          </a:p>
-        </p:txBody>
-      </p:sp>
-      <p:sp>
-        <p:nvSpPr>
-          <p:cNvPr id="5" name="Footer Placeholder 4"/>
+            </a:r>
+            <a:endParaRPr lang="en-US" dirty="0"/>
+          </a:p>
+        </p:txBody>
+      </p:sp>
+      <p:sp>
+        <p:nvSpPr>
+          <p:cNvPr id="8" name="Footer Placeholder 7">
+            <a:extLst>
+              <a:ext uri="{FF2B5EF4-FFF2-40B4-BE49-F238E27FC236}">
+                <a16:creationId xmlns:a16="http://schemas.microsoft.com/office/drawing/2014/main" id="{2CF2A15A-E38D-BBA2-F6E5-F54E8EE4FC5E}"/>
+              </a:ext>
+            </a:extLst>
+          </p:cNvPr>
           <p:cNvSpPr>
             <a:spLocks noGrp="1"/>
           </p:cNvSpPr>
@@ -1069,13 +1111,23 @@
           <a:bodyPr/>
           <a:lstStyle/>
           <a:p>
-            <a:endParaRPr lang="en-US"/>
-          </a:p>
-        </p:txBody>
-      </p:sp>
-      <p:sp>
-        <p:nvSpPr>
-          <p:cNvPr id="6" name="Slide Number Placeholder 5"/>
+            <a:r>
+              <a:rPr lang="en-US"/>
+              <a:t>© LMU Open Science Center</a:t>
+            </a:r>
+            <a:endParaRPr lang="en-US" dirty="0"/>
+          </a:p>
+        </p:txBody>
+      </p:sp>
+      <p:sp>
+        <p:nvSpPr>
+          <p:cNvPr id="9" name="Slide Number Placeholder 8">
+            <a:extLst>
+              <a:ext uri="{FF2B5EF4-FFF2-40B4-BE49-F238E27FC236}">
+                <a16:creationId xmlns:a16="http://schemas.microsoft.com/office/drawing/2014/main" id="{C752F930-079C-2B09-0620-3D5F46770B5E}"/>
+              </a:ext>
+            </a:extLst>
+          </p:cNvPr>
           <p:cNvSpPr>
             <a:spLocks noGrp="1"/>
           </p:cNvSpPr>
@@ -1088,11 +1140,17 @@
           <a:bodyPr/>
           <a:lstStyle/>
           <a:p>
+            <a:pPr algn="ctr"/>
+            <a:r>
+              <a:rPr lang="en-US"/>
+              <a:t>Slide </a:t>
+            </a:r>
             <a:fld id="{C5EF2332-01BF-834F-8236-50238282D533}" type="slidenum">
               <a:rPr lang="en-US" smtClean="0"/>
+              <a:pPr algn="ctr"/>
               <a:t>‹#›</a:t>
             </a:fld>
-            <a:endParaRPr lang="en-US"/>
+            <a:endParaRPr lang="en-US" dirty="0"/>
           </a:p>
         </p:txBody>
       </p:sp>
@@ -1211,7 +1269,13 @@
       </p:sp>
       <p:sp>
         <p:nvSpPr>
-          <p:cNvPr id="4" name="Date Placeholder 3"/>
+          <p:cNvPr id="7" name="Date Placeholder 6">
+            <a:extLst>
+              <a:ext uri="{FF2B5EF4-FFF2-40B4-BE49-F238E27FC236}">
+                <a16:creationId xmlns:a16="http://schemas.microsoft.com/office/drawing/2014/main" id="{DE35559A-56D2-4FD7-4D20-D71F4C8215E0}"/>
+              </a:ext>
+            </a:extLst>
+          </p:cNvPr>
           <p:cNvSpPr>
             <a:spLocks noGrp="1"/>
           </p:cNvSpPr>
@@ -1224,17 +1288,24 @@
           <a:bodyPr/>
           <a:lstStyle/>
           <a:p>
-            <a:fld id="{241EB5C9-1307-BA42-ABA2-0BC069CD8E7F}" type="datetimeFigureOut">
-              <a:rPr lang="en-US" smtClean="0"/>
+            <a:pPr algn="ctr"/>
+            <a:r>
+              <a:rPr lang="en-US"/>
               <a:t>9/23/26</a:t>
-            </a:fld>
-            <a:endParaRPr lang="en-US"/>
-          </a:p>
-        </p:txBody>
-      </p:sp>
-      <p:sp>
-        <p:nvSpPr>
-          <p:cNvPr id="5" name="Footer Placeholder 4"/>
+            </a:r>
+            <a:endParaRPr lang="en-US" dirty="0"/>
+          </a:p>
+        </p:txBody>
+      </p:sp>
+      <p:sp>
+        <p:nvSpPr>
+          <p:cNvPr id="8" name="Footer Placeholder 7">
+            <a:extLst>
+              <a:ext uri="{FF2B5EF4-FFF2-40B4-BE49-F238E27FC236}">
+                <a16:creationId xmlns:a16="http://schemas.microsoft.com/office/drawing/2014/main" id="{4E340C61-838A-D2E9-36F0-C1EB6496D16C}"/>
+              </a:ext>
+            </a:extLst>
+          </p:cNvPr>
           <p:cNvSpPr>
             <a:spLocks noGrp="1"/>
           </p:cNvSpPr>
@@ -1247,13 +1318,23 @@
           <a:bodyPr/>
           <a:lstStyle/>
           <a:p>
-            <a:endParaRPr lang="en-US"/>
-          </a:p>
-        </p:txBody>
-      </p:sp>
-      <p:sp>
-        <p:nvSpPr>
-          <p:cNvPr id="6" name="Slide Number Placeholder 5"/>
+            <a:r>
+              <a:rPr lang="en-US"/>
+              <a:t>© LMU Open Science Center</a:t>
+            </a:r>
+            <a:endParaRPr lang="en-US" dirty="0"/>
+          </a:p>
+        </p:txBody>
+      </p:sp>
+      <p:sp>
+        <p:nvSpPr>
+          <p:cNvPr id="9" name="Slide Number Placeholder 8">
+            <a:extLst>
+              <a:ext uri="{FF2B5EF4-FFF2-40B4-BE49-F238E27FC236}">
+                <a16:creationId xmlns:a16="http://schemas.microsoft.com/office/drawing/2014/main" id="{C0F46CA0-DC5C-0E94-9C04-A3785DB5CE53}"/>
+              </a:ext>
+            </a:extLst>
+          </p:cNvPr>
           <p:cNvSpPr>
             <a:spLocks noGrp="1"/>
           </p:cNvSpPr>
@@ -1266,11 +1347,17 @@
           <a:bodyPr/>
           <a:lstStyle/>
           <a:p>
+            <a:pPr algn="ctr"/>
+            <a:r>
+              <a:rPr lang="en-US"/>
+              <a:t>Slide </a:t>
+            </a:r>
             <a:fld id="{C5EF2332-01BF-834F-8236-50238282D533}" type="slidenum">
               <a:rPr lang="en-US" smtClean="0"/>
+              <a:pPr algn="ctr"/>
               <a:t>‹#›</a:t>
             </a:fld>
-            <a:endParaRPr lang="en-US"/>
+            <a:endParaRPr lang="en-US" dirty="0"/>
           </a:p>
         </p:txBody>
       </p:sp>
@@ -1379,7 +1466,13 @@
       </p:sp>
       <p:sp>
         <p:nvSpPr>
-          <p:cNvPr id="4" name="Date Placeholder 3"/>
+          <p:cNvPr id="7" name="Date Placeholder 6">
+            <a:extLst>
+              <a:ext uri="{FF2B5EF4-FFF2-40B4-BE49-F238E27FC236}">
+                <a16:creationId xmlns:a16="http://schemas.microsoft.com/office/drawing/2014/main" id="{E2ED1F55-3CE9-F618-3510-EE96FDC54304}"/>
+              </a:ext>
+            </a:extLst>
+          </p:cNvPr>
           <p:cNvSpPr>
             <a:spLocks noGrp="1"/>
           </p:cNvSpPr>
@@ -1392,17 +1485,24 @@
           <a:bodyPr/>
           <a:lstStyle/>
           <a:p>
-            <a:fld id="{241EB5C9-1307-BA42-ABA2-0BC069CD8E7F}" type="datetimeFigureOut">
-              <a:rPr lang="en-US" smtClean="0"/>
+            <a:pPr algn="ctr"/>
+            <a:r>
+              <a:rPr lang="en-US"/>
               <a:t>9/23/26</a:t>
-            </a:fld>
-            <a:endParaRPr lang="en-US"/>
-          </a:p>
-        </p:txBody>
-      </p:sp>
-      <p:sp>
-        <p:nvSpPr>
-          <p:cNvPr id="5" name="Footer Placeholder 4"/>
+            </a:r>
+            <a:endParaRPr lang="en-US" dirty="0"/>
+          </a:p>
+        </p:txBody>
+      </p:sp>
+      <p:sp>
+        <p:nvSpPr>
+          <p:cNvPr id="8" name="Footer Placeholder 7">
+            <a:extLst>
+              <a:ext uri="{FF2B5EF4-FFF2-40B4-BE49-F238E27FC236}">
+                <a16:creationId xmlns:a16="http://schemas.microsoft.com/office/drawing/2014/main" id="{0616AEA6-DD6E-40D4-2DDA-E355C068ABA2}"/>
+              </a:ext>
+            </a:extLst>
+          </p:cNvPr>
           <p:cNvSpPr>
             <a:spLocks noGrp="1"/>
           </p:cNvSpPr>
@@ -1415,13 +1515,23 @@
           <a:bodyPr/>
           <a:lstStyle/>
           <a:p>
-            <a:endParaRPr lang="en-US"/>
-          </a:p>
-        </p:txBody>
-      </p:sp>
-      <p:sp>
-        <p:nvSpPr>
-          <p:cNvPr id="6" name="Slide Number Placeholder 5"/>
+            <a:r>
+              <a:rPr lang="en-US"/>
+              <a:t>© LMU Open Science Center</a:t>
+            </a:r>
+            <a:endParaRPr lang="en-US" dirty="0"/>
+          </a:p>
+        </p:txBody>
+      </p:sp>
+      <p:sp>
+        <p:nvSpPr>
+          <p:cNvPr id="9" name="Slide Number Placeholder 8">
+            <a:extLst>
+              <a:ext uri="{FF2B5EF4-FFF2-40B4-BE49-F238E27FC236}">
+                <a16:creationId xmlns:a16="http://schemas.microsoft.com/office/drawing/2014/main" id="{BD632E70-5D06-CAE0-ED30-149A6C1E3F1E}"/>
+              </a:ext>
+            </a:extLst>
+          </p:cNvPr>
           <p:cNvSpPr>
             <a:spLocks noGrp="1"/>
           </p:cNvSpPr>
@@ -1434,11 +1544,17 @@
           <a:bodyPr/>
           <a:lstStyle/>
           <a:p>
+            <a:pPr algn="ctr"/>
+            <a:r>
+              <a:rPr lang="en-US"/>
+              <a:t>Slide </a:t>
+            </a:r>
             <a:fld id="{C5EF2332-01BF-834F-8236-50238282D533}" type="slidenum">
               <a:rPr lang="en-US" smtClean="0"/>
+              <a:pPr algn="ctr"/>
               <a:t>‹#›</a:t>
             </a:fld>
-            <a:endParaRPr lang="en-US"/>
+            <a:endParaRPr lang="en-US" dirty="0"/>
           </a:p>
         </p:txBody>
       </p:sp>
@@ -1624,7 +1740,13 @@
       </p:sp>
       <p:sp>
         <p:nvSpPr>
-          <p:cNvPr id="4" name="Date Placeholder 3"/>
+          <p:cNvPr id="7" name="Date Placeholder 6">
+            <a:extLst>
+              <a:ext uri="{FF2B5EF4-FFF2-40B4-BE49-F238E27FC236}">
+                <a16:creationId xmlns:a16="http://schemas.microsoft.com/office/drawing/2014/main" id="{7A3D4B62-A9D4-A224-853C-F47B5EEC33A2}"/>
+              </a:ext>
+            </a:extLst>
+          </p:cNvPr>
           <p:cNvSpPr>
             <a:spLocks noGrp="1"/>
           </p:cNvSpPr>
@@ -1637,17 +1759,24 @@
           <a:bodyPr/>
           <a:lstStyle/>
           <a:p>
-            <a:fld id="{241EB5C9-1307-BA42-ABA2-0BC069CD8E7F}" type="datetimeFigureOut">
-              <a:rPr lang="en-US" smtClean="0"/>
+            <a:pPr algn="ctr"/>
+            <a:r>
+              <a:rPr lang="en-US"/>
               <a:t>9/23/26</a:t>
-            </a:fld>
-            <a:endParaRPr lang="en-US"/>
-          </a:p>
-        </p:txBody>
-      </p:sp>
-      <p:sp>
-        <p:nvSpPr>
-          <p:cNvPr id="5" name="Footer Placeholder 4"/>
+            </a:r>
+            <a:endParaRPr lang="en-US" dirty="0"/>
+          </a:p>
+        </p:txBody>
+      </p:sp>
+      <p:sp>
+        <p:nvSpPr>
+          <p:cNvPr id="8" name="Footer Placeholder 7">
+            <a:extLst>
+              <a:ext uri="{FF2B5EF4-FFF2-40B4-BE49-F238E27FC236}">
+                <a16:creationId xmlns:a16="http://schemas.microsoft.com/office/drawing/2014/main" id="{FC227C7C-21CB-0721-ADC3-A51EEAD51D56}"/>
+              </a:ext>
+            </a:extLst>
+          </p:cNvPr>
           <p:cNvSpPr>
             <a:spLocks noGrp="1"/>
           </p:cNvSpPr>
@@ -1660,13 +1789,23 @@
           <a:bodyPr/>
           <a:lstStyle/>
           <a:p>
-            <a:endParaRPr lang="en-US"/>
-          </a:p>
-        </p:txBody>
-      </p:sp>
-      <p:sp>
-        <p:nvSpPr>
-          <p:cNvPr id="6" name="Slide Number Placeholder 5"/>
+            <a:r>
+              <a:rPr lang="en-US"/>
+              <a:t>© LMU Open Science Center</a:t>
+            </a:r>
+            <a:endParaRPr lang="en-US" dirty="0"/>
+          </a:p>
+        </p:txBody>
+      </p:sp>
+      <p:sp>
+        <p:nvSpPr>
+          <p:cNvPr id="9" name="Slide Number Placeholder 8">
+            <a:extLst>
+              <a:ext uri="{FF2B5EF4-FFF2-40B4-BE49-F238E27FC236}">
+                <a16:creationId xmlns:a16="http://schemas.microsoft.com/office/drawing/2014/main" id="{E630E53C-392D-BD97-174E-961B24066A76}"/>
+              </a:ext>
+            </a:extLst>
+          </p:cNvPr>
           <p:cNvSpPr>
             <a:spLocks noGrp="1"/>
           </p:cNvSpPr>
@@ -1679,11 +1818,17 @@
           <a:bodyPr/>
           <a:lstStyle/>
           <a:p>
+            <a:pPr algn="ctr"/>
+            <a:r>
+              <a:rPr lang="en-US"/>
+              <a:t>Slide </a:t>
+            </a:r>
             <a:fld id="{C5EF2332-01BF-834F-8236-50238282D533}" type="slidenum">
               <a:rPr lang="en-US" smtClean="0"/>
+              <a:pPr algn="ctr"/>
               <a:t>‹#›</a:t>
             </a:fld>
-            <a:endParaRPr lang="en-US"/>
+            <a:endParaRPr lang="en-US" dirty="0"/>
           </a:p>
         </p:txBody>
       </p:sp>
@@ -1909,7 +2054,13 @@
       </p:sp>
       <p:sp>
         <p:nvSpPr>
-          <p:cNvPr id="5" name="Date Placeholder 4"/>
+          <p:cNvPr id="8" name="Date Placeholder 7">
+            <a:extLst>
+              <a:ext uri="{FF2B5EF4-FFF2-40B4-BE49-F238E27FC236}">
+                <a16:creationId xmlns:a16="http://schemas.microsoft.com/office/drawing/2014/main" id="{53BFD42A-B99F-B332-F96E-677E56BC9A77}"/>
+              </a:ext>
+            </a:extLst>
+          </p:cNvPr>
           <p:cNvSpPr>
             <a:spLocks noGrp="1"/>
           </p:cNvSpPr>
@@ -1922,17 +2073,24 @@
           <a:bodyPr/>
           <a:lstStyle/>
           <a:p>
-            <a:fld id="{241EB5C9-1307-BA42-ABA2-0BC069CD8E7F}" type="datetimeFigureOut">
-              <a:rPr lang="en-US" smtClean="0"/>
+            <a:pPr algn="ctr"/>
+            <a:r>
+              <a:rPr lang="en-US"/>
               <a:t>9/23/26</a:t>
-            </a:fld>
-            <a:endParaRPr lang="en-US"/>
-          </a:p>
-        </p:txBody>
-      </p:sp>
-      <p:sp>
-        <p:nvSpPr>
-          <p:cNvPr id="6" name="Footer Placeholder 5"/>
+            </a:r>
+            <a:endParaRPr lang="en-US" dirty="0"/>
+          </a:p>
+        </p:txBody>
+      </p:sp>
+      <p:sp>
+        <p:nvSpPr>
+          <p:cNvPr id="9" name="Footer Placeholder 8">
+            <a:extLst>
+              <a:ext uri="{FF2B5EF4-FFF2-40B4-BE49-F238E27FC236}">
+                <a16:creationId xmlns:a16="http://schemas.microsoft.com/office/drawing/2014/main" id="{E7917CDB-D8CE-FB9A-9950-24117F9B85CA}"/>
+              </a:ext>
+            </a:extLst>
+          </p:cNvPr>
           <p:cNvSpPr>
             <a:spLocks noGrp="1"/>
           </p:cNvSpPr>
@@ -1945,13 +2103,23 @@
           <a:bodyPr/>
           <a:lstStyle/>
           <a:p>
-            <a:endParaRPr lang="en-US"/>
-          </a:p>
-        </p:txBody>
-      </p:sp>
-      <p:sp>
-        <p:nvSpPr>
-          <p:cNvPr id="7" name="Slide Number Placeholder 6"/>
+            <a:r>
+              <a:rPr lang="en-US"/>
+              <a:t>© LMU Open Science Center</a:t>
+            </a:r>
+            <a:endParaRPr lang="en-US" dirty="0"/>
+          </a:p>
+        </p:txBody>
+      </p:sp>
+      <p:sp>
+        <p:nvSpPr>
+          <p:cNvPr id="10" name="Slide Number Placeholder 9">
+            <a:extLst>
+              <a:ext uri="{FF2B5EF4-FFF2-40B4-BE49-F238E27FC236}">
+                <a16:creationId xmlns:a16="http://schemas.microsoft.com/office/drawing/2014/main" id="{761EF569-90C9-0E39-2DB2-EBF7BACC7581}"/>
+              </a:ext>
+            </a:extLst>
+          </p:cNvPr>
           <p:cNvSpPr>
             <a:spLocks noGrp="1"/>
           </p:cNvSpPr>
@@ -1964,11 +2132,17 @@
           <a:bodyPr/>
           <a:lstStyle/>
           <a:p>
+            <a:pPr algn="ctr"/>
+            <a:r>
+              <a:rPr lang="en-US"/>
+              <a:t>Slide </a:t>
+            </a:r>
             <a:fld id="{C5EF2332-01BF-834F-8236-50238282D533}" type="slidenum">
               <a:rPr lang="en-US" smtClean="0"/>
+              <a:pPr algn="ctr"/>
               <a:t>‹#›</a:t>
             </a:fld>
-            <a:endParaRPr lang="en-US"/>
+            <a:endParaRPr lang="en-US" dirty="0"/>
           </a:p>
         </p:txBody>
       </p:sp>
@@ -2328,7 +2502,13 @@
       </p:sp>
       <p:sp>
         <p:nvSpPr>
-          <p:cNvPr id="7" name="Date Placeholder 6"/>
+          <p:cNvPr id="10" name="Date Placeholder 9">
+            <a:extLst>
+              <a:ext uri="{FF2B5EF4-FFF2-40B4-BE49-F238E27FC236}">
+                <a16:creationId xmlns:a16="http://schemas.microsoft.com/office/drawing/2014/main" id="{C6779744-BA8A-1AED-290E-865E62914D1E}"/>
+              </a:ext>
+            </a:extLst>
+          </p:cNvPr>
           <p:cNvSpPr>
             <a:spLocks noGrp="1"/>
           </p:cNvSpPr>
@@ -2341,17 +2521,24 @@
           <a:bodyPr/>
           <a:lstStyle/>
           <a:p>
-            <a:fld id="{241EB5C9-1307-BA42-ABA2-0BC069CD8E7F}" type="datetimeFigureOut">
-              <a:rPr lang="en-US" smtClean="0"/>
+            <a:pPr algn="ctr"/>
+            <a:r>
+              <a:rPr lang="en-US"/>
               <a:t>9/23/26</a:t>
-            </a:fld>
-            <a:endParaRPr lang="en-US"/>
-          </a:p>
-        </p:txBody>
-      </p:sp>
-      <p:sp>
-        <p:nvSpPr>
-          <p:cNvPr id="8" name="Footer Placeholder 7"/>
+            </a:r>
+            <a:endParaRPr lang="en-US" dirty="0"/>
+          </a:p>
+        </p:txBody>
+      </p:sp>
+      <p:sp>
+        <p:nvSpPr>
+          <p:cNvPr id="11" name="Footer Placeholder 10">
+            <a:extLst>
+              <a:ext uri="{FF2B5EF4-FFF2-40B4-BE49-F238E27FC236}">
+                <a16:creationId xmlns:a16="http://schemas.microsoft.com/office/drawing/2014/main" id="{1848E229-50B2-977A-CF44-3D42D1183372}"/>
+              </a:ext>
+            </a:extLst>
+          </p:cNvPr>
           <p:cNvSpPr>
             <a:spLocks noGrp="1"/>
           </p:cNvSpPr>
@@ -2364,13 +2551,23 @@
           <a:bodyPr/>
           <a:lstStyle/>
           <a:p>
-            <a:endParaRPr lang="en-US"/>
-          </a:p>
-        </p:txBody>
-      </p:sp>
-      <p:sp>
-        <p:nvSpPr>
-          <p:cNvPr id="9" name="Slide Number Placeholder 8"/>
+            <a:r>
+              <a:rPr lang="en-US"/>
+              <a:t>© LMU Open Science Center</a:t>
+            </a:r>
+            <a:endParaRPr lang="en-US" dirty="0"/>
+          </a:p>
+        </p:txBody>
+      </p:sp>
+      <p:sp>
+        <p:nvSpPr>
+          <p:cNvPr id="12" name="Slide Number Placeholder 11">
+            <a:extLst>
+              <a:ext uri="{FF2B5EF4-FFF2-40B4-BE49-F238E27FC236}">
+                <a16:creationId xmlns:a16="http://schemas.microsoft.com/office/drawing/2014/main" id="{20842B77-B6EE-65F3-DC92-E2534256F029}"/>
+              </a:ext>
+            </a:extLst>
+          </p:cNvPr>
           <p:cNvSpPr>
             <a:spLocks noGrp="1"/>
           </p:cNvSpPr>
@@ -2383,11 +2580,17 @@
           <a:bodyPr/>
           <a:lstStyle/>
           <a:p>
+            <a:pPr algn="ctr"/>
+            <a:r>
+              <a:rPr lang="en-US"/>
+              <a:t>Slide </a:t>
+            </a:r>
             <a:fld id="{C5EF2332-01BF-834F-8236-50238282D533}" type="slidenum">
               <a:rPr lang="en-US" smtClean="0"/>
+              <a:pPr algn="ctr"/>
               <a:t>‹#›</a:t>
             </a:fld>
-            <a:endParaRPr lang="en-US"/>
+            <a:endParaRPr lang="en-US" dirty="0"/>
           </a:p>
         </p:txBody>
       </p:sp>
@@ -2445,7 +2648,13 @@
       </p:sp>
       <p:sp>
         <p:nvSpPr>
-          <p:cNvPr id="3" name="Date Placeholder 2"/>
+          <p:cNvPr id="6" name="Date Placeholder 5">
+            <a:extLst>
+              <a:ext uri="{FF2B5EF4-FFF2-40B4-BE49-F238E27FC236}">
+                <a16:creationId xmlns:a16="http://schemas.microsoft.com/office/drawing/2014/main" id="{EBAFF52C-BDE9-B757-3F2E-97BB80768043}"/>
+              </a:ext>
+            </a:extLst>
+          </p:cNvPr>
           <p:cNvSpPr>
             <a:spLocks noGrp="1"/>
           </p:cNvSpPr>
@@ -2458,17 +2667,24 @@
           <a:bodyPr/>
           <a:lstStyle/>
           <a:p>
-            <a:fld id="{241EB5C9-1307-BA42-ABA2-0BC069CD8E7F}" type="datetimeFigureOut">
-              <a:rPr lang="en-US" smtClean="0"/>
+            <a:pPr algn="ctr"/>
+            <a:r>
+              <a:rPr lang="en-US"/>
               <a:t>9/23/26</a:t>
-            </a:fld>
-            <a:endParaRPr lang="en-US"/>
-          </a:p>
-        </p:txBody>
-      </p:sp>
-      <p:sp>
-        <p:nvSpPr>
-          <p:cNvPr id="4" name="Footer Placeholder 3"/>
+            </a:r>
+            <a:endParaRPr lang="en-US" dirty="0"/>
+          </a:p>
+        </p:txBody>
+      </p:sp>
+      <p:sp>
+        <p:nvSpPr>
+          <p:cNvPr id="7" name="Footer Placeholder 6">
+            <a:extLst>
+              <a:ext uri="{FF2B5EF4-FFF2-40B4-BE49-F238E27FC236}">
+                <a16:creationId xmlns:a16="http://schemas.microsoft.com/office/drawing/2014/main" id="{E5405DF6-2DBE-DEB9-2870-BF132FA011E6}"/>
+              </a:ext>
+            </a:extLst>
+          </p:cNvPr>
           <p:cNvSpPr>
             <a:spLocks noGrp="1"/>
           </p:cNvSpPr>
@@ -2481,13 +2697,23 @@
           <a:bodyPr/>
           <a:lstStyle/>
           <a:p>
-            <a:endParaRPr lang="en-US"/>
-          </a:p>
-        </p:txBody>
-      </p:sp>
-      <p:sp>
-        <p:nvSpPr>
-          <p:cNvPr id="5" name="Slide Number Placeholder 4"/>
+            <a:r>
+              <a:rPr lang="en-US"/>
+              <a:t>© LMU Open Science Center</a:t>
+            </a:r>
+            <a:endParaRPr lang="en-US" dirty="0"/>
+          </a:p>
+        </p:txBody>
+      </p:sp>
+      <p:sp>
+        <p:nvSpPr>
+          <p:cNvPr id="8" name="Slide Number Placeholder 7">
+            <a:extLst>
+              <a:ext uri="{FF2B5EF4-FFF2-40B4-BE49-F238E27FC236}">
+                <a16:creationId xmlns:a16="http://schemas.microsoft.com/office/drawing/2014/main" id="{2168DBF4-2CFD-1E51-8AC7-982150A40374}"/>
+              </a:ext>
+            </a:extLst>
+          </p:cNvPr>
           <p:cNvSpPr>
             <a:spLocks noGrp="1"/>
           </p:cNvSpPr>
@@ -2500,11 +2726,17 @@
           <a:bodyPr/>
           <a:lstStyle/>
           <a:p>
+            <a:pPr algn="ctr"/>
+            <a:r>
+              <a:rPr lang="en-US"/>
+              <a:t>Slide </a:t>
+            </a:r>
             <a:fld id="{C5EF2332-01BF-834F-8236-50238282D533}" type="slidenum">
               <a:rPr lang="en-US" smtClean="0"/>
+              <a:pPr algn="ctr"/>
               <a:t>‹#›</a:t>
             </a:fld>
-            <a:endParaRPr lang="en-US"/>
+            <a:endParaRPr lang="en-US" dirty="0"/>
           </a:p>
         </p:txBody>
       </p:sp>
@@ -2540,7 +2772,13 @@
       </p:grpSpPr>
       <p:sp>
         <p:nvSpPr>
-          <p:cNvPr id="2" name="Date Placeholder 1"/>
+          <p:cNvPr id="5" name="Date Placeholder 4">
+            <a:extLst>
+              <a:ext uri="{FF2B5EF4-FFF2-40B4-BE49-F238E27FC236}">
+                <a16:creationId xmlns:a16="http://schemas.microsoft.com/office/drawing/2014/main" id="{809DEAED-D9B3-6E1B-0491-58CD791C90BA}"/>
+              </a:ext>
+            </a:extLst>
+          </p:cNvPr>
           <p:cNvSpPr>
             <a:spLocks noGrp="1"/>
           </p:cNvSpPr>
@@ -2553,17 +2791,24 @@
           <a:bodyPr/>
           <a:lstStyle/>
           <a:p>
-            <a:fld id="{241EB5C9-1307-BA42-ABA2-0BC069CD8E7F}" type="datetimeFigureOut">
-              <a:rPr lang="en-US" smtClean="0"/>
+            <a:pPr algn="ctr"/>
+            <a:r>
+              <a:rPr lang="en-US"/>
               <a:t>9/23/26</a:t>
-            </a:fld>
-            <a:endParaRPr lang="en-US"/>
-          </a:p>
-        </p:txBody>
-      </p:sp>
-      <p:sp>
-        <p:nvSpPr>
-          <p:cNvPr id="3" name="Footer Placeholder 2"/>
+            </a:r>
+            <a:endParaRPr lang="en-US" dirty="0"/>
+          </a:p>
+        </p:txBody>
+      </p:sp>
+      <p:sp>
+        <p:nvSpPr>
+          <p:cNvPr id="6" name="Footer Placeholder 5">
+            <a:extLst>
+              <a:ext uri="{FF2B5EF4-FFF2-40B4-BE49-F238E27FC236}">
+                <a16:creationId xmlns:a16="http://schemas.microsoft.com/office/drawing/2014/main" id="{77F0CD55-CE9E-DB6C-0EC3-1B10A9E5C45B}"/>
+              </a:ext>
+            </a:extLst>
+          </p:cNvPr>
           <p:cNvSpPr>
             <a:spLocks noGrp="1"/>
           </p:cNvSpPr>
@@ -2576,13 +2821,23 @@
           <a:bodyPr/>
           <a:lstStyle/>
           <a:p>
-            <a:endParaRPr lang="en-US"/>
-          </a:p>
-        </p:txBody>
-      </p:sp>
-      <p:sp>
-        <p:nvSpPr>
-          <p:cNvPr id="4" name="Slide Number Placeholder 3"/>
+            <a:r>
+              <a:rPr lang="en-US"/>
+              <a:t>© LMU Open Science Center</a:t>
+            </a:r>
+            <a:endParaRPr lang="en-US" dirty="0"/>
+          </a:p>
+        </p:txBody>
+      </p:sp>
+      <p:sp>
+        <p:nvSpPr>
+          <p:cNvPr id="7" name="Slide Number Placeholder 6">
+            <a:extLst>
+              <a:ext uri="{FF2B5EF4-FFF2-40B4-BE49-F238E27FC236}">
+                <a16:creationId xmlns:a16="http://schemas.microsoft.com/office/drawing/2014/main" id="{E9FEDD56-48D3-8D4B-FA52-B62AB7006E2A}"/>
+              </a:ext>
+            </a:extLst>
+          </p:cNvPr>
           <p:cNvSpPr>
             <a:spLocks noGrp="1"/>
           </p:cNvSpPr>
@@ -2595,11 +2850,17 @@
           <a:bodyPr/>
           <a:lstStyle/>
           <a:p>
+            <a:pPr algn="ctr"/>
+            <a:r>
+              <a:rPr lang="en-US"/>
+              <a:t>Slide </a:t>
+            </a:r>
             <a:fld id="{C5EF2332-01BF-834F-8236-50238282D533}" type="slidenum">
               <a:rPr lang="en-US" smtClean="0"/>
+              <a:pPr algn="ctr"/>
               <a:t>‹#›</a:t>
             </a:fld>
-            <a:endParaRPr lang="en-US"/>
+            <a:endParaRPr lang="en-US" dirty="0"/>
           </a:p>
         </p:txBody>
       </p:sp>
@@ -2815,7 +3076,13 @@
       </p:sp>
       <p:sp>
         <p:nvSpPr>
-          <p:cNvPr id="5" name="Date Placeholder 4"/>
+          <p:cNvPr id="8" name="Date Placeholder 7">
+            <a:extLst>
+              <a:ext uri="{FF2B5EF4-FFF2-40B4-BE49-F238E27FC236}">
+                <a16:creationId xmlns:a16="http://schemas.microsoft.com/office/drawing/2014/main" id="{E6D5126F-053F-910F-7F76-D928AC61372D}"/>
+              </a:ext>
+            </a:extLst>
+          </p:cNvPr>
           <p:cNvSpPr>
             <a:spLocks noGrp="1"/>
           </p:cNvSpPr>
@@ -2828,17 +3095,24 @@
           <a:bodyPr/>
           <a:lstStyle/>
           <a:p>
-            <a:fld id="{241EB5C9-1307-BA42-ABA2-0BC069CD8E7F}" type="datetimeFigureOut">
-              <a:rPr lang="en-US" smtClean="0"/>
+            <a:pPr algn="ctr"/>
+            <a:r>
+              <a:rPr lang="en-US"/>
               <a:t>9/23/26</a:t>
-            </a:fld>
-            <a:endParaRPr lang="en-US"/>
-          </a:p>
-        </p:txBody>
-      </p:sp>
-      <p:sp>
-        <p:nvSpPr>
-          <p:cNvPr id="6" name="Footer Placeholder 5"/>
+            </a:r>
+            <a:endParaRPr lang="en-US" dirty="0"/>
+          </a:p>
+        </p:txBody>
+      </p:sp>
+      <p:sp>
+        <p:nvSpPr>
+          <p:cNvPr id="9" name="Footer Placeholder 8">
+            <a:extLst>
+              <a:ext uri="{FF2B5EF4-FFF2-40B4-BE49-F238E27FC236}">
+                <a16:creationId xmlns:a16="http://schemas.microsoft.com/office/drawing/2014/main" id="{8EEF7D04-FF72-0698-CE48-A9A4F70D774F}"/>
+              </a:ext>
+            </a:extLst>
+          </p:cNvPr>
           <p:cNvSpPr>
             <a:spLocks noGrp="1"/>
           </p:cNvSpPr>
@@ -2851,13 +3125,23 @@
           <a:bodyPr/>
           <a:lstStyle/>
           <a:p>
-            <a:endParaRPr lang="en-US"/>
-          </a:p>
-        </p:txBody>
-      </p:sp>
-      <p:sp>
-        <p:nvSpPr>
-          <p:cNvPr id="7" name="Slide Number Placeholder 6"/>
+            <a:r>
+              <a:rPr lang="en-US"/>
+              <a:t>© LMU Open Science Center</a:t>
+            </a:r>
+            <a:endParaRPr lang="en-US" dirty="0"/>
+          </a:p>
+        </p:txBody>
+      </p:sp>
+      <p:sp>
+        <p:nvSpPr>
+          <p:cNvPr id="10" name="Slide Number Placeholder 9">
+            <a:extLst>
+              <a:ext uri="{FF2B5EF4-FFF2-40B4-BE49-F238E27FC236}">
+                <a16:creationId xmlns:a16="http://schemas.microsoft.com/office/drawing/2014/main" id="{C8B1F07D-59FC-87D1-1BB5-7C86711059AF}"/>
+              </a:ext>
+            </a:extLst>
+          </p:cNvPr>
           <p:cNvSpPr>
             <a:spLocks noGrp="1"/>
           </p:cNvSpPr>
@@ -2870,11 +3154,17 @@
           <a:bodyPr/>
           <a:lstStyle/>
           <a:p>
+            <a:pPr algn="ctr"/>
+            <a:r>
+              <a:rPr lang="en-US"/>
+              <a:t>Slide </a:t>
+            </a:r>
             <a:fld id="{C5EF2332-01BF-834F-8236-50238282D533}" type="slidenum">
               <a:rPr lang="en-US" smtClean="0"/>
+              <a:pPr algn="ctr"/>
               <a:t>‹#›</a:t>
             </a:fld>
-            <a:endParaRPr lang="en-US"/>
+            <a:endParaRPr lang="en-US" dirty="0"/>
           </a:p>
         </p:txBody>
       </p:sp>
@@ -3067,7 +3357,13 @@
       </p:sp>
       <p:sp>
         <p:nvSpPr>
-          <p:cNvPr id="5" name="Date Placeholder 4"/>
+          <p:cNvPr id="8" name="Date Placeholder 7">
+            <a:extLst>
+              <a:ext uri="{FF2B5EF4-FFF2-40B4-BE49-F238E27FC236}">
+                <a16:creationId xmlns:a16="http://schemas.microsoft.com/office/drawing/2014/main" id="{29EE7C5F-ABAD-CC52-7A14-40327B8307C5}"/>
+              </a:ext>
+            </a:extLst>
+          </p:cNvPr>
           <p:cNvSpPr>
             <a:spLocks noGrp="1"/>
           </p:cNvSpPr>
@@ -3080,17 +3376,24 @@
           <a:bodyPr/>
           <a:lstStyle/>
           <a:p>
-            <a:fld id="{241EB5C9-1307-BA42-ABA2-0BC069CD8E7F}" type="datetimeFigureOut">
-              <a:rPr lang="en-US" smtClean="0"/>
+            <a:pPr algn="ctr"/>
+            <a:r>
+              <a:rPr lang="en-US"/>
               <a:t>9/23/26</a:t>
-            </a:fld>
-            <a:endParaRPr lang="en-US"/>
-          </a:p>
-        </p:txBody>
-      </p:sp>
-      <p:sp>
-        <p:nvSpPr>
-          <p:cNvPr id="6" name="Footer Placeholder 5"/>
+            </a:r>
+            <a:endParaRPr lang="en-US" dirty="0"/>
+          </a:p>
+        </p:txBody>
+      </p:sp>
+      <p:sp>
+        <p:nvSpPr>
+          <p:cNvPr id="9" name="Footer Placeholder 8">
+            <a:extLst>
+              <a:ext uri="{FF2B5EF4-FFF2-40B4-BE49-F238E27FC236}">
+                <a16:creationId xmlns:a16="http://schemas.microsoft.com/office/drawing/2014/main" id="{DB013600-FEC1-B326-2FA5-44299E5168AB}"/>
+              </a:ext>
+            </a:extLst>
+          </p:cNvPr>
           <p:cNvSpPr>
             <a:spLocks noGrp="1"/>
           </p:cNvSpPr>
@@ -3103,13 +3406,23 @@
           <a:bodyPr/>
           <a:lstStyle/>
           <a:p>
-            <a:endParaRPr lang="en-US"/>
-          </a:p>
-        </p:txBody>
-      </p:sp>
-      <p:sp>
-        <p:nvSpPr>
-          <p:cNvPr id="7" name="Slide Number Placeholder 6"/>
+            <a:r>
+              <a:rPr lang="en-US"/>
+              <a:t>© LMU Open Science Center</a:t>
+            </a:r>
+            <a:endParaRPr lang="en-US" dirty="0"/>
+          </a:p>
+        </p:txBody>
+      </p:sp>
+      <p:sp>
+        <p:nvSpPr>
+          <p:cNvPr id="10" name="Slide Number Placeholder 9">
+            <a:extLst>
+              <a:ext uri="{FF2B5EF4-FFF2-40B4-BE49-F238E27FC236}">
+                <a16:creationId xmlns:a16="http://schemas.microsoft.com/office/drawing/2014/main" id="{15CA6B3C-BACA-8A65-B5EF-54019213DBD8}"/>
+              </a:ext>
+            </a:extLst>
+          </p:cNvPr>
           <p:cNvSpPr>
             <a:spLocks noGrp="1"/>
           </p:cNvSpPr>
@@ -3122,11 +3435,17 @@
           <a:bodyPr/>
           <a:lstStyle/>
           <a:p>
+            <a:pPr algn="ctr"/>
+            <a:r>
+              <a:rPr lang="en-US"/>
+              <a:t>Slide </a:t>
+            </a:r>
             <a:fld id="{C5EF2332-01BF-834F-8236-50238282D533}" type="slidenum">
               <a:rPr lang="en-US" smtClean="0"/>
+              <a:pPr algn="ctr"/>
               <a:t>‹#›</a:t>
             </a:fld>
-            <a:endParaRPr lang="en-US"/>
+            <a:endParaRPr lang="en-US" dirty="0"/>
           </a:p>
         </p:txBody>
       </p:sp>
@@ -3177,7 +3496,7 @@
         </p:nvSpPr>
         <p:spPr>
           <a:xfrm>
-            <a:off x="457200" y="205979"/>
+            <a:off x="457200" y="138111"/>
             <a:ext cx="8229600" cy="857250"/>
           </a:xfrm>
           <a:prstGeom prst="rect">
@@ -3270,8 +3589,8 @@
         </p:nvSpPr>
         <p:spPr>
           <a:xfrm>
-            <a:off x="457200" y="4767263"/>
-            <a:ext cx="2133600" cy="273844"/>
+            <a:off x="1995729" y="4774118"/>
+            <a:ext cx="1363851" cy="223839"/>
           </a:xfrm>
           <a:prstGeom prst="rect">
             <a:avLst/>
@@ -3291,10 +3610,11 @@
             </a:lvl1pPr>
           </a:lstStyle>
           <a:p>
-            <a:fld id="{241EB5C9-1307-BA42-ABA2-0BC069CD8E7F}" type="datetimeFigureOut">
-              <a:rPr lang="en-US" smtClean="0"/>
+            <a:pPr algn="ctr"/>
+            <a:r>
+              <a:rPr lang="en-US"/>
               <a:t>9/23/26</a:t>
-            </a:fld>
+            </a:r>
             <a:endParaRPr lang="en-US" dirty="0"/>
           </a:p>
         </p:txBody>
@@ -3311,8 +3631,8 @@
         </p:nvSpPr>
         <p:spPr>
           <a:xfrm>
-            <a:off x="3124200" y="4767263"/>
-            <a:ext cx="2895600" cy="273844"/>
+            <a:off x="3542008" y="4774116"/>
+            <a:ext cx="2059983" cy="223839"/>
           </a:xfrm>
           <a:prstGeom prst="rect">
             <a:avLst/>
@@ -3332,7 +3652,10 @@
             </a:lvl1pPr>
           </a:lstStyle>
           <a:p>
-            <a:endParaRPr lang="en-US"/>
+            <a:r>
+              <a:rPr lang="en-US" dirty="0"/>
+              <a:t>© LMU Open Science Center</a:t>
+            </a:r>
           </a:p>
         </p:txBody>
       </p:sp>
@@ -3348,8 +3671,8 @@
         </p:nvSpPr>
         <p:spPr>
           <a:xfrm>
-            <a:off x="6553200" y="4767263"/>
-            <a:ext cx="2133600" cy="273844"/>
+            <a:off x="5784419" y="4774116"/>
+            <a:ext cx="1363851" cy="223840"/>
           </a:xfrm>
           <a:prstGeom prst="rect">
             <a:avLst/>
@@ -3369,14 +3692,56 @@
             </a:lvl1pPr>
           </a:lstStyle>
           <a:p>
+            <a:pPr algn="ctr"/>
+            <a:r>
+              <a:rPr lang="en-US" dirty="0"/>
+              <a:t>Slide </a:t>
+            </a:r>
             <a:fld id="{C5EF2332-01BF-834F-8236-50238282D533}" type="slidenum">
               <a:rPr lang="en-US" smtClean="0"/>
+              <a:pPr algn="ctr"/>
               <a:t>‹#›</a:t>
             </a:fld>
-            <a:endParaRPr lang="en-US"/>
-          </a:p>
-        </p:txBody>
-      </p:sp>
+            <a:endParaRPr lang="en-US" dirty="0"/>
+          </a:p>
+        </p:txBody>
+      </p:sp>
+      <p:pic>
+        <p:nvPicPr>
+          <p:cNvPr id="8" name="Graphic 7">
+            <a:extLst>
+              <a:ext uri="{FF2B5EF4-FFF2-40B4-BE49-F238E27FC236}">
+                <a16:creationId xmlns:a16="http://schemas.microsoft.com/office/drawing/2014/main" id="{7F87F00D-71B3-247C-7322-26988D4CF4AC}"/>
+              </a:ext>
+            </a:extLst>
+          </p:cNvPr>
+          <p:cNvPicPr>
+            <a:picLocks noChangeAspect="1"/>
+          </p:cNvPicPr>
+          <p:nvPr userDrawn="1"/>
+        </p:nvPicPr>
+        <p:blipFill>
+          <a:blip>
+            <a:extLst>
+              <a:ext uri="{96DAC541-7B7A-43D3-8B79-37D633B846F1}">
+                <asvg:svgBlip xmlns:asvg="http://schemas.microsoft.com/office/drawing/2016/SVG/main" r:embed="rId13"/>
+              </a:ext>
+            </a:extLst>
+          </a:blip>
+          <a:stretch>
+            <a:fillRect/>
+          </a:stretch>
+        </p:blipFill>
+        <p:spPr>
+          <a:xfrm>
+            <a:off x="8134028" y="4725240"/>
+            <a:ext cx="857572" cy="321589"/>
+          </a:xfrm>
+          <a:prstGeom prst="rect">
+            <a:avLst/>
+          </a:prstGeom>
+        </p:spPr>
+      </p:pic>
     </p:spTree>
     <p:extLst>
       <p:ext uri="{BB962C8B-B14F-4D97-AF65-F5344CB8AC3E}">
@@ -3398,6 +3763,7 @@
     <p:sldLayoutId id="2147483658" r:id="rId10"/>
     <p:sldLayoutId id="2147483659" r:id="rId11"/>
   </p:sldLayoutIdLst>
+  <p:hf hdr="0"/>
   <p:txStyles>
     <p:titleStyle>
       <a:lvl1pPr algn="ctr" defTabSz="342900" rtl="0" eaLnBrk="1" latinLnBrk="0" hangingPunct="1">
@@ -3655,6 +4021,37 @@
       </a:lvl9pPr>
     </p:otherStyle>
   </p:txStyles>
+  <p:extLst>
+    <p:ext uri="{27BBF7A9-308A-43DC-89C8-2F10F3537804}">
+      <p15:sldGuideLst xmlns:p15="http://schemas.microsoft.com/office/powerpoint/2012/main">
+        <p15:guide id="1" orient="horz" pos="84" userDrawn="1">
+          <p15:clr>
+            <a:srgbClr val="F26B43"/>
+          </p15:clr>
+        </p15:guide>
+        <p15:guide id="2" pos="96" userDrawn="1">
+          <p15:clr>
+            <a:srgbClr val="F26B43"/>
+          </p15:clr>
+        </p15:guide>
+        <p15:guide id="3" orient="horz" pos="3156" userDrawn="1">
+          <p15:clr>
+            <a:srgbClr val="F26B43"/>
+          </p15:clr>
+        </p15:guide>
+        <p15:guide id="4" pos="5664" userDrawn="1">
+          <p15:clr>
+            <a:srgbClr val="F26B43"/>
+          </p15:clr>
+        </p15:guide>
+        <p15:guide id="5" pos="2880" userDrawn="1">
+          <p15:clr>
+            <a:srgbClr val="F26B43"/>
+          </p15:clr>
+        </p15:guide>
+      </p15:sldGuideLst>
+    </p:ext>
+  </p:extLst>
 </p:sldMaster>
 </file>
 
@@ -3800,6 +4197,106 @@
           </a:p>
         </p:txBody>
       </p:sp>
+      <p:sp>
+        <p:nvSpPr>
+          <p:cNvPr id="4" name="Date Placeholder 3">
+            <a:extLst>
+              <a:ext uri="{FF2B5EF4-FFF2-40B4-BE49-F238E27FC236}">
+                <a16:creationId xmlns:a16="http://schemas.microsoft.com/office/drawing/2014/main" id="{AB402DD3-4C0E-CF95-0659-A1E04D16462A}"/>
+              </a:ext>
+            </a:extLst>
+          </p:cNvPr>
+          <p:cNvSpPr>
+            <a:spLocks noGrp="1"/>
+          </p:cNvSpPr>
+          <p:nvPr>
+            <p:ph type="dt" sz="half" idx="10"/>
+          </p:nvPr>
+        </p:nvSpPr>
+        <p:spPr>
+          <a:xfrm>
+            <a:off x="1995729" y="4774118"/>
+            <a:ext cx="1363851" cy="223839"/>
+          </a:xfrm>
+        </p:spPr>
+        <p:txBody>
+          <a:bodyPr/>
+          <a:lstStyle/>
+          <a:p>
+            <a:r>
+              <a:rPr lang="en-US"/>
+              <a:t>9/23/26</a:t>
+            </a:r>
+          </a:p>
+        </p:txBody>
+      </p:sp>
+      <p:sp>
+        <p:nvSpPr>
+          <p:cNvPr id="5" name="Footer Placeholder 4">
+            <a:extLst>
+              <a:ext uri="{FF2B5EF4-FFF2-40B4-BE49-F238E27FC236}">
+                <a16:creationId xmlns:a16="http://schemas.microsoft.com/office/drawing/2014/main" id="{FDEB2E45-A946-074A-068E-1E42DFCDD28C}"/>
+              </a:ext>
+            </a:extLst>
+          </p:cNvPr>
+          <p:cNvSpPr>
+            <a:spLocks noGrp="1"/>
+          </p:cNvSpPr>
+          <p:nvPr>
+            <p:ph type="ftr" sz="quarter" idx="11"/>
+          </p:nvPr>
+        </p:nvSpPr>
+        <p:spPr>
+          <a:xfrm>
+            <a:off x="3542008" y="4774116"/>
+            <a:ext cx="2059983" cy="223839"/>
+          </a:xfrm>
+        </p:spPr>
+        <p:txBody>
+          <a:bodyPr/>
+          <a:lstStyle/>
+          <a:p>
+            <a:r>
+              <a:rPr lang="en-US"/>
+              <a:t>© LMU Open Science Center</a:t>
+            </a:r>
+          </a:p>
+        </p:txBody>
+      </p:sp>
+      <p:sp>
+        <p:nvSpPr>
+          <p:cNvPr id="6" name="Slide Number Placeholder 5">
+            <a:extLst>
+              <a:ext uri="{FF2B5EF4-FFF2-40B4-BE49-F238E27FC236}">
+                <a16:creationId xmlns:a16="http://schemas.microsoft.com/office/drawing/2014/main" id="{997FCDA6-E006-238B-CCC4-EE3B425DB260}"/>
+              </a:ext>
+            </a:extLst>
+          </p:cNvPr>
+          <p:cNvSpPr>
+            <a:spLocks noGrp="1"/>
+          </p:cNvSpPr>
+          <p:nvPr>
+            <p:ph type="sldNum" sz="quarter" idx="12"/>
+          </p:nvPr>
+        </p:nvSpPr>
+        <p:spPr>
+          <a:xfrm>
+            <a:off x="5784419" y="4774116"/>
+            <a:ext cx="1363851" cy="223840"/>
+          </a:xfrm>
+        </p:spPr>
+        <p:txBody>
+          <a:bodyPr/>
+          <a:lstStyle/>
+          <a:p>
+            <a:fld id="{C5EF2332-01BF-834F-8236-50238282D533}" type="slidenum">
+              <a:rPr lang="en-US" smtClean="0"/>
+              <a:t>2</a:t>
+            </a:fld>
+            <a:endParaRPr lang="en-US"/>
+          </a:p>
+        </p:txBody>
+      </p:sp>
     </p:spTree>
     <p:extLst>
       <p:ext uri="{BB962C8B-B14F-4D97-AF65-F5344CB8AC3E}">
@@ -3871,6 +4368,106 @@
           </a:p>
         </p:txBody>
       </p:sp>
+      <p:sp>
+        <p:nvSpPr>
+          <p:cNvPr id="4" name="Date Placeholder 3">
+            <a:extLst>
+              <a:ext uri="{FF2B5EF4-FFF2-40B4-BE49-F238E27FC236}">
+                <a16:creationId xmlns:a16="http://schemas.microsoft.com/office/drawing/2014/main" id="{9B5354E8-DE02-E9BD-65EC-F8FE5267D478}"/>
+              </a:ext>
+            </a:extLst>
+          </p:cNvPr>
+          <p:cNvSpPr>
+            <a:spLocks noGrp="1"/>
+          </p:cNvSpPr>
+          <p:nvPr>
+            <p:ph type="dt" sz="half" idx="10"/>
+          </p:nvPr>
+        </p:nvSpPr>
+        <p:spPr>
+          <a:xfrm>
+            <a:off x="1995729" y="4774118"/>
+            <a:ext cx="1363851" cy="223839"/>
+          </a:xfrm>
+        </p:spPr>
+        <p:txBody>
+          <a:bodyPr/>
+          <a:lstStyle/>
+          <a:p>
+            <a:r>
+              <a:rPr lang="en-US"/>
+              <a:t>9/23/26</a:t>
+            </a:r>
+          </a:p>
+        </p:txBody>
+      </p:sp>
+      <p:sp>
+        <p:nvSpPr>
+          <p:cNvPr id="5" name="Footer Placeholder 4">
+            <a:extLst>
+              <a:ext uri="{FF2B5EF4-FFF2-40B4-BE49-F238E27FC236}">
+                <a16:creationId xmlns:a16="http://schemas.microsoft.com/office/drawing/2014/main" id="{80133233-FBA7-8299-FED0-18A3AF792AD4}"/>
+              </a:ext>
+            </a:extLst>
+          </p:cNvPr>
+          <p:cNvSpPr>
+            <a:spLocks noGrp="1"/>
+          </p:cNvSpPr>
+          <p:nvPr>
+            <p:ph type="ftr" sz="quarter" idx="11"/>
+          </p:nvPr>
+        </p:nvSpPr>
+        <p:spPr>
+          <a:xfrm>
+            <a:off x="3542008" y="4774116"/>
+            <a:ext cx="2059983" cy="223839"/>
+          </a:xfrm>
+        </p:spPr>
+        <p:txBody>
+          <a:bodyPr/>
+          <a:lstStyle/>
+          <a:p>
+            <a:r>
+              <a:rPr lang="en-US"/>
+              <a:t>© LMU Open Science Center</a:t>
+            </a:r>
+          </a:p>
+        </p:txBody>
+      </p:sp>
+      <p:sp>
+        <p:nvSpPr>
+          <p:cNvPr id="6" name="Slide Number Placeholder 5">
+            <a:extLst>
+              <a:ext uri="{FF2B5EF4-FFF2-40B4-BE49-F238E27FC236}">
+                <a16:creationId xmlns:a16="http://schemas.microsoft.com/office/drawing/2014/main" id="{C161F541-912D-071C-AD06-98F2B3702919}"/>
+              </a:ext>
+            </a:extLst>
+          </p:cNvPr>
+          <p:cNvSpPr>
+            <a:spLocks noGrp="1"/>
+          </p:cNvSpPr>
+          <p:nvPr>
+            <p:ph type="sldNum" sz="quarter" idx="12"/>
+          </p:nvPr>
+        </p:nvSpPr>
+        <p:spPr>
+          <a:xfrm>
+            <a:off x="5784419" y="4774116"/>
+            <a:ext cx="1363851" cy="223840"/>
+          </a:xfrm>
+        </p:spPr>
+        <p:txBody>
+          <a:bodyPr/>
+          <a:lstStyle/>
+          <a:p>
+            <a:fld id="{C5EF2332-01BF-834F-8236-50238282D533}" type="slidenum">
+              <a:rPr lang="en-US" smtClean="0"/>
+              <a:t>3</a:t>
+            </a:fld>
+            <a:endParaRPr lang="en-US"/>
+          </a:p>
+        </p:txBody>
+      </p:sp>
     </p:spTree>
     <p:extLst>
       <p:ext uri="{BB962C8B-B14F-4D97-AF65-F5344CB8AC3E}">
@@ -3975,6 +4572,106 @@
               <a:rPr lang="en-US" dirty="0"/>
               <a:t>Some content on the right.</a:t>
             </a:r>
+          </a:p>
+        </p:txBody>
+      </p:sp>
+      <p:sp>
+        <p:nvSpPr>
+          <p:cNvPr id="2" name="Date Placeholder 1">
+            <a:extLst>
+              <a:ext uri="{FF2B5EF4-FFF2-40B4-BE49-F238E27FC236}">
+                <a16:creationId xmlns:a16="http://schemas.microsoft.com/office/drawing/2014/main" id="{8C5467AE-143E-1232-2977-1EE7C6533511}"/>
+              </a:ext>
+            </a:extLst>
+          </p:cNvPr>
+          <p:cNvSpPr>
+            <a:spLocks noGrp="1"/>
+          </p:cNvSpPr>
+          <p:nvPr>
+            <p:ph type="dt" sz="half" idx="10"/>
+          </p:nvPr>
+        </p:nvSpPr>
+        <p:spPr>
+          <a:xfrm>
+            <a:off x="1995729" y="4774118"/>
+            <a:ext cx="1363851" cy="223839"/>
+          </a:xfrm>
+        </p:spPr>
+        <p:txBody>
+          <a:bodyPr/>
+          <a:lstStyle/>
+          <a:p>
+            <a:r>
+              <a:rPr lang="en-US"/>
+              <a:t>9/23/26</a:t>
+            </a:r>
+          </a:p>
+        </p:txBody>
+      </p:sp>
+      <p:sp>
+        <p:nvSpPr>
+          <p:cNvPr id="3" name="Footer Placeholder 2">
+            <a:extLst>
+              <a:ext uri="{FF2B5EF4-FFF2-40B4-BE49-F238E27FC236}">
+                <a16:creationId xmlns:a16="http://schemas.microsoft.com/office/drawing/2014/main" id="{F951179C-A0C6-853A-DDDD-EA559AD4D93F}"/>
+              </a:ext>
+            </a:extLst>
+          </p:cNvPr>
+          <p:cNvSpPr>
+            <a:spLocks noGrp="1"/>
+          </p:cNvSpPr>
+          <p:nvPr>
+            <p:ph type="ftr" sz="quarter" idx="11"/>
+          </p:nvPr>
+        </p:nvSpPr>
+        <p:spPr>
+          <a:xfrm>
+            <a:off x="3542008" y="4774116"/>
+            <a:ext cx="2059983" cy="223839"/>
+          </a:xfrm>
+        </p:spPr>
+        <p:txBody>
+          <a:bodyPr/>
+          <a:lstStyle/>
+          <a:p>
+            <a:r>
+              <a:rPr lang="en-US"/>
+              <a:t>© LMU Open Science Center</a:t>
+            </a:r>
+          </a:p>
+        </p:txBody>
+      </p:sp>
+      <p:sp>
+        <p:nvSpPr>
+          <p:cNvPr id="7" name="Slide Number Placeholder 6">
+            <a:extLst>
+              <a:ext uri="{FF2B5EF4-FFF2-40B4-BE49-F238E27FC236}">
+                <a16:creationId xmlns:a16="http://schemas.microsoft.com/office/drawing/2014/main" id="{6857DA2F-8FDB-880B-3B9A-47D426F02D03}"/>
+              </a:ext>
+            </a:extLst>
+          </p:cNvPr>
+          <p:cNvSpPr>
+            <a:spLocks noGrp="1"/>
+          </p:cNvSpPr>
+          <p:nvPr>
+            <p:ph type="sldNum" sz="quarter" idx="12"/>
+          </p:nvPr>
+        </p:nvSpPr>
+        <p:spPr>
+          <a:xfrm>
+            <a:off x="5784419" y="4774116"/>
+            <a:ext cx="1363851" cy="223840"/>
+          </a:xfrm>
+        </p:spPr>
+        <p:txBody>
+          <a:bodyPr/>
+          <a:lstStyle/>
+          <a:p>
+            <a:fld id="{C5EF2332-01BF-834F-8236-50238282D533}" type="slidenum">
+              <a:rPr lang="en-US" smtClean="0"/>
+              <a:t>4</a:t>
+            </a:fld>
+            <a:endParaRPr lang="en-US"/>
           </a:p>
         </p:txBody>
       </p:sp>

</xml_diff>

<commit_message>
Add green side bar to all slides but title slide
</commit_message>
<xml_diff>
--- a/working-template.pptx
+++ b/working-template.pptx
@@ -1154,6 +1154,56 @@
           </a:p>
         </p:txBody>
       </p:sp>
+      <p:sp>
+        <p:nvSpPr>
+          <p:cNvPr id="4" name="Rectangle 3">
+            <a:extLst>
+              <a:ext uri="{FF2B5EF4-FFF2-40B4-BE49-F238E27FC236}">
+                <a16:creationId xmlns:a16="http://schemas.microsoft.com/office/drawing/2014/main" id="{8AB907D2-6A5F-9B5B-F5B4-C4FEA6389021}"/>
+              </a:ext>
+            </a:extLst>
+          </p:cNvPr>
+          <p:cNvSpPr/>
+          <p:nvPr userDrawn="1"/>
+        </p:nvSpPr>
+        <p:spPr>
+          <a:xfrm>
+            <a:off x="8991600" y="0"/>
+            <a:ext cx="152400" cy="5143500"/>
+          </a:xfrm>
+          <a:prstGeom prst="rect">
+            <a:avLst/>
+          </a:prstGeom>
+          <a:solidFill>
+            <a:srgbClr val="008B2D"/>
+          </a:solidFill>
+          <a:ln>
+            <a:noFill/>
+          </a:ln>
+        </p:spPr>
+        <p:style>
+          <a:lnRef idx="1">
+            <a:schemeClr val="accent1"/>
+          </a:lnRef>
+          <a:fillRef idx="3">
+            <a:schemeClr val="accent1"/>
+          </a:fillRef>
+          <a:effectRef idx="2">
+            <a:schemeClr val="accent1"/>
+          </a:effectRef>
+          <a:fontRef idx="minor">
+            <a:schemeClr val="lt1"/>
+          </a:fontRef>
+        </p:style>
+        <p:txBody>
+          <a:bodyPr rtlCol="0" anchor="ctr"/>
+          <a:lstStyle/>
+          <a:p>
+            <a:pPr algn="ctr"/>
+            <a:endParaRPr lang="en-US"/>
+          </a:p>
+        </p:txBody>
+      </p:sp>
     </p:spTree>
     <p:extLst>
       <p:ext uri="{BB962C8B-B14F-4D97-AF65-F5344CB8AC3E}">
@@ -1361,6 +1411,56 @@
           </a:p>
         </p:txBody>
       </p:sp>
+      <p:sp>
+        <p:nvSpPr>
+          <p:cNvPr id="4" name="Rectangle 3">
+            <a:extLst>
+              <a:ext uri="{FF2B5EF4-FFF2-40B4-BE49-F238E27FC236}">
+                <a16:creationId xmlns:a16="http://schemas.microsoft.com/office/drawing/2014/main" id="{304BE907-8A33-EAC8-E40E-042F62D8A32D}"/>
+              </a:ext>
+            </a:extLst>
+          </p:cNvPr>
+          <p:cNvSpPr/>
+          <p:nvPr userDrawn="1"/>
+        </p:nvSpPr>
+        <p:spPr>
+          <a:xfrm>
+            <a:off x="8991600" y="0"/>
+            <a:ext cx="152400" cy="5143500"/>
+          </a:xfrm>
+          <a:prstGeom prst="rect">
+            <a:avLst/>
+          </a:prstGeom>
+          <a:solidFill>
+            <a:srgbClr val="008B2D"/>
+          </a:solidFill>
+          <a:ln>
+            <a:noFill/>
+          </a:ln>
+        </p:spPr>
+        <p:style>
+          <a:lnRef idx="1">
+            <a:schemeClr val="accent1"/>
+          </a:lnRef>
+          <a:fillRef idx="3">
+            <a:schemeClr val="accent1"/>
+          </a:fillRef>
+          <a:effectRef idx="2">
+            <a:schemeClr val="accent1"/>
+          </a:effectRef>
+          <a:fontRef idx="minor">
+            <a:schemeClr val="lt1"/>
+          </a:fontRef>
+        </p:style>
+        <p:txBody>
+          <a:bodyPr rtlCol="0" anchor="ctr"/>
+          <a:lstStyle/>
+          <a:p>
+            <a:pPr algn="ctr"/>
+            <a:endParaRPr lang="en-US"/>
+          </a:p>
+        </p:txBody>
+      </p:sp>
     </p:spTree>
     <p:extLst>
       <p:ext uri="{BB962C8B-B14F-4D97-AF65-F5344CB8AC3E}">
@@ -1558,6 +1658,56 @@
           </a:p>
         </p:txBody>
       </p:sp>
+      <p:sp>
+        <p:nvSpPr>
+          <p:cNvPr id="4" name="Rectangle 3">
+            <a:extLst>
+              <a:ext uri="{FF2B5EF4-FFF2-40B4-BE49-F238E27FC236}">
+                <a16:creationId xmlns:a16="http://schemas.microsoft.com/office/drawing/2014/main" id="{7695D47B-82BE-FA8D-B3D0-43C1EF89F98F}"/>
+              </a:ext>
+            </a:extLst>
+          </p:cNvPr>
+          <p:cNvSpPr/>
+          <p:nvPr userDrawn="1"/>
+        </p:nvSpPr>
+        <p:spPr>
+          <a:xfrm>
+            <a:off x="8991600" y="0"/>
+            <a:ext cx="152400" cy="5143500"/>
+          </a:xfrm>
+          <a:prstGeom prst="rect">
+            <a:avLst/>
+          </a:prstGeom>
+          <a:solidFill>
+            <a:srgbClr val="008B2D"/>
+          </a:solidFill>
+          <a:ln>
+            <a:noFill/>
+          </a:ln>
+        </p:spPr>
+        <p:style>
+          <a:lnRef idx="1">
+            <a:schemeClr val="accent1"/>
+          </a:lnRef>
+          <a:fillRef idx="3">
+            <a:schemeClr val="accent1"/>
+          </a:fillRef>
+          <a:effectRef idx="2">
+            <a:schemeClr val="accent1"/>
+          </a:effectRef>
+          <a:fontRef idx="minor">
+            <a:schemeClr val="lt1"/>
+          </a:fontRef>
+        </p:style>
+        <p:txBody>
+          <a:bodyPr rtlCol="0" anchor="ctr"/>
+          <a:lstStyle/>
+          <a:p>
+            <a:pPr algn="ctr"/>
+            <a:endParaRPr lang="en-US"/>
+          </a:p>
+        </p:txBody>
+      </p:sp>
     </p:spTree>
     <p:extLst>
       <p:ext uri="{BB962C8B-B14F-4D97-AF65-F5344CB8AC3E}">
@@ -1832,6 +1982,56 @@
           </a:p>
         </p:txBody>
       </p:sp>
+      <p:sp>
+        <p:nvSpPr>
+          <p:cNvPr id="4" name="Rectangle 3">
+            <a:extLst>
+              <a:ext uri="{FF2B5EF4-FFF2-40B4-BE49-F238E27FC236}">
+                <a16:creationId xmlns:a16="http://schemas.microsoft.com/office/drawing/2014/main" id="{64D8B8CE-DBC2-402F-F776-7642508B65A2}"/>
+              </a:ext>
+            </a:extLst>
+          </p:cNvPr>
+          <p:cNvSpPr/>
+          <p:nvPr userDrawn="1"/>
+        </p:nvSpPr>
+        <p:spPr>
+          <a:xfrm>
+            <a:off x="8991600" y="0"/>
+            <a:ext cx="152400" cy="5143500"/>
+          </a:xfrm>
+          <a:prstGeom prst="rect">
+            <a:avLst/>
+          </a:prstGeom>
+          <a:solidFill>
+            <a:srgbClr val="008B2D"/>
+          </a:solidFill>
+          <a:ln>
+            <a:noFill/>
+          </a:ln>
+        </p:spPr>
+        <p:style>
+          <a:lnRef idx="1">
+            <a:schemeClr val="accent1"/>
+          </a:lnRef>
+          <a:fillRef idx="3">
+            <a:schemeClr val="accent1"/>
+          </a:fillRef>
+          <a:effectRef idx="2">
+            <a:schemeClr val="accent1"/>
+          </a:effectRef>
+          <a:fontRef idx="minor">
+            <a:schemeClr val="lt1"/>
+          </a:fontRef>
+        </p:style>
+        <p:txBody>
+          <a:bodyPr rtlCol="0" anchor="ctr"/>
+          <a:lstStyle/>
+          <a:p>
+            <a:pPr algn="ctr"/>
+            <a:endParaRPr lang="en-US"/>
+          </a:p>
+        </p:txBody>
+      </p:sp>
     </p:spTree>
     <p:extLst>
       <p:ext uri="{BB962C8B-B14F-4D97-AF65-F5344CB8AC3E}">
@@ -2146,6 +2346,56 @@
           </a:p>
         </p:txBody>
       </p:sp>
+      <p:sp>
+        <p:nvSpPr>
+          <p:cNvPr id="5" name="Rectangle 4">
+            <a:extLst>
+              <a:ext uri="{FF2B5EF4-FFF2-40B4-BE49-F238E27FC236}">
+                <a16:creationId xmlns:a16="http://schemas.microsoft.com/office/drawing/2014/main" id="{964C6C71-8D4C-B542-9542-DE3F868C8BCD}"/>
+              </a:ext>
+            </a:extLst>
+          </p:cNvPr>
+          <p:cNvSpPr/>
+          <p:nvPr userDrawn="1"/>
+        </p:nvSpPr>
+        <p:spPr>
+          <a:xfrm>
+            <a:off x="8991600" y="0"/>
+            <a:ext cx="152400" cy="5143500"/>
+          </a:xfrm>
+          <a:prstGeom prst="rect">
+            <a:avLst/>
+          </a:prstGeom>
+          <a:solidFill>
+            <a:srgbClr val="008B2D"/>
+          </a:solidFill>
+          <a:ln>
+            <a:noFill/>
+          </a:ln>
+        </p:spPr>
+        <p:style>
+          <a:lnRef idx="1">
+            <a:schemeClr val="accent1"/>
+          </a:lnRef>
+          <a:fillRef idx="3">
+            <a:schemeClr val="accent1"/>
+          </a:fillRef>
+          <a:effectRef idx="2">
+            <a:schemeClr val="accent1"/>
+          </a:effectRef>
+          <a:fontRef idx="minor">
+            <a:schemeClr val="lt1"/>
+          </a:fontRef>
+        </p:style>
+        <p:txBody>
+          <a:bodyPr rtlCol="0" anchor="ctr"/>
+          <a:lstStyle/>
+          <a:p>
+            <a:pPr algn="ctr"/>
+            <a:endParaRPr lang="en-US"/>
+          </a:p>
+        </p:txBody>
+      </p:sp>
     </p:spTree>
     <p:extLst>
       <p:ext uri="{BB962C8B-B14F-4D97-AF65-F5344CB8AC3E}">
@@ -2594,6 +2844,56 @@
           </a:p>
         </p:txBody>
       </p:sp>
+      <p:sp>
+        <p:nvSpPr>
+          <p:cNvPr id="7" name="Rectangle 6">
+            <a:extLst>
+              <a:ext uri="{FF2B5EF4-FFF2-40B4-BE49-F238E27FC236}">
+                <a16:creationId xmlns:a16="http://schemas.microsoft.com/office/drawing/2014/main" id="{178081C7-8D63-717B-E81C-FB6B04A7D54D}"/>
+              </a:ext>
+            </a:extLst>
+          </p:cNvPr>
+          <p:cNvSpPr/>
+          <p:nvPr userDrawn="1"/>
+        </p:nvSpPr>
+        <p:spPr>
+          <a:xfrm>
+            <a:off x="8991600" y="0"/>
+            <a:ext cx="152400" cy="5143500"/>
+          </a:xfrm>
+          <a:prstGeom prst="rect">
+            <a:avLst/>
+          </a:prstGeom>
+          <a:solidFill>
+            <a:srgbClr val="008B2D"/>
+          </a:solidFill>
+          <a:ln>
+            <a:noFill/>
+          </a:ln>
+        </p:spPr>
+        <p:style>
+          <a:lnRef idx="1">
+            <a:schemeClr val="accent1"/>
+          </a:lnRef>
+          <a:fillRef idx="3">
+            <a:schemeClr val="accent1"/>
+          </a:fillRef>
+          <a:effectRef idx="2">
+            <a:schemeClr val="accent1"/>
+          </a:effectRef>
+          <a:fontRef idx="minor">
+            <a:schemeClr val="lt1"/>
+          </a:fontRef>
+        </p:style>
+        <p:txBody>
+          <a:bodyPr rtlCol="0" anchor="ctr"/>
+          <a:lstStyle/>
+          <a:p>
+            <a:pPr algn="ctr"/>
+            <a:endParaRPr lang="en-US"/>
+          </a:p>
+        </p:txBody>
+      </p:sp>
     </p:spTree>
     <p:extLst>
       <p:ext uri="{BB962C8B-B14F-4D97-AF65-F5344CB8AC3E}">
@@ -2740,6 +3040,56 @@
           </a:p>
         </p:txBody>
       </p:sp>
+      <p:sp>
+        <p:nvSpPr>
+          <p:cNvPr id="3" name="Rectangle 2">
+            <a:extLst>
+              <a:ext uri="{FF2B5EF4-FFF2-40B4-BE49-F238E27FC236}">
+                <a16:creationId xmlns:a16="http://schemas.microsoft.com/office/drawing/2014/main" id="{BCEB6D96-52B9-49DF-A40F-D3028B8FC97F}"/>
+              </a:ext>
+            </a:extLst>
+          </p:cNvPr>
+          <p:cNvSpPr/>
+          <p:nvPr userDrawn="1"/>
+        </p:nvSpPr>
+        <p:spPr>
+          <a:xfrm>
+            <a:off x="8991600" y="0"/>
+            <a:ext cx="152400" cy="5143500"/>
+          </a:xfrm>
+          <a:prstGeom prst="rect">
+            <a:avLst/>
+          </a:prstGeom>
+          <a:solidFill>
+            <a:srgbClr val="008B2D"/>
+          </a:solidFill>
+          <a:ln>
+            <a:noFill/>
+          </a:ln>
+        </p:spPr>
+        <p:style>
+          <a:lnRef idx="1">
+            <a:schemeClr val="accent1"/>
+          </a:lnRef>
+          <a:fillRef idx="3">
+            <a:schemeClr val="accent1"/>
+          </a:fillRef>
+          <a:effectRef idx="2">
+            <a:schemeClr val="accent1"/>
+          </a:effectRef>
+          <a:fontRef idx="minor">
+            <a:schemeClr val="lt1"/>
+          </a:fontRef>
+        </p:style>
+        <p:txBody>
+          <a:bodyPr rtlCol="0" anchor="ctr"/>
+          <a:lstStyle/>
+          <a:p>
+            <a:pPr algn="ctr"/>
+            <a:endParaRPr lang="en-US"/>
+          </a:p>
+        </p:txBody>
+      </p:sp>
     </p:spTree>
     <p:extLst>
       <p:ext uri="{BB962C8B-B14F-4D97-AF65-F5344CB8AC3E}">
@@ -2864,6 +3214,56 @@
           </a:p>
         </p:txBody>
       </p:sp>
+      <p:sp>
+        <p:nvSpPr>
+          <p:cNvPr id="2" name="Rectangle 1">
+            <a:extLst>
+              <a:ext uri="{FF2B5EF4-FFF2-40B4-BE49-F238E27FC236}">
+                <a16:creationId xmlns:a16="http://schemas.microsoft.com/office/drawing/2014/main" id="{7EF01941-7737-2934-6952-CCA6B638ACA0}"/>
+              </a:ext>
+            </a:extLst>
+          </p:cNvPr>
+          <p:cNvSpPr/>
+          <p:nvPr userDrawn="1"/>
+        </p:nvSpPr>
+        <p:spPr>
+          <a:xfrm>
+            <a:off x="8991600" y="0"/>
+            <a:ext cx="152400" cy="5143500"/>
+          </a:xfrm>
+          <a:prstGeom prst="rect">
+            <a:avLst/>
+          </a:prstGeom>
+          <a:solidFill>
+            <a:srgbClr val="008B2D"/>
+          </a:solidFill>
+          <a:ln>
+            <a:noFill/>
+          </a:ln>
+        </p:spPr>
+        <p:style>
+          <a:lnRef idx="1">
+            <a:schemeClr val="accent1"/>
+          </a:lnRef>
+          <a:fillRef idx="3">
+            <a:schemeClr val="accent1"/>
+          </a:fillRef>
+          <a:effectRef idx="2">
+            <a:schemeClr val="accent1"/>
+          </a:effectRef>
+          <a:fontRef idx="minor">
+            <a:schemeClr val="lt1"/>
+          </a:fontRef>
+        </p:style>
+        <p:txBody>
+          <a:bodyPr rtlCol="0" anchor="ctr"/>
+          <a:lstStyle/>
+          <a:p>
+            <a:pPr algn="ctr"/>
+            <a:endParaRPr lang="en-US"/>
+          </a:p>
+        </p:txBody>
+      </p:sp>
     </p:spTree>
     <p:extLst>
       <p:ext uri="{BB962C8B-B14F-4D97-AF65-F5344CB8AC3E}">
@@ -3168,6 +3568,56 @@
           </a:p>
         </p:txBody>
       </p:sp>
+      <p:sp>
+        <p:nvSpPr>
+          <p:cNvPr id="5" name="Rectangle 4">
+            <a:extLst>
+              <a:ext uri="{FF2B5EF4-FFF2-40B4-BE49-F238E27FC236}">
+                <a16:creationId xmlns:a16="http://schemas.microsoft.com/office/drawing/2014/main" id="{2F13ACB6-AD35-166A-7095-CE78FB7C65DC}"/>
+              </a:ext>
+            </a:extLst>
+          </p:cNvPr>
+          <p:cNvSpPr/>
+          <p:nvPr userDrawn="1"/>
+        </p:nvSpPr>
+        <p:spPr>
+          <a:xfrm>
+            <a:off x="8991600" y="0"/>
+            <a:ext cx="152400" cy="5143500"/>
+          </a:xfrm>
+          <a:prstGeom prst="rect">
+            <a:avLst/>
+          </a:prstGeom>
+          <a:solidFill>
+            <a:srgbClr val="008B2D"/>
+          </a:solidFill>
+          <a:ln>
+            <a:noFill/>
+          </a:ln>
+        </p:spPr>
+        <p:style>
+          <a:lnRef idx="1">
+            <a:schemeClr val="accent1"/>
+          </a:lnRef>
+          <a:fillRef idx="3">
+            <a:schemeClr val="accent1"/>
+          </a:fillRef>
+          <a:effectRef idx="2">
+            <a:schemeClr val="accent1"/>
+          </a:effectRef>
+          <a:fontRef idx="minor">
+            <a:schemeClr val="lt1"/>
+          </a:fontRef>
+        </p:style>
+        <p:txBody>
+          <a:bodyPr rtlCol="0" anchor="ctr"/>
+          <a:lstStyle/>
+          <a:p>
+            <a:pPr algn="ctr"/>
+            <a:endParaRPr lang="en-US"/>
+          </a:p>
+        </p:txBody>
+      </p:sp>
     </p:spTree>
     <p:extLst>
       <p:ext uri="{BB962C8B-B14F-4D97-AF65-F5344CB8AC3E}">
@@ -3446,6 +3896,56 @@
               <a:t>‹#›</a:t>
             </a:fld>
             <a:endParaRPr lang="en-US" dirty="0"/>
+          </a:p>
+        </p:txBody>
+      </p:sp>
+      <p:sp>
+        <p:nvSpPr>
+          <p:cNvPr id="5" name="Rectangle 4">
+            <a:extLst>
+              <a:ext uri="{FF2B5EF4-FFF2-40B4-BE49-F238E27FC236}">
+                <a16:creationId xmlns:a16="http://schemas.microsoft.com/office/drawing/2014/main" id="{31D6DC9D-A966-EA21-E561-10535CC769C8}"/>
+              </a:ext>
+            </a:extLst>
+          </p:cNvPr>
+          <p:cNvSpPr/>
+          <p:nvPr userDrawn="1"/>
+        </p:nvSpPr>
+        <p:spPr>
+          <a:xfrm>
+            <a:off x="8991600" y="0"/>
+            <a:ext cx="152400" cy="5143500"/>
+          </a:xfrm>
+          <a:prstGeom prst="rect">
+            <a:avLst/>
+          </a:prstGeom>
+          <a:solidFill>
+            <a:srgbClr val="008B2D"/>
+          </a:solidFill>
+          <a:ln>
+            <a:noFill/>
+          </a:ln>
+        </p:spPr>
+        <p:style>
+          <a:lnRef idx="1">
+            <a:schemeClr val="accent1"/>
+          </a:lnRef>
+          <a:fillRef idx="3">
+            <a:schemeClr val="accent1"/>
+          </a:fillRef>
+          <a:effectRef idx="2">
+            <a:schemeClr val="accent1"/>
+          </a:effectRef>
+          <a:fontRef idx="minor">
+            <a:schemeClr val="lt1"/>
+          </a:fontRef>
+        </p:style>
+        <p:txBody>
+          <a:bodyPr rtlCol="0" anchor="ctr"/>
+          <a:lstStyle/>
+          <a:p>
+            <a:pPr algn="ctr"/>
+            <a:endParaRPr lang="en-US"/>
           </a:p>
         </p:txBody>
       </p:sp>

</xml_diff>

<commit_message>
Adjust section slide text size
</commit_message>
<xml_diff>
--- a/working-template.pptx
+++ b/working-template.pptx
@@ -1745,12 +1745,12 @@
             <a:spLocks noGrp="1"/>
           </p:cNvSpPr>
           <p:nvPr>
-            <p:ph type="title"/>
+            <p:ph type="title" hasCustomPrompt="1"/>
           </p:nvPr>
         </p:nvSpPr>
         <p:spPr>
           <a:xfrm>
-            <a:off x="722313" y="3305176"/>
+            <a:off x="722313" y="2375222"/>
             <a:ext cx="7772400" cy="1021556"/>
           </a:xfrm>
         </p:spPr>
@@ -1758,13 +1758,13 @@
           <a:bodyPr anchor="t"/>
           <a:lstStyle>
             <a:lvl1pPr algn="l">
-              <a:defRPr sz="3000" b="1" cap="all"/>
+              <a:defRPr sz="2800" b="1" cap="none"/>
             </a:lvl1pPr>
           </a:lstStyle>
           <a:p>
             <a:r>
-              <a:rPr lang="en-US"/>
-              <a:t>Click to edit Master title style</a:t>
+              <a:rPr lang="en-US" dirty="0"/>
+              <a:t>Click to edit master title style</a:t>
             </a:r>
           </a:p>
         </p:txBody>
@@ -1781,7 +1781,7 @@
         </p:nvSpPr>
         <p:spPr>
           <a:xfrm>
-            <a:off x="722313" y="2180035"/>
+            <a:off x="722313" y="1208909"/>
             <a:ext cx="7772400" cy="1125140"/>
           </a:xfrm>
         </p:spPr>
@@ -2078,7 +2078,7 @@
           <a:lstStyle/>
           <a:p>
             <a:r>
-              <a:rPr lang="en-US"/>
+              <a:rPr lang="en-US" dirty="0"/>
               <a:t>Click to edit Master title style</a:t>
             </a:r>
           </a:p>
@@ -2511,7 +2511,7 @@
           <a:p>
             <a:pPr lvl="0"/>
             <a:r>
-              <a:rPr lang="en-US"/>
+              <a:rPr lang="en-US" dirty="0"/>
               <a:t>Click to edit Master text styles</a:t>
             </a:r>
           </a:p>

</xml_diff>

<commit_message>
Change font style to Aptos
</commit_message>
<xml_diff>
--- a/working-template.pptx
+++ b/working-template.pptx
@@ -841,7 +841,7 @@
           </a:lstStyle>
           <a:p>
             <a:r>
-              <a:rPr lang="en-US"/>
+              <a:rPr lang="en-US" dirty="0"/>
               <a:t>Click to edit Master subtitle style</a:t>
             </a:r>
           </a:p>
@@ -1530,35 +1530,35 @@
           <a:p>
             <a:pPr lvl="0"/>
             <a:r>
-              <a:rPr lang="en-US"/>
+              <a:rPr lang="en-US" dirty="0"/>
               <a:t>Click to edit Master text styles</a:t>
             </a:r>
           </a:p>
           <a:p>
             <a:pPr lvl="1"/>
             <a:r>
-              <a:rPr lang="en-US"/>
+              <a:rPr lang="en-US" dirty="0"/>
               <a:t>Second level</a:t>
             </a:r>
           </a:p>
           <a:p>
             <a:pPr lvl="2"/>
             <a:r>
-              <a:rPr lang="en-US"/>
+              <a:rPr lang="en-US" dirty="0"/>
               <a:t>Third level</a:t>
             </a:r>
           </a:p>
           <a:p>
             <a:pPr lvl="3"/>
             <a:r>
-              <a:rPr lang="en-US"/>
+              <a:rPr lang="en-US" dirty="0"/>
               <a:t>Fourth level</a:t>
             </a:r>
           </a:p>
           <a:p>
             <a:pPr lvl="4"/>
             <a:r>
-              <a:rPr lang="en-US"/>
+              <a:rPr lang="en-US" dirty="0"/>
               <a:t>Fifth level</a:t>
             </a:r>
           </a:p>
@@ -4271,11 +4271,11 @@
           <a:spcPct val="0"/>
         </a:spcBef>
         <a:buNone/>
-        <a:defRPr sz="2800" kern="1200">
+        <a:defRPr sz="2800" b="1" i="0" kern="1200">
           <a:solidFill>
             <a:schemeClr val="tx1"/>
           </a:solidFill>
-          <a:latin typeface="Verdana" panose="020B0604030504040204" pitchFamily="34" charset="0"/>
+          <a:latin typeface="Aptos ExtraBold" panose="020B0004020202020204" pitchFamily="34" charset="0"/>
           <a:ea typeface="Verdana" panose="020B0604030504040204" pitchFamily="34" charset="0"/>
           <a:cs typeface="Verdana" panose="020B0604030504040204" pitchFamily="34" charset="0"/>
         </a:defRPr>
@@ -4288,11 +4288,11 @@
         </a:spcBef>
         <a:buFont typeface="Arial" panose="020B0604020202020204" pitchFamily="34" charset="0"/>
         <a:buChar char="•"/>
-        <a:defRPr sz="2000" b="0" i="0" kern="1200">
+        <a:defRPr sz="1800" b="0" i="0" kern="1200">
           <a:solidFill>
             <a:schemeClr val="tx1"/>
           </a:solidFill>
-          <a:latin typeface="Verdana" panose="020B0604030504040204" pitchFamily="34" charset="0"/>
+          <a:latin typeface="Aptos" panose="020B0004020202020204" pitchFamily="34" charset="0"/>
           <a:ea typeface="Verdana" panose="020B0604030504040204" pitchFamily="34" charset="0"/>
           <a:cs typeface="Verdana" panose="020B0604030504040204" pitchFamily="34" charset="0"/>
         </a:defRPr>
@@ -4304,11 +4304,11 @@
         <a:buFont typeface="Wingdings" pitchFamily="2" charset="2"/>
         <a:buChar char="§"/>
         <a:tabLst/>
-        <a:defRPr sz="1800" b="0" i="0" kern="1200">
+        <a:defRPr sz="1600" b="0" i="0" kern="1200">
           <a:solidFill>
             <a:schemeClr val="tx1"/>
           </a:solidFill>
-          <a:latin typeface="Verdana" panose="020B0604030504040204" pitchFamily="34" charset="0"/>
+          <a:latin typeface="Aptos" panose="020B0004020202020204" pitchFamily="34" charset="0"/>
           <a:ea typeface="Verdana" panose="020B0604030504040204" pitchFamily="34" charset="0"/>
           <a:cs typeface="Verdana" panose="020B0604030504040204" pitchFamily="34" charset="0"/>
         </a:defRPr>
@@ -4320,11 +4320,11 @@
         <a:buFont typeface="Courier New" panose="02070309020205020404" pitchFamily="49" charset="0"/>
         <a:buChar char="o"/>
         <a:tabLst/>
-        <a:defRPr sz="1600" b="0" i="0" kern="1200">
+        <a:defRPr sz="1400" b="0" i="0" kern="1200">
           <a:solidFill>
             <a:schemeClr val="tx1"/>
           </a:solidFill>
-          <a:latin typeface="Verdana" panose="020B0604030504040204" pitchFamily="34" charset="0"/>
+          <a:latin typeface="Aptos" panose="020B0004020202020204" pitchFamily="34" charset="0"/>
           <a:ea typeface="Verdana" panose="020B0604030504040204" pitchFamily="34" charset="0"/>
           <a:cs typeface="Verdana" panose="020B0604030504040204" pitchFamily="34" charset="0"/>
         </a:defRPr>
@@ -4336,11 +4336,11 @@
         <a:buFont typeface="Arial"/>
         <a:buChar char="–"/>
         <a:tabLst/>
-        <a:defRPr sz="1400" b="0" i="0" kern="1200">
+        <a:defRPr sz="1200" b="0" i="0" kern="1200">
           <a:solidFill>
             <a:schemeClr val="tx1"/>
           </a:solidFill>
-          <a:latin typeface="Verdana" panose="020B0604030504040204" pitchFamily="34" charset="0"/>
+          <a:latin typeface="Aptos" panose="020B0004020202020204" pitchFamily="34" charset="0"/>
           <a:ea typeface="Verdana" panose="020B0604030504040204" pitchFamily="34" charset="0"/>
           <a:cs typeface="Verdana" panose="020B0604030504040204" pitchFamily="34" charset="0"/>
         </a:defRPr>
@@ -4352,14 +4352,14 @@
         <a:buFont typeface="Arial"/>
         <a:buChar char="»"/>
         <a:tabLst/>
-        <a:defRPr sz="1400" b="0" i="0" kern="1200">
+        <a:defRPr sz="1200" b="0" i="0" kern="1200">
           <a:solidFill>
             <a:schemeClr val="tx1">
               <a:lumMod val="65000"/>
               <a:lumOff val="35000"/>
             </a:schemeClr>
           </a:solidFill>
-          <a:latin typeface="Verdana" panose="020B0604030504040204" pitchFamily="34" charset="0"/>
+          <a:latin typeface="Aptos" panose="020B0004020202020204" pitchFamily="34" charset="0"/>
           <a:ea typeface="Verdana" panose="020B0604030504040204" pitchFamily="34" charset="0"/>
           <a:cs typeface="Verdana" panose="020B0604030504040204" pitchFamily="34" charset="0"/>
         </a:defRPr>

</xml_diff>

<commit_message>
Adjust template footer date
</commit_message>
<xml_diff>
--- a/working-template.pptx
+++ b/working-template.pptx
@@ -871,7 +871,7 @@
             <a:pPr algn="ctr"/>
             <a:r>
               <a:rPr lang="en-US"/>
-              <a:t>9/23/26</a:t>
+              <a:t>DATE</a:t>
             </a:r>
             <a:endParaRPr lang="en-US" dirty="0"/>
           </a:p>
@@ -1084,7 +1084,7 @@
             <a:pPr algn="ctr"/>
             <a:r>
               <a:rPr lang="en-US"/>
-              <a:t>9/23/26</a:t>
+              <a:t>DATE</a:t>
             </a:r>
             <a:endParaRPr lang="en-US" dirty="0"/>
           </a:p>
@@ -1341,7 +1341,7 @@
             <a:pPr algn="ctr"/>
             <a:r>
               <a:rPr lang="en-US"/>
-              <a:t>9/23/26</a:t>
+              <a:t>DATE</a:t>
             </a:r>
             <a:endParaRPr lang="en-US" dirty="0"/>
           </a:p>
@@ -1588,7 +1588,7 @@
             <a:pPr algn="ctr"/>
             <a:r>
               <a:rPr lang="en-US"/>
-              <a:t>9/23/26</a:t>
+              <a:t>DATE</a:t>
             </a:r>
             <a:endParaRPr lang="en-US" dirty="0"/>
           </a:p>
@@ -1912,7 +1912,7 @@
             <a:pPr algn="ctr"/>
             <a:r>
               <a:rPr lang="en-US"/>
-              <a:t>9/23/26</a:t>
+              <a:t>DATE</a:t>
             </a:r>
             <a:endParaRPr lang="en-US" dirty="0"/>
           </a:p>
@@ -2276,7 +2276,7 @@
             <a:pPr algn="ctr"/>
             <a:r>
               <a:rPr lang="en-US"/>
-              <a:t>9/23/26</a:t>
+              <a:t>DATE</a:t>
             </a:r>
             <a:endParaRPr lang="en-US" dirty="0"/>
           </a:p>
@@ -2774,7 +2774,7 @@
             <a:pPr algn="ctr"/>
             <a:r>
               <a:rPr lang="en-US"/>
-              <a:t>9/23/26</a:t>
+              <a:t>DATE</a:t>
             </a:r>
             <a:endParaRPr lang="en-US" dirty="0"/>
           </a:p>
@@ -2970,7 +2970,7 @@
             <a:pPr algn="ctr"/>
             <a:r>
               <a:rPr lang="en-US"/>
-              <a:t>9/23/26</a:t>
+              <a:t>DATE</a:t>
             </a:r>
             <a:endParaRPr lang="en-US" dirty="0"/>
           </a:p>
@@ -3144,7 +3144,7 @@
             <a:pPr algn="ctr"/>
             <a:r>
               <a:rPr lang="en-US"/>
-              <a:t>9/23/26</a:t>
+              <a:t>DATE</a:t>
             </a:r>
             <a:endParaRPr lang="en-US" dirty="0"/>
           </a:p>
@@ -3498,7 +3498,7 @@
             <a:pPr algn="ctr"/>
             <a:r>
               <a:rPr lang="en-US"/>
-              <a:t>9/23/26</a:t>
+              <a:t>DATE</a:t>
             </a:r>
             <a:endParaRPr lang="en-US" dirty="0"/>
           </a:p>
@@ -3829,7 +3829,7 @@
             <a:pPr algn="ctr"/>
             <a:r>
               <a:rPr lang="en-US"/>
-              <a:t>9/23/26</a:t>
+              <a:t>DATE</a:t>
             </a:r>
             <a:endParaRPr lang="en-US" dirty="0"/>
           </a:p>
@@ -4113,7 +4113,7 @@
             <a:pPr algn="ctr"/>
             <a:r>
               <a:rPr lang="en-US"/>
-              <a:t>9/23/26</a:t>
+              <a:t>DATE</a:t>
             </a:r>
             <a:endParaRPr lang="en-US" dirty="0"/>
           </a:p>
@@ -4725,7 +4725,7 @@
           <a:p>
             <a:r>
               <a:rPr lang="en-US"/>
-              <a:t>9/23/26</a:t>
+              <a:t>DATE</a:t>
             </a:r>
           </a:p>
         </p:txBody>
@@ -4896,7 +4896,7 @@
           <a:p>
             <a:r>
               <a:rPr lang="en-US"/>
-              <a:t>9/23/26</a:t>
+              <a:t>DATE</a:t>
             </a:r>
           </a:p>
         </p:txBody>
@@ -5103,7 +5103,7 @@
           <a:p>
             <a:r>
               <a:rPr lang="en-US"/>
-              <a:t>9/23/26</a:t>
+              <a:t>DATE</a:t>
             </a:r>
           </a:p>
         </p:txBody>

</xml_diff>

<commit_message>
Adjust slide ratio to widescreen and fix some of the font sizes after change
</commit_message>
<xml_diff>
--- a/working-template.pptx
+++ b/working-template.pptx
@@ -13,14 +13,14 @@
     <p:sldId id="258" r:id="rId4"/>
     <p:sldId id="259" r:id="rId5"/>
   </p:sldIdLst>
-  <p:sldSz cx="9144000" cy="5143500" type="screen16x9"/>
+  <p:sldSz cx="12192000" cy="6858000"/>
   <p:notesSz cx="6858000" cy="9144000"/>
   <p:defaultTextStyle>
     <a:defPPr>
       <a:defRPr lang="en-US"/>
     </a:defPPr>
-    <a:lvl1pPr marL="0" algn="l" defTabSz="457200" rtl="0" eaLnBrk="1" latinLnBrk="0" hangingPunct="1">
-      <a:defRPr sz="1800" kern="1200">
+    <a:lvl1pPr marL="0" algn="l" defTabSz="609585" rtl="0" eaLnBrk="1" latinLnBrk="0" hangingPunct="1">
+      <a:defRPr sz="2400" kern="1200">
         <a:solidFill>
           <a:schemeClr val="tx1"/>
         </a:solidFill>
@@ -29,8 +29,8 @@
         <a:cs typeface="+mn-cs"/>
       </a:defRPr>
     </a:lvl1pPr>
-    <a:lvl2pPr marL="457200" algn="l" defTabSz="457200" rtl="0" eaLnBrk="1" latinLnBrk="0" hangingPunct="1">
-      <a:defRPr sz="1800" kern="1200">
+    <a:lvl2pPr marL="609585" algn="l" defTabSz="609585" rtl="0" eaLnBrk="1" latinLnBrk="0" hangingPunct="1">
+      <a:defRPr sz="2400" kern="1200">
         <a:solidFill>
           <a:schemeClr val="tx1"/>
         </a:solidFill>
@@ -39,8 +39,8 @@
         <a:cs typeface="+mn-cs"/>
       </a:defRPr>
     </a:lvl2pPr>
-    <a:lvl3pPr marL="914400" algn="l" defTabSz="457200" rtl="0" eaLnBrk="1" latinLnBrk="0" hangingPunct="1">
-      <a:defRPr sz="1800" kern="1200">
+    <a:lvl3pPr marL="1219170" algn="l" defTabSz="609585" rtl="0" eaLnBrk="1" latinLnBrk="0" hangingPunct="1">
+      <a:defRPr sz="2400" kern="1200">
         <a:solidFill>
           <a:schemeClr val="tx1"/>
         </a:solidFill>
@@ -49,8 +49,8 @@
         <a:cs typeface="+mn-cs"/>
       </a:defRPr>
     </a:lvl3pPr>
-    <a:lvl4pPr marL="1371600" algn="l" defTabSz="457200" rtl="0" eaLnBrk="1" latinLnBrk="0" hangingPunct="1">
-      <a:defRPr sz="1800" kern="1200">
+    <a:lvl4pPr marL="1828754" algn="l" defTabSz="609585" rtl="0" eaLnBrk="1" latinLnBrk="0" hangingPunct="1">
+      <a:defRPr sz="2400" kern="1200">
         <a:solidFill>
           <a:schemeClr val="tx1"/>
         </a:solidFill>
@@ -59,8 +59,8 @@
         <a:cs typeface="+mn-cs"/>
       </a:defRPr>
     </a:lvl4pPr>
-    <a:lvl5pPr marL="1828800" algn="l" defTabSz="457200" rtl="0" eaLnBrk="1" latinLnBrk="0" hangingPunct="1">
-      <a:defRPr sz="1800" kern="1200">
+    <a:lvl5pPr marL="2438339" algn="l" defTabSz="609585" rtl="0" eaLnBrk="1" latinLnBrk="0" hangingPunct="1">
+      <a:defRPr sz="2400" kern="1200">
         <a:solidFill>
           <a:schemeClr val="tx1"/>
         </a:solidFill>
@@ -69,8 +69,8 @@
         <a:cs typeface="+mn-cs"/>
       </a:defRPr>
     </a:lvl5pPr>
-    <a:lvl6pPr marL="2286000" algn="l" defTabSz="457200" rtl="0" eaLnBrk="1" latinLnBrk="0" hangingPunct="1">
-      <a:defRPr sz="1800" kern="1200">
+    <a:lvl6pPr marL="3047924" algn="l" defTabSz="609585" rtl="0" eaLnBrk="1" latinLnBrk="0" hangingPunct="1">
+      <a:defRPr sz="2400" kern="1200">
         <a:solidFill>
           <a:schemeClr val="tx1"/>
         </a:solidFill>
@@ -79,8 +79,8 @@
         <a:cs typeface="+mn-cs"/>
       </a:defRPr>
     </a:lvl6pPr>
-    <a:lvl7pPr marL="2743200" algn="l" defTabSz="457200" rtl="0" eaLnBrk="1" latinLnBrk="0" hangingPunct="1">
-      <a:defRPr sz="1800" kern="1200">
+    <a:lvl7pPr marL="3657509" algn="l" defTabSz="609585" rtl="0" eaLnBrk="1" latinLnBrk="0" hangingPunct="1">
+      <a:defRPr sz="2400" kern="1200">
         <a:solidFill>
           <a:schemeClr val="tx1"/>
         </a:solidFill>
@@ -89,8 +89,8 @@
         <a:cs typeface="+mn-cs"/>
       </a:defRPr>
     </a:lvl7pPr>
-    <a:lvl8pPr marL="3200400" algn="l" defTabSz="457200" rtl="0" eaLnBrk="1" latinLnBrk="0" hangingPunct="1">
-      <a:defRPr sz="1800" kern="1200">
+    <a:lvl8pPr marL="4267093" algn="l" defTabSz="609585" rtl="0" eaLnBrk="1" latinLnBrk="0" hangingPunct="1">
+      <a:defRPr sz="2400" kern="1200">
         <a:solidFill>
           <a:schemeClr val="tx1"/>
         </a:solidFill>
@@ -99,8 +99,8 @@
         <a:cs typeface="+mn-cs"/>
       </a:defRPr>
     </a:lvl8pPr>
-    <a:lvl9pPr marL="3657600" algn="l" defTabSz="457200" rtl="0" eaLnBrk="1" latinLnBrk="0" hangingPunct="1">
-      <a:defRPr sz="1800" kern="1200">
+    <a:lvl9pPr marL="4876678" algn="l" defTabSz="609585" rtl="0" eaLnBrk="1" latinLnBrk="0" hangingPunct="1">
+      <a:defRPr sz="2400" kern="1200">
         <a:solidFill>
           <a:schemeClr val="tx1"/>
         </a:solidFill>
@@ -113,12 +113,12 @@
   <p:extLst>
     <p:ext uri="{EFAFB233-063F-42B5-8137-9DF3F51BA10A}">
       <p15:sldGuideLst xmlns:p15="http://schemas.microsoft.com/office/powerpoint/2012/main">
-        <p15:guide id="1" orient="horz" pos="1620" userDrawn="1">
+        <p15:guide id="1" orient="horz" pos="2160" userDrawn="1">
           <p15:clr>
             <a:srgbClr val="A4A3A4"/>
           </p15:clr>
         </p15:guide>
-        <p15:guide id="2" pos="2880" userDrawn="1">
+        <p15:guide id="2" pos="3840" userDrawn="1">
           <p15:clr>
             <a:srgbClr val="A4A3A4"/>
           </p15:clr>
@@ -384,8 +384,8 @@
   </p:cSld>
   <p:clrMap bg1="lt1" tx1="dk1" bg2="lt2" tx2="dk2" accent1="accent1" accent2="accent2" accent3="accent3" accent4="accent4" accent5="accent5" accent6="accent6" hlink="hlink" folHlink="folHlink"/>
   <p:notesStyle>
-    <a:lvl1pPr marL="0" algn="l" defTabSz="914400" rtl="0" eaLnBrk="1" latinLnBrk="0" hangingPunct="1">
-      <a:defRPr sz="1200" kern="1200">
+    <a:lvl1pPr marL="0" algn="l" defTabSz="1219170" rtl="0" eaLnBrk="1" latinLnBrk="0" hangingPunct="1">
+      <a:defRPr sz="1600" kern="1200">
         <a:solidFill>
           <a:schemeClr val="tx1"/>
         </a:solidFill>
@@ -394,8 +394,8 @@
         <a:cs typeface="+mn-cs"/>
       </a:defRPr>
     </a:lvl1pPr>
-    <a:lvl2pPr marL="457200" algn="l" defTabSz="914400" rtl="0" eaLnBrk="1" latinLnBrk="0" hangingPunct="1">
-      <a:defRPr sz="1200" kern="1200">
+    <a:lvl2pPr marL="609585" algn="l" defTabSz="1219170" rtl="0" eaLnBrk="1" latinLnBrk="0" hangingPunct="1">
+      <a:defRPr sz="1600" kern="1200">
         <a:solidFill>
           <a:schemeClr val="tx1"/>
         </a:solidFill>
@@ -404,8 +404,8 @@
         <a:cs typeface="+mn-cs"/>
       </a:defRPr>
     </a:lvl2pPr>
-    <a:lvl3pPr marL="914400" algn="l" defTabSz="914400" rtl="0" eaLnBrk="1" latinLnBrk="0" hangingPunct="1">
-      <a:defRPr sz="1200" kern="1200">
+    <a:lvl3pPr marL="1219170" algn="l" defTabSz="1219170" rtl="0" eaLnBrk="1" latinLnBrk="0" hangingPunct="1">
+      <a:defRPr sz="1600" kern="1200">
         <a:solidFill>
           <a:schemeClr val="tx1"/>
         </a:solidFill>
@@ -414,8 +414,8 @@
         <a:cs typeface="+mn-cs"/>
       </a:defRPr>
     </a:lvl3pPr>
-    <a:lvl4pPr marL="1371600" algn="l" defTabSz="914400" rtl="0" eaLnBrk="1" latinLnBrk="0" hangingPunct="1">
-      <a:defRPr sz="1200" kern="1200">
+    <a:lvl4pPr marL="1828754" algn="l" defTabSz="1219170" rtl="0" eaLnBrk="1" latinLnBrk="0" hangingPunct="1">
+      <a:defRPr sz="1600" kern="1200">
         <a:solidFill>
           <a:schemeClr val="tx1"/>
         </a:solidFill>
@@ -424,8 +424,8 @@
         <a:cs typeface="+mn-cs"/>
       </a:defRPr>
     </a:lvl4pPr>
-    <a:lvl5pPr marL="1828800" algn="l" defTabSz="914400" rtl="0" eaLnBrk="1" latinLnBrk="0" hangingPunct="1">
-      <a:defRPr sz="1200" kern="1200">
+    <a:lvl5pPr marL="2438339" algn="l" defTabSz="1219170" rtl="0" eaLnBrk="1" latinLnBrk="0" hangingPunct="1">
+      <a:defRPr sz="1600" kern="1200">
         <a:solidFill>
           <a:schemeClr val="tx1"/>
         </a:solidFill>
@@ -434,8 +434,8 @@
         <a:cs typeface="+mn-cs"/>
       </a:defRPr>
     </a:lvl5pPr>
-    <a:lvl6pPr marL="2286000" algn="l" defTabSz="914400" rtl="0" eaLnBrk="1" latinLnBrk="0" hangingPunct="1">
-      <a:defRPr sz="1200" kern="1200">
+    <a:lvl6pPr marL="3047924" algn="l" defTabSz="1219170" rtl="0" eaLnBrk="1" latinLnBrk="0" hangingPunct="1">
+      <a:defRPr sz="1600" kern="1200">
         <a:solidFill>
           <a:schemeClr val="tx1"/>
         </a:solidFill>
@@ -444,8 +444,8 @@
         <a:cs typeface="+mn-cs"/>
       </a:defRPr>
     </a:lvl6pPr>
-    <a:lvl7pPr marL="2743200" algn="l" defTabSz="914400" rtl="0" eaLnBrk="1" latinLnBrk="0" hangingPunct="1">
-      <a:defRPr sz="1200" kern="1200">
+    <a:lvl7pPr marL="3657509" algn="l" defTabSz="1219170" rtl="0" eaLnBrk="1" latinLnBrk="0" hangingPunct="1">
+      <a:defRPr sz="1600" kern="1200">
         <a:solidFill>
           <a:schemeClr val="tx1"/>
         </a:solidFill>
@@ -454,8 +454,8 @@
         <a:cs typeface="+mn-cs"/>
       </a:defRPr>
     </a:lvl7pPr>
-    <a:lvl8pPr marL="3200400" algn="l" defTabSz="914400" rtl="0" eaLnBrk="1" latinLnBrk="0" hangingPunct="1">
-      <a:defRPr sz="1200" kern="1200">
+    <a:lvl8pPr marL="4267093" algn="l" defTabSz="1219170" rtl="0" eaLnBrk="1" latinLnBrk="0" hangingPunct="1">
+      <a:defRPr sz="1600" kern="1200">
         <a:solidFill>
           <a:schemeClr val="tx1"/>
         </a:solidFill>
@@ -464,8 +464,8 @@
         <a:cs typeface="+mn-cs"/>
       </a:defRPr>
     </a:lvl8pPr>
-    <a:lvl9pPr marL="3657600" algn="l" defTabSz="914400" rtl="0" eaLnBrk="1" latinLnBrk="0" hangingPunct="1">
-      <a:defRPr sz="1200" kern="1200">
+    <a:lvl9pPr marL="4876678" algn="l" defTabSz="1219170" rtl="0" eaLnBrk="1" latinLnBrk="0" hangingPunct="1">
+      <a:defRPr sz="1600" kern="1200">
         <a:solidFill>
           <a:schemeClr val="tx1"/>
         </a:solidFill>
@@ -714,8 +714,8 @@
         </p:nvSpPr>
         <p:spPr>
           <a:xfrm>
-            <a:off x="685800" y="1597819"/>
-            <a:ext cx="7772400" cy="1102519"/>
+            <a:off x="914400" y="2130426"/>
+            <a:ext cx="10363200" cy="1470025"/>
           </a:xfrm>
         </p:spPr>
         <p:txBody>
@@ -741,8 +741,8 @@
         </p:nvSpPr>
         <p:spPr>
           <a:xfrm>
-            <a:off x="1371600" y="2914650"/>
-            <a:ext cx="6400800" cy="1314450"/>
+            <a:off x="1828800" y="3886200"/>
+            <a:ext cx="8534400" cy="1752600"/>
           </a:xfrm>
         </p:spPr>
         <p:txBody>
@@ -758,7 +758,7 @@
                 </a:solidFill>
               </a:defRPr>
             </a:lvl1pPr>
-            <a:lvl2pPr marL="342900" indent="0" algn="ctr">
+            <a:lvl2pPr marL="457189" indent="0" algn="ctr">
               <a:buNone/>
               <a:defRPr>
                 <a:solidFill>
@@ -768,7 +768,7 @@
                 </a:solidFill>
               </a:defRPr>
             </a:lvl2pPr>
-            <a:lvl3pPr marL="685800" indent="0" algn="ctr">
+            <a:lvl3pPr marL="914377" indent="0" algn="ctr">
               <a:buNone/>
               <a:defRPr>
                 <a:solidFill>
@@ -778,7 +778,7 @@
                 </a:solidFill>
               </a:defRPr>
             </a:lvl3pPr>
-            <a:lvl4pPr marL="1028700" indent="0" algn="ctr">
+            <a:lvl4pPr marL="1371566" indent="0" algn="ctr">
               <a:buNone/>
               <a:defRPr>
                 <a:solidFill>
@@ -788,7 +788,7 @@
                 </a:solidFill>
               </a:defRPr>
             </a:lvl4pPr>
-            <a:lvl5pPr marL="1371600" indent="0" algn="ctr">
+            <a:lvl5pPr marL="1828754" indent="0" algn="ctr">
               <a:buNone/>
               <a:defRPr>
                 <a:solidFill>
@@ -798,7 +798,7 @@
                 </a:solidFill>
               </a:defRPr>
             </a:lvl5pPr>
-            <a:lvl6pPr marL="1714500" indent="0" algn="ctr">
+            <a:lvl6pPr marL="2285943" indent="0" algn="ctr">
               <a:buNone/>
               <a:defRPr>
                 <a:solidFill>
@@ -808,7 +808,7 @@
                 </a:solidFill>
               </a:defRPr>
             </a:lvl6pPr>
-            <a:lvl7pPr marL="2057400" indent="0" algn="ctr">
+            <a:lvl7pPr marL="2743131" indent="0" algn="ctr">
               <a:buNone/>
               <a:defRPr>
                 <a:solidFill>
@@ -818,7 +818,7 @@
                 </a:solidFill>
               </a:defRPr>
             </a:lvl7pPr>
-            <a:lvl8pPr marL="2400300" indent="0" algn="ctr">
+            <a:lvl8pPr marL="3200320" indent="0" algn="ctr">
               <a:buNone/>
               <a:defRPr>
                 <a:solidFill>
@@ -828,7 +828,7 @@
                 </a:solidFill>
               </a:defRPr>
             </a:lvl8pPr>
-            <a:lvl9pPr marL="2743200" indent="0" algn="ctr">
+            <a:lvl9pPr marL="3657509" indent="0" algn="ctr">
               <a:buNone/>
               <a:defRPr>
                 <a:solidFill>
@@ -954,12 +954,12 @@
   <p:extLst>
     <p:ext uri="{DCECCB84-F9BA-43D5-87BE-67443E8EF086}">
       <p15:sldGuideLst xmlns:p15="http://schemas.microsoft.com/office/powerpoint/2012/main">
-        <p15:guide id="1" orient="horz" pos="1620" userDrawn="1">
+        <p15:guide id="1" orient="horz" pos="2160" userDrawn="1">
           <p15:clr>
             <a:srgbClr val="FBAE40"/>
           </p15:clr>
         </p15:guide>
-        <p15:guide id="2" pos="2880" userDrawn="1">
+        <p15:guide id="2" pos="3840" userDrawn="1">
           <p15:clr>
             <a:srgbClr val="FBAE40"/>
           </p15:clr>
@@ -1168,8 +1168,8 @@
         </p:nvSpPr>
         <p:spPr>
           <a:xfrm>
-            <a:off x="8991600" y="0"/>
-            <a:ext cx="152400" cy="5143500"/>
+            <a:off x="11988800" y="0"/>
+            <a:ext cx="203200" cy="6858000"/>
           </a:xfrm>
           <a:prstGeom prst="rect">
             <a:avLst/>
@@ -1200,7 +1200,7 @@
           <a:lstStyle/>
           <a:p>
             <a:pPr algn="ctr"/>
-            <a:endParaRPr lang="en-US"/>
+            <a:endParaRPr lang="en-US" sz="3200"/>
           </a:p>
         </p:txBody>
       </p:sp>
@@ -1246,8 +1246,8 @@
         </p:nvSpPr>
         <p:spPr>
           <a:xfrm>
-            <a:off x="6629400" y="205979"/>
-            <a:ext cx="2057400" cy="4388644"/>
+            <a:off x="8839200" y="274639"/>
+            <a:ext cx="2743200" cy="5851525"/>
           </a:xfrm>
         </p:spPr>
         <p:txBody>
@@ -1273,8 +1273,8 @@
         </p:nvSpPr>
         <p:spPr>
           <a:xfrm>
-            <a:off x="457200" y="205979"/>
-            <a:ext cx="6019800" cy="4388644"/>
+            <a:off x="609600" y="274639"/>
+            <a:ext cx="8026400" cy="5851525"/>
           </a:xfrm>
         </p:spPr>
         <p:txBody>
@@ -1425,8 +1425,8 @@
         </p:nvSpPr>
         <p:spPr>
           <a:xfrm>
-            <a:off x="8991600" y="0"/>
-            <a:ext cx="152400" cy="5143500"/>
+            <a:off x="11988800" y="0"/>
+            <a:ext cx="203200" cy="6858000"/>
           </a:xfrm>
           <a:prstGeom prst="rect">
             <a:avLst/>
@@ -1457,7 +1457,7 @@
           <a:lstStyle/>
           <a:p>
             <a:pPr algn="ctr"/>
-            <a:endParaRPr lang="en-US"/>
+            <a:endParaRPr lang="en-US" sz="3200"/>
           </a:p>
         </p:txBody>
       </p:sp>
@@ -1672,8 +1672,8 @@
         </p:nvSpPr>
         <p:spPr>
           <a:xfrm>
-            <a:off x="8991600" y="0"/>
-            <a:ext cx="152400" cy="5143500"/>
+            <a:off x="11988800" y="0"/>
+            <a:ext cx="203200" cy="6858000"/>
           </a:xfrm>
           <a:prstGeom prst="rect">
             <a:avLst/>
@@ -1704,7 +1704,7 @@
           <a:lstStyle/>
           <a:p>
             <a:pPr algn="ctr"/>
-            <a:endParaRPr lang="en-US"/>
+            <a:endParaRPr lang="en-US" sz="3200"/>
           </a:p>
         </p:txBody>
       </p:sp>
@@ -1750,15 +1750,15 @@
         </p:nvSpPr>
         <p:spPr>
           <a:xfrm>
-            <a:off x="722313" y="2375222"/>
-            <a:ext cx="7772400" cy="1021556"/>
+            <a:off x="963084" y="3166963"/>
+            <a:ext cx="10363200" cy="1362075"/>
           </a:xfrm>
         </p:spPr>
         <p:txBody>
           <a:bodyPr anchor="t"/>
           <a:lstStyle>
             <a:lvl1pPr algn="l">
-              <a:defRPr sz="2800" b="1" cap="none"/>
+              <a:defRPr sz="3733" b="1" cap="none"/>
             </a:lvl1pPr>
           </a:lstStyle>
           <a:p>
@@ -1781,8 +1781,8 @@
         </p:nvSpPr>
         <p:spPr>
           <a:xfrm>
-            <a:off x="722313" y="1208909"/>
-            <a:ext cx="7772400" cy="1125140"/>
+            <a:off x="963084" y="1611879"/>
+            <a:ext cx="10363200" cy="1500187"/>
           </a:xfrm>
         </p:spPr>
         <p:txBody>
@@ -1790,7 +1790,7 @@
           <a:lstStyle>
             <a:lvl1pPr marL="0" indent="0">
               <a:buNone/>
-              <a:defRPr sz="1500">
+              <a:defRPr sz="2000">
                 <a:solidFill>
                   <a:schemeClr val="tx1">
                     <a:tint val="75000"/>
@@ -1798,9 +1798,9 @@
                 </a:solidFill>
               </a:defRPr>
             </a:lvl1pPr>
-            <a:lvl2pPr marL="342900" indent="0">
-              <a:buNone/>
-              <a:defRPr sz="1350">
+            <a:lvl2pPr marL="457189" indent="0">
+              <a:buNone/>
+              <a:defRPr sz="1800">
                 <a:solidFill>
                   <a:schemeClr val="tx1">
                     <a:tint val="75000"/>
@@ -1808,9 +1808,9 @@
                 </a:solidFill>
               </a:defRPr>
             </a:lvl2pPr>
-            <a:lvl3pPr marL="685800" indent="0">
-              <a:buNone/>
-              <a:defRPr sz="1200">
+            <a:lvl3pPr marL="914377" indent="0">
+              <a:buNone/>
+              <a:defRPr sz="1600">
                 <a:solidFill>
                   <a:schemeClr val="tx1">
                     <a:tint val="75000"/>
@@ -1818,9 +1818,9 @@
                 </a:solidFill>
               </a:defRPr>
             </a:lvl3pPr>
-            <a:lvl4pPr marL="1028700" indent="0">
-              <a:buNone/>
-              <a:defRPr sz="1050">
+            <a:lvl4pPr marL="1371566" indent="0">
+              <a:buNone/>
+              <a:defRPr sz="1400">
                 <a:solidFill>
                   <a:schemeClr val="tx1">
                     <a:tint val="75000"/>
@@ -1828,9 +1828,9 @@
                 </a:solidFill>
               </a:defRPr>
             </a:lvl4pPr>
-            <a:lvl5pPr marL="1371600" indent="0">
-              <a:buNone/>
-              <a:defRPr sz="1050">
+            <a:lvl5pPr marL="1828754" indent="0">
+              <a:buNone/>
+              <a:defRPr sz="1400">
                 <a:solidFill>
                   <a:schemeClr val="tx1">
                     <a:tint val="75000"/>
@@ -1838,9 +1838,9 @@
                 </a:solidFill>
               </a:defRPr>
             </a:lvl5pPr>
-            <a:lvl6pPr marL="1714500" indent="0">
-              <a:buNone/>
-              <a:defRPr sz="1050">
+            <a:lvl6pPr marL="2285943" indent="0">
+              <a:buNone/>
+              <a:defRPr sz="1400">
                 <a:solidFill>
                   <a:schemeClr val="tx1">
                     <a:tint val="75000"/>
@@ -1848,9 +1848,9 @@
                 </a:solidFill>
               </a:defRPr>
             </a:lvl6pPr>
-            <a:lvl7pPr marL="2057400" indent="0">
-              <a:buNone/>
-              <a:defRPr sz="1050">
+            <a:lvl7pPr marL="2743131" indent="0">
+              <a:buNone/>
+              <a:defRPr sz="1400">
                 <a:solidFill>
                   <a:schemeClr val="tx1">
                     <a:tint val="75000"/>
@@ -1858,9 +1858,9 @@
                 </a:solidFill>
               </a:defRPr>
             </a:lvl7pPr>
-            <a:lvl8pPr marL="2400300" indent="0">
-              <a:buNone/>
-              <a:defRPr sz="1050">
+            <a:lvl8pPr marL="3200320" indent="0">
+              <a:buNone/>
+              <a:defRPr sz="1400">
                 <a:solidFill>
                   <a:schemeClr val="tx1">
                     <a:tint val="75000"/>
@@ -1868,9 +1868,9 @@
                 </a:solidFill>
               </a:defRPr>
             </a:lvl8pPr>
-            <a:lvl9pPr marL="2743200" indent="0">
-              <a:buNone/>
-              <a:defRPr sz="1050">
+            <a:lvl9pPr marL="3657509" indent="0">
+              <a:buNone/>
+              <a:defRPr sz="1400">
                 <a:solidFill>
                   <a:schemeClr val="tx1">
                     <a:tint val="75000"/>
@@ -1996,8 +1996,8 @@
         </p:nvSpPr>
         <p:spPr>
           <a:xfrm>
-            <a:off x="8991600" y="0"/>
-            <a:ext cx="152400" cy="5143500"/>
+            <a:off x="11988800" y="0"/>
+            <a:ext cx="203200" cy="6858000"/>
           </a:xfrm>
           <a:prstGeom prst="rect">
             <a:avLst/>
@@ -2028,7 +2028,7 @@
           <a:lstStyle/>
           <a:p>
             <a:pPr algn="ctr"/>
-            <a:endParaRPr lang="en-US"/>
+            <a:endParaRPr lang="en-US" sz="3200"/>
           </a:p>
         </p:txBody>
       </p:sp>
@@ -2096,39 +2096,39 @@
         </p:nvSpPr>
         <p:spPr>
           <a:xfrm>
-            <a:off x="457200" y="1200151"/>
-            <a:ext cx="4038600" cy="3394472"/>
+            <a:off x="609600" y="1600201"/>
+            <a:ext cx="5384800" cy="4525963"/>
           </a:xfrm>
         </p:spPr>
         <p:txBody>
           <a:bodyPr/>
           <a:lstStyle>
             <a:lvl1pPr>
-              <a:defRPr sz="2100"/>
+              <a:defRPr sz="2800"/>
             </a:lvl1pPr>
             <a:lvl2pPr>
-              <a:defRPr sz="1800"/>
+              <a:defRPr sz="2400"/>
             </a:lvl2pPr>
             <a:lvl3pPr>
-              <a:defRPr sz="1500"/>
+              <a:defRPr sz="2000"/>
             </a:lvl3pPr>
             <a:lvl4pPr>
-              <a:defRPr sz="1350"/>
+              <a:defRPr sz="1800"/>
             </a:lvl4pPr>
             <a:lvl5pPr>
-              <a:defRPr sz="1350"/>
+              <a:defRPr sz="1800"/>
             </a:lvl5pPr>
             <a:lvl6pPr>
-              <a:defRPr sz="1350"/>
+              <a:defRPr sz="1800"/>
             </a:lvl6pPr>
             <a:lvl7pPr>
-              <a:defRPr sz="1350"/>
+              <a:defRPr sz="1800"/>
             </a:lvl7pPr>
             <a:lvl8pPr>
-              <a:defRPr sz="1350"/>
+              <a:defRPr sz="1800"/>
             </a:lvl8pPr>
             <a:lvl9pPr>
-              <a:defRPr sz="1350"/>
+              <a:defRPr sz="1800"/>
             </a:lvl9pPr>
           </a:lstStyle>
           <a:p>
@@ -2180,39 +2180,39 @@
         </p:nvSpPr>
         <p:spPr>
           <a:xfrm>
-            <a:off x="4648200" y="1200151"/>
-            <a:ext cx="4038600" cy="3394472"/>
+            <a:off x="6197600" y="1600201"/>
+            <a:ext cx="5384800" cy="4525963"/>
           </a:xfrm>
         </p:spPr>
         <p:txBody>
           <a:bodyPr/>
           <a:lstStyle>
             <a:lvl1pPr>
-              <a:defRPr sz="2100"/>
+              <a:defRPr sz="2800"/>
             </a:lvl1pPr>
             <a:lvl2pPr>
-              <a:defRPr sz="1800"/>
+              <a:defRPr sz="2400"/>
             </a:lvl2pPr>
             <a:lvl3pPr>
-              <a:defRPr sz="1500"/>
+              <a:defRPr sz="2000"/>
             </a:lvl3pPr>
             <a:lvl4pPr>
-              <a:defRPr sz="1350"/>
+              <a:defRPr sz="1800"/>
             </a:lvl4pPr>
             <a:lvl5pPr>
-              <a:defRPr sz="1350"/>
+              <a:defRPr sz="1800"/>
             </a:lvl5pPr>
             <a:lvl6pPr>
-              <a:defRPr sz="1350"/>
+              <a:defRPr sz="1800"/>
             </a:lvl6pPr>
             <a:lvl7pPr>
-              <a:defRPr sz="1350"/>
+              <a:defRPr sz="1800"/>
             </a:lvl7pPr>
             <a:lvl8pPr>
-              <a:defRPr sz="1350"/>
+              <a:defRPr sz="1800"/>
             </a:lvl8pPr>
             <a:lvl9pPr>
-              <a:defRPr sz="1350"/>
+              <a:defRPr sz="1800"/>
             </a:lvl9pPr>
           </a:lstStyle>
           <a:p>
@@ -2360,8 +2360,8 @@
         </p:nvSpPr>
         <p:spPr>
           <a:xfrm>
-            <a:off x="8991600" y="0"/>
-            <a:ext cx="152400" cy="5143500"/>
+            <a:off x="11988800" y="0"/>
+            <a:ext cx="203200" cy="6858000"/>
           </a:xfrm>
           <a:prstGeom prst="rect">
             <a:avLst/>
@@ -2392,7 +2392,7 @@
           <a:lstStyle/>
           <a:p>
             <a:pPr algn="ctr"/>
-            <a:endParaRPr lang="en-US"/>
+            <a:endParaRPr lang="en-US" sz="3200"/>
           </a:p>
         </p:txBody>
       </p:sp>
@@ -2464,8 +2464,8 @@
         </p:nvSpPr>
         <p:spPr>
           <a:xfrm>
-            <a:off x="457200" y="1151335"/>
-            <a:ext cx="4040188" cy="479822"/>
+            <a:off x="609600" y="1535113"/>
+            <a:ext cx="5386917" cy="639763"/>
           </a:xfrm>
         </p:spPr>
         <p:txBody>
@@ -2473,39 +2473,39 @@
           <a:lstStyle>
             <a:lvl1pPr marL="0" indent="0">
               <a:buNone/>
+              <a:defRPr sz="2400" b="1"/>
+            </a:lvl1pPr>
+            <a:lvl2pPr marL="457189" indent="0">
+              <a:buNone/>
+              <a:defRPr sz="2000" b="1"/>
+            </a:lvl2pPr>
+            <a:lvl3pPr marL="914377" indent="0">
+              <a:buNone/>
               <a:defRPr sz="1800" b="1"/>
-            </a:lvl1pPr>
-            <a:lvl2pPr marL="342900" indent="0">
-              <a:buNone/>
-              <a:defRPr sz="1500" b="1"/>
-            </a:lvl2pPr>
-            <a:lvl3pPr marL="685800" indent="0">
-              <a:buNone/>
-              <a:defRPr sz="1350" b="1"/>
             </a:lvl3pPr>
-            <a:lvl4pPr marL="1028700" indent="0">
-              <a:buNone/>
-              <a:defRPr sz="1200" b="1"/>
+            <a:lvl4pPr marL="1371566" indent="0">
+              <a:buNone/>
+              <a:defRPr sz="1600" b="1"/>
             </a:lvl4pPr>
-            <a:lvl5pPr marL="1371600" indent="0">
-              <a:buNone/>
-              <a:defRPr sz="1200" b="1"/>
+            <a:lvl5pPr marL="1828754" indent="0">
+              <a:buNone/>
+              <a:defRPr sz="1600" b="1"/>
             </a:lvl5pPr>
-            <a:lvl6pPr marL="1714500" indent="0">
-              <a:buNone/>
-              <a:defRPr sz="1200" b="1"/>
+            <a:lvl6pPr marL="2285943" indent="0">
+              <a:buNone/>
+              <a:defRPr sz="1600" b="1"/>
             </a:lvl6pPr>
-            <a:lvl7pPr marL="2057400" indent="0">
-              <a:buNone/>
-              <a:defRPr sz="1200" b="1"/>
+            <a:lvl7pPr marL="2743131" indent="0">
+              <a:buNone/>
+              <a:defRPr sz="1600" b="1"/>
             </a:lvl7pPr>
-            <a:lvl8pPr marL="2400300" indent="0">
-              <a:buNone/>
-              <a:defRPr sz="1200" b="1"/>
+            <a:lvl8pPr marL="3200320" indent="0">
+              <a:buNone/>
+              <a:defRPr sz="1600" b="1"/>
             </a:lvl8pPr>
-            <a:lvl9pPr marL="2743200" indent="0">
-              <a:buNone/>
-              <a:defRPr sz="1200" b="1"/>
+            <a:lvl9pPr marL="3657509" indent="0">
+              <a:buNone/>
+              <a:defRPr sz="1600" b="1"/>
             </a:lvl9pPr>
           </a:lstStyle>
           <a:p>
@@ -2529,39 +2529,39 @@
         </p:nvSpPr>
         <p:spPr>
           <a:xfrm>
-            <a:off x="457200" y="1631156"/>
-            <a:ext cx="4040188" cy="2963466"/>
+            <a:off x="609600" y="2174875"/>
+            <a:ext cx="5386917" cy="3951288"/>
           </a:xfrm>
         </p:spPr>
         <p:txBody>
           <a:bodyPr/>
           <a:lstStyle>
             <a:lvl1pPr>
-              <a:defRPr sz="1800"/>
+              <a:defRPr sz="2400"/>
             </a:lvl1pPr>
             <a:lvl2pPr>
-              <a:defRPr sz="1500"/>
+              <a:defRPr sz="2000"/>
             </a:lvl2pPr>
             <a:lvl3pPr>
-              <a:defRPr sz="1350"/>
+              <a:defRPr sz="1800"/>
             </a:lvl3pPr>
             <a:lvl4pPr>
-              <a:defRPr sz="1200"/>
+              <a:defRPr sz="1600"/>
             </a:lvl4pPr>
             <a:lvl5pPr>
-              <a:defRPr sz="1200"/>
+              <a:defRPr sz="1600"/>
             </a:lvl5pPr>
             <a:lvl6pPr>
-              <a:defRPr sz="1200"/>
+              <a:defRPr sz="1600"/>
             </a:lvl6pPr>
             <a:lvl7pPr>
-              <a:defRPr sz="1200"/>
+              <a:defRPr sz="1600"/>
             </a:lvl7pPr>
             <a:lvl8pPr>
-              <a:defRPr sz="1200"/>
+              <a:defRPr sz="1600"/>
             </a:lvl8pPr>
             <a:lvl9pPr>
-              <a:defRPr sz="1200"/>
+              <a:defRPr sz="1600"/>
             </a:lvl9pPr>
           </a:lstStyle>
           <a:p>
@@ -2613,8 +2613,8 @@
         </p:nvSpPr>
         <p:spPr>
           <a:xfrm>
-            <a:off x="4645026" y="1151335"/>
-            <a:ext cx="4041775" cy="479822"/>
+            <a:off x="6193369" y="1535113"/>
+            <a:ext cx="5389033" cy="639763"/>
           </a:xfrm>
         </p:spPr>
         <p:txBody>
@@ -2622,39 +2622,39 @@
           <a:lstStyle>
             <a:lvl1pPr marL="0" indent="0">
               <a:buNone/>
+              <a:defRPr sz="2400" b="1"/>
+            </a:lvl1pPr>
+            <a:lvl2pPr marL="457189" indent="0">
+              <a:buNone/>
+              <a:defRPr sz="2000" b="1"/>
+            </a:lvl2pPr>
+            <a:lvl3pPr marL="914377" indent="0">
+              <a:buNone/>
               <a:defRPr sz="1800" b="1"/>
-            </a:lvl1pPr>
-            <a:lvl2pPr marL="342900" indent="0">
-              <a:buNone/>
-              <a:defRPr sz="1500" b="1"/>
-            </a:lvl2pPr>
-            <a:lvl3pPr marL="685800" indent="0">
-              <a:buNone/>
-              <a:defRPr sz="1350" b="1"/>
             </a:lvl3pPr>
-            <a:lvl4pPr marL="1028700" indent="0">
-              <a:buNone/>
-              <a:defRPr sz="1200" b="1"/>
+            <a:lvl4pPr marL="1371566" indent="0">
+              <a:buNone/>
+              <a:defRPr sz="1600" b="1"/>
             </a:lvl4pPr>
-            <a:lvl5pPr marL="1371600" indent="0">
-              <a:buNone/>
-              <a:defRPr sz="1200" b="1"/>
+            <a:lvl5pPr marL="1828754" indent="0">
+              <a:buNone/>
+              <a:defRPr sz="1600" b="1"/>
             </a:lvl5pPr>
-            <a:lvl6pPr marL="1714500" indent="0">
-              <a:buNone/>
-              <a:defRPr sz="1200" b="1"/>
+            <a:lvl6pPr marL="2285943" indent="0">
+              <a:buNone/>
+              <a:defRPr sz="1600" b="1"/>
             </a:lvl6pPr>
-            <a:lvl7pPr marL="2057400" indent="0">
-              <a:buNone/>
-              <a:defRPr sz="1200" b="1"/>
+            <a:lvl7pPr marL="2743131" indent="0">
+              <a:buNone/>
+              <a:defRPr sz="1600" b="1"/>
             </a:lvl7pPr>
-            <a:lvl8pPr marL="2400300" indent="0">
-              <a:buNone/>
-              <a:defRPr sz="1200" b="1"/>
+            <a:lvl8pPr marL="3200320" indent="0">
+              <a:buNone/>
+              <a:defRPr sz="1600" b="1"/>
             </a:lvl8pPr>
-            <a:lvl9pPr marL="2743200" indent="0">
-              <a:buNone/>
-              <a:defRPr sz="1200" b="1"/>
+            <a:lvl9pPr marL="3657509" indent="0">
+              <a:buNone/>
+              <a:defRPr sz="1600" b="1"/>
             </a:lvl9pPr>
           </a:lstStyle>
           <a:p>
@@ -2678,39 +2678,39 @@
         </p:nvSpPr>
         <p:spPr>
           <a:xfrm>
-            <a:off x="4645026" y="1631156"/>
-            <a:ext cx="4041775" cy="2963466"/>
+            <a:off x="6193369" y="2174875"/>
+            <a:ext cx="5389033" cy="3951288"/>
           </a:xfrm>
         </p:spPr>
         <p:txBody>
           <a:bodyPr/>
           <a:lstStyle>
             <a:lvl1pPr>
-              <a:defRPr sz="1800"/>
+              <a:defRPr sz="2400"/>
             </a:lvl1pPr>
             <a:lvl2pPr>
-              <a:defRPr sz="1500"/>
+              <a:defRPr sz="2000"/>
             </a:lvl2pPr>
             <a:lvl3pPr>
-              <a:defRPr sz="1350"/>
+              <a:defRPr sz="1800"/>
             </a:lvl3pPr>
             <a:lvl4pPr>
-              <a:defRPr sz="1200"/>
+              <a:defRPr sz="1600"/>
             </a:lvl4pPr>
             <a:lvl5pPr>
-              <a:defRPr sz="1200"/>
+              <a:defRPr sz="1600"/>
             </a:lvl5pPr>
             <a:lvl6pPr>
-              <a:defRPr sz="1200"/>
+              <a:defRPr sz="1600"/>
             </a:lvl6pPr>
             <a:lvl7pPr>
-              <a:defRPr sz="1200"/>
+              <a:defRPr sz="1600"/>
             </a:lvl7pPr>
             <a:lvl8pPr>
-              <a:defRPr sz="1200"/>
+              <a:defRPr sz="1600"/>
             </a:lvl8pPr>
             <a:lvl9pPr>
-              <a:defRPr sz="1200"/>
+              <a:defRPr sz="1600"/>
             </a:lvl9pPr>
           </a:lstStyle>
           <a:p>
@@ -2858,8 +2858,8 @@
         </p:nvSpPr>
         <p:spPr>
           <a:xfrm>
-            <a:off x="8991600" y="0"/>
-            <a:ext cx="152400" cy="5143500"/>
+            <a:off x="11988800" y="0"/>
+            <a:ext cx="203200" cy="6858000"/>
           </a:xfrm>
           <a:prstGeom prst="rect">
             <a:avLst/>
@@ -2890,7 +2890,7 @@
           <a:lstStyle/>
           <a:p>
             <a:pPr algn="ctr"/>
-            <a:endParaRPr lang="en-US"/>
+            <a:endParaRPr lang="en-US" sz="3200"/>
           </a:p>
         </p:txBody>
       </p:sp>
@@ -3054,8 +3054,8 @@
         </p:nvSpPr>
         <p:spPr>
           <a:xfrm>
-            <a:off x="8991600" y="0"/>
-            <a:ext cx="152400" cy="5143500"/>
+            <a:off x="11988800" y="0"/>
+            <a:ext cx="203200" cy="6858000"/>
           </a:xfrm>
           <a:prstGeom prst="rect">
             <a:avLst/>
@@ -3086,7 +3086,7 @@
           <a:lstStyle/>
           <a:p>
             <a:pPr algn="ctr"/>
-            <a:endParaRPr lang="en-US"/>
+            <a:endParaRPr lang="en-US" sz="3200"/>
           </a:p>
         </p:txBody>
       </p:sp>
@@ -3228,8 +3228,8 @@
         </p:nvSpPr>
         <p:spPr>
           <a:xfrm>
-            <a:off x="8991600" y="0"/>
-            <a:ext cx="152400" cy="5143500"/>
+            <a:off x="11988800" y="0"/>
+            <a:ext cx="203200" cy="6858000"/>
           </a:xfrm>
           <a:prstGeom prst="rect">
             <a:avLst/>
@@ -3260,7 +3260,7 @@
           <a:lstStyle/>
           <a:p>
             <a:pPr algn="ctr"/>
-            <a:endParaRPr lang="en-US"/>
+            <a:endParaRPr lang="en-US" sz="3200"/>
           </a:p>
         </p:txBody>
       </p:sp>
@@ -3306,15 +3306,15 @@
         </p:nvSpPr>
         <p:spPr>
           <a:xfrm>
-            <a:off x="457201" y="204787"/>
-            <a:ext cx="3008313" cy="871538"/>
+            <a:off x="609602" y="273049"/>
+            <a:ext cx="4011084" cy="1162051"/>
           </a:xfrm>
         </p:spPr>
         <p:txBody>
           <a:bodyPr anchor="b"/>
           <a:lstStyle>
             <a:lvl1pPr algn="l">
-              <a:defRPr sz="1500" b="1"/>
+              <a:defRPr sz="2000" b="1"/>
             </a:lvl1pPr>
           </a:lstStyle>
           <a:p>
@@ -3337,39 +3337,39 @@
         </p:nvSpPr>
         <p:spPr>
           <a:xfrm>
-            <a:off x="3575050" y="204788"/>
-            <a:ext cx="5111750" cy="4389835"/>
+            <a:off x="4766733" y="273052"/>
+            <a:ext cx="6815667" cy="5853113"/>
           </a:xfrm>
         </p:spPr>
         <p:txBody>
           <a:bodyPr/>
           <a:lstStyle>
             <a:lvl1pPr>
-              <a:defRPr sz="2400"/>
+              <a:defRPr sz="3200"/>
             </a:lvl1pPr>
             <a:lvl2pPr>
-              <a:defRPr sz="2100"/>
+              <a:defRPr sz="2800"/>
             </a:lvl2pPr>
             <a:lvl3pPr>
-              <a:defRPr sz="1800"/>
+              <a:defRPr sz="2400"/>
             </a:lvl3pPr>
             <a:lvl4pPr>
-              <a:defRPr sz="1500"/>
+              <a:defRPr sz="2000"/>
             </a:lvl4pPr>
             <a:lvl5pPr>
-              <a:defRPr sz="1500"/>
+              <a:defRPr sz="2000"/>
             </a:lvl5pPr>
             <a:lvl6pPr>
-              <a:defRPr sz="1500"/>
+              <a:defRPr sz="2000"/>
             </a:lvl6pPr>
             <a:lvl7pPr>
-              <a:defRPr sz="1500"/>
+              <a:defRPr sz="2000"/>
             </a:lvl7pPr>
             <a:lvl8pPr>
-              <a:defRPr sz="1500"/>
+              <a:defRPr sz="2000"/>
             </a:lvl8pPr>
             <a:lvl9pPr>
-              <a:defRPr sz="1500"/>
+              <a:defRPr sz="2000"/>
             </a:lvl9pPr>
           </a:lstStyle>
           <a:p>
@@ -3421,8 +3421,8 @@
         </p:nvSpPr>
         <p:spPr>
           <a:xfrm>
-            <a:off x="457201" y="1076326"/>
-            <a:ext cx="3008313" cy="3518297"/>
+            <a:off x="609602" y="1435102"/>
+            <a:ext cx="4011084" cy="4691063"/>
           </a:xfrm>
         </p:spPr>
         <p:txBody>
@@ -3430,39 +3430,39 @@
           <a:lstStyle>
             <a:lvl1pPr marL="0" indent="0">
               <a:buNone/>
-              <a:defRPr sz="1050"/>
+              <a:defRPr sz="1400"/>
             </a:lvl1pPr>
-            <a:lvl2pPr marL="342900" indent="0">
+            <a:lvl2pPr marL="457189" indent="0">
+              <a:buNone/>
+              <a:defRPr sz="1200"/>
+            </a:lvl2pPr>
+            <a:lvl3pPr marL="914377" indent="0">
+              <a:buNone/>
+              <a:defRPr sz="1000"/>
+            </a:lvl3pPr>
+            <a:lvl4pPr marL="1371566" indent="0">
               <a:buNone/>
               <a:defRPr sz="900"/>
-            </a:lvl2pPr>
-            <a:lvl3pPr marL="685800" indent="0">
-              <a:buNone/>
-              <a:defRPr sz="750"/>
-            </a:lvl3pPr>
-            <a:lvl4pPr marL="1028700" indent="0">
-              <a:buNone/>
-              <a:defRPr sz="675"/>
             </a:lvl4pPr>
-            <a:lvl5pPr marL="1371600" indent="0">
-              <a:buNone/>
-              <a:defRPr sz="675"/>
+            <a:lvl5pPr marL="1828754" indent="0">
+              <a:buNone/>
+              <a:defRPr sz="900"/>
             </a:lvl5pPr>
-            <a:lvl6pPr marL="1714500" indent="0">
-              <a:buNone/>
-              <a:defRPr sz="675"/>
+            <a:lvl6pPr marL="2285943" indent="0">
+              <a:buNone/>
+              <a:defRPr sz="900"/>
             </a:lvl6pPr>
-            <a:lvl7pPr marL="2057400" indent="0">
-              <a:buNone/>
-              <a:defRPr sz="675"/>
+            <a:lvl7pPr marL="2743131" indent="0">
+              <a:buNone/>
+              <a:defRPr sz="900"/>
             </a:lvl7pPr>
-            <a:lvl8pPr marL="2400300" indent="0">
-              <a:buNone/>
-              <a:defRPr sz="675"/>
+            <a:lvl8pPr marL="3200320" indent="0">
+              <a:buNone/>
+              <a:defRPr sz="900"/>
             </a:lvl8pPr>
-            <a:lvl9pPr marL="2743200" indent="0">
-              <a:buNone/>
-              <a:defRPr sz="675"/>
+            <a:lvl9pPr marL="3657509" indent="0">
+              <a:buNone/>
+              <a:defRPr sz="900"/>
             </a:lvl9pPr>
           </a:lstStyle>
           <a:p>
@@ -3582,8 +3582,8 @@
         </p:nvSpPr>
         <p:spPr>
           <a:xfrm>
-            <a:off x="8991600" y="0"/>
-            <a:ext cx="152400" cy="5143500"/>
+            <a:off x="11988800" y="0"/>
+            <a:ext cx="203200" cy="6858000"/>
           </a:xfrm>
           <a:prstGeom prst="rect">
             <a:avLst/>
@@ -3614,7 +3614,7 @@
           <a:lstStyle/>
           <a:p>
             <a:pPr algn="ctr"/>
-            <a:endParaRPr lang="en-US"/>
+            <a:endParaRPr lang="en-US" sz="3200"/>
           </a:p>
         </p:txBody>
       </p:sp>
@@ -3660,15 +3660,15 @@
         </p:nvSpPr>
         <p:spPr>
           <a:xfrm>
-            <a:off x="1792288" y="3600450"/>
-            <a:ext cx="5486400" cy="425054"/>
+            <a:off x="2389717" y="4800600"/>
+            <a:ext cx="7315200" cy="566739"/>
           </a:xfrm>
         </p:spPr>
         <p:txBody>
           <a:bodyPr anchor="b"/>
           <a:lstStyle>
             <a:lvl1pPr algn="l">
-              <a:defRPr sz="1500" b="1"/>
+              <a:defRPr sz="2000" b="1"/>
             </a:lvl1pPr>
           </a:lstStyle>
           <a:p>
@@ -3691,8 +3691,8 @@
         </p:nvSpPr>
         <p:spPr>
           <a:xfrm>
-            <a:off x="1792288" y="459581"/>
-            <a:ext cx="5486400" cy="3086100"/>
+            <a:off x="2389717" y="612775"/>
+            <a:ext cx="7315200" cy="4114800"/>
           </a:xfrm>
         </p:spPr>
         <p:txBody>
@@ -3700,39 +3700,39 @@
           <a:lstStyle>
             <a:lvl1pPr marL="0" indent="0">
               <a:buNone/>
+              <a:defRPr sz="3200"/>
+            </a:lvl1pPr>
+            <a:lvl2pPr marL="457189" indent="0">
+              <a:buNone/>
+              <a:defRPr sz="2800"/>
+            </a:lvl2pPr>
+            <a:lvl3pPr marL="914377" indent="0">
+              <a:buNone/>
               <a:defRPr sz="2400"/>
-            </a:lvl1pPr>
-            <a:lvl2pPr marL="342900" indent="0">
-              <a:buNone/>
-              <a:defRPr sz="2100"/>
-            </a:lvl2pPr>
-            <a:lvl3pPr marL="685800" indent="0">
-              <a:buNone/>
-              <a:defRPr sz="1800"/>
             </a:lvl3pPr>
-            <a:lvl4pPr marL="1028700" indent="0">
-              <a:buNone/>
-              <a:defRPr sz="1500"/>
+            <a:lvl4pPr marL="1371566" indent="0">
+              <a:buNone/>
+              <a:defRPr sz="2000"/>
             </a:lvl4pPr>
-            <a:lvl5pPr marL="1371600" indent="0">
-              <a:buNone/>
-              <a:defRPr sz="1500"/>
+            <a:lvl5pPr marL="1828754" indent="0">
+              <a:buNone/>
+              <a:defRPr sz="2000"/>
             </a:lvl5pPr>
-            <a:lvl6pPr marL="1714500" indent="0">
-              <a:buNone/>
-              <a:defRPr sz="1500"/>
+            <a:lvl6pPr marL="2285943" indent="0">
+              <a:buNone/>
+              <a:defRPr sz="2000"/>
             </a:lvl6pPr>
-            <a:lvl7pPr marL="2057400" indent="0">
-              <a:buNone/>
-              <a:defRPr sz="1500"/>
+            <a:lvl7pPr marL="2743131" indent="0">
+              <a:buNone/>
+              <a:defRPr sz="2000"/>
             </a:lvl7pPr>
-            <a:lvl8pPr marL="2400300" indent="0">
-              <a:buNone/>
-              <a:defRPr sz="1500"/>
+            <a:lvl8pPr marL="3200320" indent="0">
+              <a:buNone/>
+              <a:defRPr sz="2000"/>
             </a:lvl8pPr>
-            <a:lvl9pPr marL="2743200" indent="0">
-              <a:buNone/>
-              <a:defRPr sz="1500"/>
+            <a:lvl9pPr marL="3657509" indent="0">
+              <a:buNone/>
+              <a:defRPr sz="2000"/>
             </a:lvl9pPr>
           </a:lstStyle>
           <a:p>
@@ -3752,8 +3752,8 @@
         </p:nvSpPr>
         <p:spPr>
           <a:xfrm>
-            <a:off x="1792288" y="4025503"/>
-            <a:ext cx="5486400" cy="603647"/>
+            <a:off x="2389717" y="5367338"/>
+            <a:ext cx="7315200" cy="804863"/>
           </a:xfrm>
         </p:spPr>
         <p:txBody>
@@ -3761,39 +3761,39 @@
           <a:lstStyle>
             <a:lvl1pPr marL="0" indent="0">
               <a:buNone/>
-              <a:defRPr sz="1050"/>
+              <a:defRPr sz="1400"/>
             </a:lvl1pPr>
-            <a:lvl2pPr marL="342900" indent="0">
+            <a:lvl2pPr marL="457189" indent="0">
+              <a:buNone/>
+              <a:defRPr sz="1200"/>
+            </a:lvl2pPr>
+            <a:lvl3pPr marL="914377" indent="0">
+              <a:buNone/>
+              <a:defRPr sz="1000"/>
+            </a:lvl3pPr>
+            <a:lvl4pPr marL="1371566" indent="0">
               <a:buNone/>
               <a:defRPr sz="900"/>
-            </a:lvl2pPr>
-            <a:lvl3pPr marL="685800" indent="0">
-              <a:buNone/>
-              <a:defRPr sz="750"/>
-            </a:lvl3pPr>
-            <a:lvl4pPr marL="1028700" indent="0">
-              <a:buNone/>
-              <a:defRPr sz="675"/>
             </a:lvl4pPr>
-            <a:lvl5pPr marL="1371600" indent="0">
-              <a:buNone/>
-              <a:defRPr sz="675"/>
+            <a:lvl5pPr marL="1828754" indent="0">
+              <a:buNone/>
+              <a:defRPr sz="900"/>
             </a:lvl5pPr>
-            <a:lvl6pPr marL="1714500" indent="0">
-              <a:buNone/>
-              <a:defRPr sz="675"/>
+            <a:lvl6pPr marL="2285943" indent="0">
+              <a:buNone/>
+              <a:defRPr sz="900"/>
             </a:lvl6pPr>
-            <a:lvl7pPr marL="2057400" indent="0">
-              <a:buNone/>
-              <a:defRPr sz="675"/>
+            <a:lvl7pPr marL="2743131" indent="0">
+              <a:buNone/>
+              <a:defRPr sz="900"/>
             </a:lvl7pPr>
-            <a:lvl8pPr marL="2400300" indent="0">
-              <a:buNone/>
-              <a:defRPr sz="675"/>
+            <a:lvl8pPr marL="3200320" indent="0">
+              <a:buNone/>
+              <a:defRPr sz="900"/>
             </a:lvl8pPr>
-            <a:lvl9pPr marL="2743200" indent="0">
-              <a:buNone/>
-              <a:defRPr sz="675"/>
+            <a:lvl9pPr marL="3657509" indent="0">
+              <a:buNone/>
+              <a:defRPr sz="900"/>
             </a:lvl9pPr>
           </a:lstStyle>
           <a:p>
@@ -3913,8 +3913,8 @@
         </p:nvSpPr>
         <p:spPr>
           <a:xfrm>
-            <a:off x="8991600" y="0"/>
-            <a:ext cx="152400" cy="5143500"/>
+            <a:off x="11988800" y="0"/>
+            <a:ext cx="203200" cy="6858000"/>
           </a:xfrm>
           <a:prstGeom prst="rect">
             <a:avLst/>
@@ -3945,7 +3945,7 @@
           <a:lstStyle/>
           <a:p>
             <a:pPr algn="ctr"/>
-            <a:endParaRPr lang="en-US"/>
+            <a:endParaRPr lang="en-US" sz="3200"/>
           </a:p>
         </p:txBody>
       </p:sp>
@@ -3996,8 +3996,8 @@
         </p:nvSpPr>
         <p:spPr>
           <a:xfrm>
-            <a:off x="457200" y="138111"/>
-            <a:ext cx="8229600" cy="857250"/>
+            <a:off x="609600" y="184148"/>
+            <a:ext cx="10972800" cy="1143000"/>
           </a:xfrm>
           <a:prstGeom prst="rect">
             <a:avLst/>
@@ -4028,8 +4028,8 @@
         </p:nvSpPr>
         <p:spPr>
           <a:xfrm>
-            <a:off x="457200" y="1200151"/>
-            <a:ext cx="8229600" cy="3394472"/>
+            <a:off x="609600" y="1600201"/>
+            <a:ext cx="10972800" cy="4525963"/>
           </a:xfrm>
           <a:prstGeom prst="rect">
             <a:avLst/>
@@ -4089,8 +4089,8 @@
         </p:nvSpPr>
         <p:spPr>
           <a:xfrm>
-            <a:off x="1995729" y="4774118"/>
-            <a:ext cx="1363851" cy="223839"/>
+            <a:off x="2660973" y="6365491"/>
+            <a:ext cx="1818468" cy="298452"/>
           </a:xfrm>
           <a:prstGeom prst="rect">
             <a:avLst/>
@@ -4100,7 +4100,7 @@
           <a:bodyPr vert="horz" lIns="91440" tIns="45720" rIns="91440" bIns="45720" rtlCol="0" anchor="ctr"/>
           <a:lstStyle>
             <a:lvl1pPr algn="l">
-              <a:defRPr sz="900">
+              <a:defRPr sz="1200">
                 <a:solidFill>
                   <a:schemeClr val="tx1">
                     <a:tint val="75000"/>
@@ -4131,8 +4131,8 @@
         </p:nvSpPr>
         <p:spPr>
           <a:xfrm>
-            <a:off x="3542008" y="4774116"/>
-            <a:ext cx="2059983" cy="223839"/>
+            <a:off x="4722678" y="6365489"/>
+            <a:ext cx="2746644" cy="298452"/>
           </a:xfrm>
           <a:prstGeom prst="rect">
             <a:avLst/>
@@ -4142,7 +4142,7 @@
           <a:bodyPr vert="horz" lIns="91440" tIns="45720" rIns="91440" bIns="45720" rtlCol="0" anchor="ctr"/>
           <a:lstStyle>
             <a:lvl1pPr algn="ctr">
-              <a:defRPr sz="900">
+              <a:defRPr sz="1200">
                 <a:solidFill>
                   <a:schemeClr val="tx1">
                     <a:tint val="75000"/>
@@ -4171,8 +4171,8 @@
         </p:nvSpPr>
         <p:spPr>
           <a:xfrm>
-            <a:off x="5784419" y="4774116"/>
-            <a:ext cx="1363851" cy="223840"/>
+            <a:off x="7712559" y="6365488"/>
+            <a:ext cx="1818468" cy="298453"/>
           </a:xfrm>
           <a:prstGeom prst="rect">
             <a:avLst/>
@@ -4182,7 +4182,7 @@
           <a:bodyPr vert="horz" lIns="91440" tIns="45720" rIns="91440" bIns="45720" rtlCol="0" anchor="ctr"/>
           <a:lstStyle>
             <a:lvl1pPr algn="r">
-              <a:defRPr sz="900">
+              <a:defRPr sz="1200">
                 <a:solidFill>
                   <a:schemeClr val="tx1">
                     <a:tint val="75000"/>
@@ -4234,8 +4234,8 @@
         </p:blipFill>
         <p:spPr>
           <a:xfrm>
-            <a:off x="8134028" y="4725240"/>
-            <a:ext cx="857572" cy="321589"/>
+            <a:off x="10845371" y="6300321"/>
+            <a:ext cx="1143429" cy="428785"/>
           </a:xfrm>
           <a:prstGeom prst="rect">
             <a:avLst/>
@@ -4266,12 +4266,12 @@
   <p:hf hdr="0"/>
   <p:txStyles>
     <p:titleStyle>
-      <a:lvl1pPr algn="ctr" defTabSz="342900" rtl="0" eaLnBrk="1" latinLnBrk="0" hangingPunct="1">
+      <a:lvl1pPr algn="ctr" defTabSz="457189" rtl="0" eaLnBrk="1" latinLnBrk="0" hangingPunct="1">
         <a:spcBef>
           <a:spcPct val="0"/>
         </a:spcBef>
         <a:buNone/>
-        <a:defRPr sz="2800" b="1" i="0" kern="1200">
+        <a:defRPr sz="3733" b="1" i="0" kern="1200">
           <a:solidFill>
             <a:schemeClr val="tx1"/>
           </a:solidFill>
@@ -4282,12 +4282,44 @@
       </a:lvl1pPr>
     </p:titleStyle>
     <p:bodyStyle>
-      <a:lvl1pPr marL="342900" indent="-342900" algn="l" defTabSz="342900" rtl="0" eaLnBrk="1" latinLnBrk="0" hangingPunct="1">
+      <a:lvl1pPr marL="457189" indent="-457189" algn="l" defTabSz="457189" rtl="0" eaLnBrk="1" latinLnBrk="0" hangingPunct="1">
         <a:spcBef>
           <a:spcPct val="20000"/>
         </a:spcBef>
         <a:buFont typeface="Arial" panose="020B0604020202020204" pitchFamily="34" charset="0"/>
         <a:buChar char="•"/>
+        <a:defRPr sz="2200" b="0" i="0" kern="1200">
+          <a:solidFill>
+            <a:schemeClr val="tx1"/>
+          </a:solidFill>
+          <a:latin typeface="Aptos" panose="020B0004020202020204" pitchFamily="34" charset="0"/>
+          <a:ea typeface="Verdana" panose="020B0604030504040204" pitchFamily="34" charset="0"/>
+          <a:cs typeface="Verdana" panose="020B0604030504040204" pitchFamily="34" charset="0"/>
+        </a:defRPr>
+      </a:lvl1pPr>
+      <a:lvl2pPr marL="768331" indent="-461422" algn="l" defTabSz="457189" rtl="0" eaLnBrk="1" latinLnBrk="0" hangingPunct="1">
+        <a:spcBef>
+          <a:spcPct val="20000"/>
+        </a:spcBef>
+        <a:buFont typeface="Wingdings" pitchFamily="2" charset="2"/>
+        <a:buChar char="§"/>
+        <a:tabLst/>
+        <a:defRPr sz="2000" b="0" i="0" kern="1200">
+          <a:solidFill>
+            <a:schemeClr val="tx1"/>
+          </a:solidFill>
+          <a:latin typeface="Aptos" panose="020B0004020202020204" pitchFamily="34" charset="0"/>
+          <a:ea typeface="Verdana" panose="020B0604030504040204" pitchFamily="34" charset="0"/>
+          <a:cs typeface="Verdana" panose="020B0604030504040204" pitchFamily="34" charset="0"/>
+        </a:defRPr>
+      </a:lvl2pPr>
+      <a:lvl3pPr marL="1149322" indent="-452955" algn="l" defTabSz="457189" rtl="0" eaLnBrk="1" latinLnBrk="0" hangingPunct="1">
+        <a:spcBef>
+          <a:spcPct val="20000"/>
+        </a:spcBef>
+        <a:buFont typeface="Courier New" panose="02070309020205020404" pitchFamily="49" charset="0"/>
+        <a:buChar char="o"/>
+        <a:tabLst/>
         <a:defRPr sz="1800" b="0" i="0" kern="1200">
           <a:solidFill>
             <a:schemeClr val="tx1"/>
@@ -4296,13 +4328,13 @@
           <a:ea typeface="Verdana" panose="020B0604030504040204" pitchFamily="34" charset="0"/>
           <a:cs typeface="Verdana" panose="020B0604030504040204" pitchFamily="34" charset="0"/>
         </a:defRPr>
-      </a:lvl1pPr>
-      <a:lvl2pPr marL="576263" indent="-346075" algn="l" defTabSz="342900" rtl="0" eaLnBrk="1" latinLnBrk="0" hangingPunct="1">
+      </a:lvl3pPr>
+      <a:lvl4pPr marL="1600160" indent="-461422" algn="l" defTabSz="457189" rtl="0" eaLnBrk="1" latinLnBrk="0" hangingPunct="1">
         <a:spcBef>
           <a:spcPct val="20000"/>
         </a:spcBef>
-        <a:buFont typeface="Wingdings" pitchFamily="2" charset="2"/>
-        <a:buChar char="§"/>
+        <a:buFont typeface="Arial"/>
+        <a:buChar char="–"/>
         <a:tabLst/>
         <a:defRPr sz="1600" b="0" i="0" kern="1200">
           <a:solidFill>
@@ -4312,47 +4344,15 @@
           <a:ea typeface="Verdana" panose="020B0604030504040204" pitchFamily="34" charset="0"/>
           <a:cs typeface="Verdana" panose="020B0604030504040204" pitchFamily="34" charset="0"/>
         </a:defRPr>
-      </a:lvl2pPr>
-      <a:lvl3pPr marL="862013" indent="-339725" algn="l" defTabSz="342900" rtl="0" eaLnBrk="1" latinLnBrk="0" hangingPunct="1">
-        <a:spcBef>
-          <a:spcPct val="20000"/>
-        </a:spcBef>
-        <a:buFont typeface="Courier New" panose="02070309020205020404" pitchFamily="49" charset="0"/>
-        <a:buChar char="o"/>
-        <a:tabLst/>
-        <a:defRPr sz="1400" b="0" i="0" kern="1200">
-          <a:solidFill>
-            <a:schemeClr val="tx1"/>
-          </a:solidFill>
-          <a:latin typeface="Aptos" panose="020B0004020202020204" pitchFamily="34" charset="0"/>
-          <a:ea typeface="Verdana" panose="020B0604030504040204" pitchFamily="34" charset="0"/>
-          <a:cs typeface="Verdana" panose="020B0604030504040204" pitchFamily="34" charset="0"/>
-        </a:defRPr>
-      </a:lvl3pPr>
-      <a:lvl4pPr marL="1200150" indent="-346075" algn="l" defTabSz="342900" rtl="0" eaLnBrk="1" latinLnBrk="0" hangingPunct="1">
-        <a:spcBef>
-          <a:spcPct val="20000"/>
-        </a:spcBef>
-        <a:buFont typeface="Arial"/>
-        <a:buChar char="–"/>
-        <a:tabLst/>
-        <a:defRPr sz="1200" b="0" i="0" kern="1200">
-          <a:solidFill>
-            <a:schemeClr val="tx1"/>
-          </a:solidFill>
-          <a:latin typeface="Aptos" panose="020B0004020202020204" pitchFamily="34" charset="0"/>
-          <a:ea typeface="Verdana" panose="020B0604030504040204" pitchFamily="34" charset="0"/>
-          <a:cs typeface="Verdana" panose="020B0604030504040204" pitchFamily="34" charset="0"/>
-        </a:defRPr>
       </a:lvl4pPr>
-      <a:lvl5pPr marL="1492250" indent="-338138" algn="l" defTabSz="342900" rtl="0" eaLnBrk="1" latinLnBrk="0" hangingPunct="1">
+      <a:lvl5pPr marL="1989617" indent="-450839" algn="l" defTabSz="457189" rtl="0" eaLnBrk="1" latinLnBrk="0" hangingPunct="1">
         <a:spcBef>
           <a:spcPct val="20000"/>
         </a:spcBef>
         <a:buFont typeface="Arial"/>
         <a:buChar char="»"/>
         <a:tabLst/>
-        <a:defRPr sz="1200" b="0" i="0" kern="1200">
+        <a:defRPr sz="1600" b="0" i="0" kern="1200">
           <a:solidFill>
             <a:schemeClr val="tx1">
               <a:lumMod val="65000"/>
@@ -4364,13 +4364,13 @@
           <a:cs typeface="Verdana" panose="020B0604030504040204" pitchFamily="34" charset="0"/>
         </a:defRPr>
       </a:lvl5pPr>
-      <a:lvl6pPr marL="2057400" indent="-342900" algn="l" defTabSz="342900" rtl="0" eaLnBrk="1" latinLnBrk="0" hangingPunct="1">
+      <a:lvl6pPr marL="2743131" indent="-457189" algn="l" defTabSz="457189" rtl="0" eaLnBrk="1" latinLnBrk="0" hangingPunct="1">
         <a:spcBef>
           <a:spcPct val="20000"/>
         </a:spcBef>
         <a:buFont typeface="Arial"/>
         <a:buChar char="•"/>
-        <a:defRPr sz="1500" kern="1200">
+        <a:defRPr sz="2000" kern="1200">
           <a:solidFill>
             <a:schemeClr val="tx1"/>
           </a:solidFill>
@@ -4379,13 +4379,13 @@
           <a:cs typeface="+mn-cs"/>
         </a:defRPr>
       </a:lvl6pPr>
-      <a:lvl7pPr marL="2400300" indent="-342900" algn="l" defTabSz="342900" rtl="0" eaLnBrk="1" latinLnBrk="0" hangingPunct="1">
+      <a:lvl7pPr marL="3200320" indent="-457189" algn="l" defTabSz="457189" rtl="0" eaLnBrk="1" latinLnBrk="0" hangingPunct="1">
         <a:spcBef>
           <a:spcPct val="20000"/>
         </a:spcBef>
         <a:buFont typeface="Arial"/>
         <a:buChar char="•"/>
-        <a:defRPr sz="1500" kern="1200">
+        <a:defRPr sz="2000" kern="1200">
           <a:solidFill>
             <a:schemeClr val="tx1"/>
           </a:solidFill>
@@ -4394,13 +4394,13 @@
           <a:cs typeface="+mn-cs"/>
         </a:defRPr>
       </a:lvl7pPr>
-      <a:lvl8pPr marL="2743200" indent="-342900" algn="l" defTabSz="342900" rtl="0" eaLnBrk="1" latinLnBrk="0" hangingPunct="1">
+      <a:lvl8pPr marL="3657509" indent="-457189" algn="l" defTabSz="457189" rtl="0" eaLnBrk="1" latinLnBrk="0" hangingPunct="1">
         <a:spcBef>
           <a:spcPct val="20000"/>
         </a:spcBef>
         <a:buFont typeface="Arial"/>
         <a:buChar char="•"/>
-        <a:defRPr sz="1500" kern="1200">
+        <a:defRPr sz="2000" kern="1200">
           <a:solidFill>
             <a:schemeClr val="tx1"/>
           </a:solidFill>
@@ -4409,13 +4409,13 @@
           <a:cs typeface="+mn-cs"/>
         </a:defRPr>
       </a:lvl8pPr>
-      <a:lvl9pPr marL="3086100" indent="-342900" algn="l" defTabSz="342900" rtl="0" eaLnBrk="1" latinLnBrk="0" hangingPunct="1">
+      <a:lvl9pPr marL="4114697" indent="-457189" algn="l" defTabSz="457189" rtl="0" eaLnBrk="1" latinLnBrk="0" hangingPunct="1">
         <a:spcBef>
           <a:spcPct val="20000"/>
         </a:spcBef>
         <a:buFont typeface="Arial"/>
         <a:buChar char="•"/>
-        <a:defRPr sz="1500" kern="1200">
+        <a:defRPr sz="2000" kern="1200">
           <a:solidFill>
             <a:schemeClr val="tx1"/>
           </a:solidFill>
@@ -4429,8 +4429,8 @@
       <a:defPPr>
         <a:defRPr lang="en-US"/>
       </a:defPPr>
-      <a:lvl1pPr marL="0" algn="l" defTabSz="342900" rtl="0" eaLnBrk="1" latinLnBrk="0" hangingPunct="1">
-        <a:defRPr sz="1350" kern="1200">
+      <a:lvl1pPr marL="0" algn="l" defTabSz="457189" rtl="0" eaLnBrk="1" latinLnBrk="0" hangingPunct="1">
+        <a:defRPr sz="1800" kern="1200">
           <a:solidFill>
             <a:schemeClr val="tx1"/>
           </a:solidFill>
@@ -4439,8 +4439,8 @@
           <a:cs typeface="+mn-cs"/>
         </a:defRPr>
       </a:lvl1pPr>
-      <a:lvl2pPr marL="342900" algn="l" defTabSz="342900" rtl="0" eaLnBrk="1" latinLnBrk="0" hangingPunct="1">
-        <a:defRPr sz="1350" kern="1200">
+      <a:lvl2pPr marL="457189" algn="l" defTabSz="457189" rtl="0" eaLnBrk="1" latinLnBrk="0" hangingPunct="1">
+        <a:defRPr sz="1800" kern="1200">
           <a:solidFill>
             <a:schemeClr val="tx1"/>
           </a:solidFill>
@@ -4449,8 +4449,8 @@
           <a:cs typeface="+mn-cs"/>
         </a:defRPr>
       </a:lvl2pPr>
-      <a:lvl3pPr marL="685800" algn="l" defTabSz="342900" rtl="0" eaLnBrk="1" latinLnBrk="0" hangingPunct="1">
-        <a:defRPr sz="1350" kern="1200">
+      <a:lvl3pPr marL="914377" algn="l" defTabSz="457189" rtl="0" eaLnBrk="1" latinLnBrk="0" hangingPunct="1">
+        <a:defRPr sz="1800" kern="1200">
           <a:solidFill>
             <a:schemeClr val="tx1"/>
           </a:solidFill>
@@ -4459,8 +4459,8 @@
           <a:cs typeface="+mn-cs"/>
         </a:defRPr>
       </a:lvl3pPr>
-      <a:lvl4pPr marL="1028700" algn="l" defTabSz="342900" rtl="0" eaLnBrk="1" latinLnBrk="0" hangingPunct="1">
-        <a:defRPr sz="1350" kern="1200">
+      <a:lvl4pPr marL="1371566" algn="l" defTabSz="457189" rtl="0" eaLnBrk="1" latinLnBrk="0" hangingPunct="1">
+        <a:defRPr sz="1800" kern="1200">
           <a:solidFill>
             <a:schemeClr val="tx1"/>
           </a:solidFill>
@@ -4469,8 +4469,8 @@
           <a:cs typeface="+mn-cs"/>
         </a:defRPr>
       </a:lvl4pPr>
-      <a:lvl5pPr marL="1371600" algn="l" defTabSz="342900" rtl="0" eaLnBrk="1" latinLnBrk="0" hangingPunct="1">
-        <a:defRPr sz="1350" kern="1200">
+      <a:lvl5pPr marL="1828754" algn="l" defTabSz="457189" rtl="0" eaLnBrk="1" latinLnBrk="0" hangingPunct="1">
+        <a:defRPr sz="1800" kern="1200">
           <a:solidFill>
             <a:schemeClr val="tx1"/>
           </a:solidFill>
@@ -4479,8 +4479,8 @@
           <a:cs typeface="+mn-cs"/>
         </a:defRPr>
       </a:lvl5pPr>
-      <a:lvl6pPr marL="1714500" algn="l" defTabSz="342900" rtl="0" eaLnBrk="1" latinLnBrk="0" hangingPunct="1">
-        <a:defRPr sz="1350" kern="1200">
+      <a:lvl6pPr marL="2285943" algn="l" defTabSz="457189" rtl="0" eaLnBrk="1" latinLnBrk="0" hangingPunct="1">
+        <a:defRPr sz="1800" kern="1200">
           <a:solidFill>
             <a:schemeClr val="tx1"/>
           </a:solidFill>
@@ -4489,8 +4489,8 @@
           <a:cs typeface="+mn-cs"/>
         </a:defRPr>
       </a:lvl6pPr>
-      <a:lvl7pPr marL="2057400" algn="l" defTabSz="342900" rtl="0" eaLnBrk="1" latinLnBrk="0" hangingPunct="1">
-        <a:defRPr sz="1350" kern="1200">
+      <a:lvl7pPr marL="2743131" algn="l" defTabSz="457189" rtl="0" eaLnBrk="1" latinLnBrk="0" hangingPunct="1">
+        <a:defRPr sz="1800" kern="1200">
           <a:solidFill>
             <a:schemeClr val="tx1"/>
           </a:solidFill>
@@ -4499,8 +4499,8 @@
           <a:cs typeface="+mn-cs"/>
         </a:defRPr>
       </a:lvl7pPr>
-      <a:lvl8pPr marL="2400300" algn="l" defTabSz="342900" rtl="0" eaLnBrk="1" latinLnBrk="0" hangingPunct="1">
-        <a:defRPr sz="1350" kern="1200">
+      <a:lvl8pPr marL="3200320" algn="l" defTabSz="457189" rtl="0" eaLnBrk="1" latinLnBrk="0" hangingPunct="1">
+        <a:defRPr sz="1800" kern="1200">
           <a:solidFill>
             <a:schemeClr val="tx1"/>
           </a:solidFill>
@@ -4509,8 +4509,8 @@
           <a:cs typeface="+mn-cs"/>
         </a:defRPr>
       </a:lvl8pPr>
-      <a:lvl9pPr marL="2743200" algn="l" defTabSz="342900" rtl="0" eaLnBrk="1" latinLnBrk="0" hangingPunct="1">
-        <a:defRPr sz="1350" kern="1200">
+      <a:lvl9pPr marL="3657509" algn="l" defTabSz="457189" rtl="0" eaLnBrk="1" latinLnBrk="0" hangingPunct="1">
+        <a:defRPr sz="1800" kern="1200">
           <a:solidFill>
             <a:schemeClr val="tx1"/>
           </a:solidFill>
@@ -4524,27 +4524,27 @@
   <p:extLst>
     <p:ext uri="{27BBF7A9-308A-43DC-89C8-2F10F3537804}">
       <p15:sldGuideLst xmlns:p15="http://schemas.microsoft.com/office/powerpoint/2012/main">
-        <p15:guide id="1" orient="horz" pos="84" userDrawn="1">
+        <p15:guide id="1" orient="horz" pos="112" userDrawn="1">
           <p15:clr>
             <a:srgbClr val="F26B43"/>
           </p15:clr>
         </p15:guide>
-        <p15:guide id="2" pos="96" userDrawn="1">
+        <p15:guide id="2" pos="128" userDrawn="1">
           <p15:clr>
             <a:srgbClr val="F26B43"/>
           </p15:clr>
         </p15:guide>
-        <p15:guide id="3" orient="horz" pos="3156" userDrawn="1">
+        <p15:guide id="3" orient="horz" pos="4208" userDrawn="1">
           <p15:clr>
             <a:srgbClr val="F26B43"/>
           </p15:clr>
         </p15:guide>
-        <p15:guide id="4" pos="5664" userDrawn="1">
+        <p15:guide id="4" pos="7552" userDrawn="1">
           <p15:clr>
             <a:srgbClr val="F26B43"/>
           </p15:clr>
         </p15:guide>
-        <p15:guide id="5" pos="2880" userDrawn="1">
+        <p15:guide id="5" pos="3840" userDrawn="1">
           <p15:clr>
             <a:srgbClr val="F26B43"/>
           </p15:clr>
@@ -4715,8 +4715,8 @@
         </p:nvSpPr>
         <p:spPr>
           <a:xfrm>
-            <a:off x="1995729" y="4774118"/>
-            <a:ext cx="1363851" cy="223839"/>
+            <a:off x="2660973" y="6365491"/>
+            <a:ext cx="1818468" cy="298452"/>
           </a:xfrm>
         </p:spPr>
         <p:txBody>
@@ -4748,8 +4748,8 @@
         </p:nvSpPr>
         <p:spPr>
           <a:xfrm>
-            <a:off x="3542008" y="4774116"/>
-            <a:ext cx="2059983" cy="223839"/>
+            <a:off x="4722678" y="6365489"/>
+            <a:ext cx="2746644" cy="298452"/>
           </a:xfrm>
         </p:spPr>
         <p:txBody>
@@ -4781,8 +4781,8 @@
         </p:nvSpPr>
         <p:spPr>
           <a:xfrm>
-            <a:off x="5784419" y="4774116"/>
-            <a:ext cx="1363851" cy="223840"/>
+            <a:off x="7712559" y="6365488"/>
+            <a:ext cx="1818468" cy="298453"/>
           </a:xfrm>
         </p:spPr>
         <p:txBody>
@@ -4886,8 +4886,8 @@
         </p:nvSpPr>
         <p:spPr>
           <a:xfrm>
-            <a:off x="1995729" y="4774118"/>
-            <a:ext cx="1363851" cy="223839"/>
+            <a:off x="2660973" y="6365491"/>
+            <a:ext cx="1818468" cy="298452"/>
           </a:xfrm>
         </p:spPr>
         <p:txBody>
@@ -4919,8 +4919,8 @@
         </p:nvSpPr>
         <p:spPr>
           <a:xfrm>
-            <a:off x="3542008" y="4774116"/>
-            <a:ext cx="2059983" cy="223839"/>
+            <a:off x="4722678" y="6365489"/>
+            <a:ext cx="2746644" cy="298452"/>
           </a:xfrm>
         </p:spPr>
         <p:txBody>
@@ -4952,8 +4952,8 @@
         </p:nvSpPr>
         <p:spPr>
           <a:xfrm>
-            <a:off x="5784419" y="4774116"/>
-            <a:ext cx="1363851" cy="223840"/>
+            <a:off x="7712559" y="6365488"/>
+            <a:ext cx="1818468" cy="298453"/>
           </a:xfrm>
         </p:spPr>
         <p:txBody>
@@ -5093,8 +5093,8 @@
         </p:nvSpPr>
         <p:spPr>
           <a:xfrm>
-            <a:off x="1995729" y="4774118"/>
-            <a:ext cx="1363851" cy="223839"/>
+            <a:off x="2660973" y="6365491"/>
+            <a:ext cx="1818468" cy="298452"/>
           </a:xfrm>
         </p:spPr>
         <p:txBody>
@@ -5126,8 +5126,8 @@
         </p:nvSpPr>
         <p:spPr>
           <a:xfrm>
-            <a:off x="3542008" y="4774116"/>
-            <a:ext cx="2059983" cy="223839"/>
+            <a:off x="4722678" y="6365489"/>
+            <a:ext cx="2746644" cy="298452"/>
           </a:xfrm>
         </p:spPr>
         <p:txBody>
@@ -5159,8 +5159,8 @@
         </p:nvSpPr>
         <p:spPr>
           <a:xfrm>
-            <a:off x="5784419" y="4774116"/>
-            <a:ext cx="1363851" cy="223840"/>
+            <a:off x="7712559" y="6365488"/>
+            <a:ext cx="1818468" cy="298453"/>
           </a:xfrm>
         </p:spPr>
         <p:txBody>

</xml_diff>

<commit_message>
Adjust title font size
Center the 2nd column content for no-title slides
</commit_message>
<xml_diff>
--- a/working-template.pptx
+++ b/working-template.pptx
@@ -2940,7 +2940,7 @@
           <a:lstStyle/>
           <a:p>
             <a:r>
-              <a:rPr lang="en-US"/>
+              <a:rPr lang="en-US" dirty="0"/>
               <a:t>Click to edit Master title style</a:t>
             </a:r>
           </a:p>
@@ -3342,7 +3342,7 @@
           </a:xfrm>
         </p:spPr>
         <p:txBody>
-          <a:bodyPr/>
+          <a:bodyPr anchor="ctr"/>
           <a:lstStyle>
             <a:lvl1pPr>
               <a:defRPr sz="3200"/>
@@ -3375,35 +3375,35 @@
           <a:p>
             <a:pPr lvl="0"/>
             <a:r>
-              <a:rPr lang="en-US"/>
+              <a:rPr lang="en-US" dirty="0"/>
               <a:t>Click to edit Master text styles</a:t>
             </a:r>
           </a:p>
           <a:p>
             <a:pPr lvl="1"/>
             <a:r>
-              <a:rPr lang="en-US"/>
+              <a:rPr lang="en-US" dirty="0"/>
               <a:t>Second level</a:t>
             </a:r>
           </a:p>
           <a:p>
             <a:pPr lvl="2"/>
             <a:r>
-              <a:rPr lang="en-US"/>
+              <a:rPr lang="en-US" dirty="0"/>
               <a:t>Third level</a:t>
             </a:r>
           </a:p>
           <a:p>
             <a:pPr lvl="3"/>
             <a:r>
-              <a:rPr lang="en-US"/>
+              <a:rPr lang="en-US" dirty="0"/>
               <a:t>Fourth level</a:t>
             </a:r>
           </a:p>
           <a:p>
             <a:pPr lvl="4"/>
             <a:r>
-              <a:rPr lang="en-US"/>
+              <a:rPr lang="en-US" dirty="0"/>
               <a:t>Fifth level</a:t>
             </a:r>
           </a:p>
@@ -4271,7 +4271,7 @@
           <a:spcPct val="0"/>
         </a:spcBef>
         <a:buNone/>
-        <a:defRPr sz="3733" b="1" i="0" kern="1200">
+        <a:defRPr sz="3200" b="1" i="0" kern="1200">
           <a:solidFill>
             <a:schemeClr val="tx1"/>
           </a:solidFill>

</xml_diff>